<commit_message>
style: apply warm-white projector theme + translate all slides to English
- Switch all 10 parts to setTheme("light") (warm cream background)
- Translate all Chinese text to English across 110 slides
- Remove page numbers from all part labels
- Translate helpers.js Chinese labels (complexity, pros/cons headers)
- Fix remaining Chinese in part9 code card strings
- Add skills.md documenting all design conventions

Co-authored-by: Copilot <223556219+Copilot@users.noreply.github.com>
</commit_message>
<xml_diff>
--- a/output/part5.pptx
+++ b/output/part5.pptx
@@ -1480,7 +1480,7 @@
     <p:bg>
       <p:bgPr>
         <a:solidFill>
-          <a:srgbClr val="0D1117"/>
+          <a:srgbClr val="FFFDF8"/>
         </a:solidFill>
       </p:bgPr>
     </p:bg>
@@ -1513,11 +1513,11 @@
             <a:avLst/>
           </a:prstGeom>
           <a:solidFill>
-            <a:srgbClr val="161B22"/>
+            <a:srgbClr val="F5F1EB"/>
           </a:solidFill>
           <a:ln w="6350">
             <a:solidFill>
-              <a:srgbClr val="30363D"/>
+              <a:srgbClr val="D6CCBF"/>
             </a:solidFill>
             <a:prstDash val="solid"/>
           </a:ln>
@@ -1538,11 +1538,11 @@
             <a:avLst/>
           </a:prstGeom>
           <a:solidFill>
-            <a:srgbClr val="58A6FF"/>
+            <a:srgbClr val="4A7FB5"/>
           </a:solidFill>
           <a:ln w="12700">
             <a:solidFill>
-              <a:srgbClr val="58A6FF"/>
+              <a:srgbClr val="4A7FB5"/>
             </a:solidFill>
             <a:prstDash val="solid"/>
           </a:ln>
@@ -1575,13 +1575,13 @@
             <a:r>
               <a:rPr lang="en-US" sz="1600" b="1" dirty="0">
                 <a:solidFill>
-                  <a:srgbClr val="E6EDF3"/>
-                </a:solidFill>
-                <a:latin typeface="Calibri" pitchFamily="34" charset="0"/>
-                <a:ea typeface="Calibri" pitchFamily="34" charset="-122"/>
-                <a:cs typeface="Calibri" pitchFamily="34" charset="-120"/>
-              </a:rPr>
-              <a:t>DevOps：打破開發與維運的高牆</a:t>
+                  <a:srgbClr val="2D2926"/>
+                </a:solidFill>
+                <a:latin typeface="Calibri" pitchFamily="34" charset="0"/>
+                <a:ea typeface="Calibri" pitchFamily="34" charset="-122"/>
+                <a:cs typeface="Calibri" pitchFamily="34" charset="-120"/>
+              </a:rPr>
+              <a:t>DevOps: Breaking Down the Wall Between Dev and Ops</a:t>
             </a:r>
             <a:endParaRPr lang="en-US" sz="1600" dirty="0"/>
           </a:p>
@@ -1614,13 +1614,13 @@
             <a:r>
               <a:rPr lang="en-US" sz="850" dirty="0">
                 <a:solidFill>
-                  <a:srgbClr val="8B949E"/>
-                </a:solidFill>
-                <a:latin typeface="Calibri" pitchFamily="34" charset="0"/>
-                <a:ea typeface="Calibri" pitchFamily="34" charset="-122"/>
-                <a:cs typeface="Calibri" pitchFamily="34" charset="-120"/>
-              </a:rPr>
-              <a:t>PART 5  ·  35 / 50</a:t>
+                  <a:srgbClr val="8A8078"/>
+                </a:solidFill>
+                <a:latin typeface="Calibri" pitchFamily="34" charset="0"/>
+                <a:ea typeface="Calibri" pitchFamily="34" charset="-122"/>
+                <a:cs typeface="Calibri" pitchFamily="34" charset="-120"/>
+              </a:rPr>
+              <a:t>PART 5</a:t>
             </a:r>
             <a:endParaRPr lang="en-US" sz="850" dirty="0"/>
           </a:p>
@@ -1643,11 +1643,11 @@
             </a:avLst>
           </a:prstGeom>
           <a:solidFill>
-            <a:srgbClr val="0F2A1A"/>
+            <a:srgbClr val="E5F0E9"/>
           </a:solidFill>
           <a:ln w="12700">
             <a:solidFill>
-              <a:srgbClr val="3FB950"/>
+              <a:srgbClr val="4A9968"/>
             </a:solidFill>
             <a:prstDash val="solid"/>
           </a:ln>
@@ -1680,13 +1680,13 @@
             <a:r>
               <a:rPr lang="en-US" sz="1200" b="1" dirty="0">
                 <a:solidFill>
-                  <a:srgbClr val="3FB950"/>
-                </a:solidFill>
-                <a:latin typeface="Calibri" pitchFamily="34" charset="0"/>
-                <a:ea typeface="Calibri" pitchFamily="34" charset="-122"/>
-                <a:cs typeface="Calibri" pitchFamily="34" charset="-120"/>
-              </a:rPr>
-              <a:t>👨‍💻 開發團隊 (Dev)</a:t>
+                  <a:srgbClr val="4A9968"/>
+                </a:solidFill>
+                <a:latin typeface="Calibri" pitchFamily="34" charset="0"/>
+                <a:ea typeface="Calibri" pitchFamily="34" charset="-122"/>
+                <a:cs typeface="Calibri" pitchFamily="34" charset="-120"/>
+              </a:rPr>
+              <a:t>👨‍💻 Dev Team</a:t>
             </a:r>
             <a:endParaRPr lang="en-US" sz="1200" dirty="0"/>
           </a:p>
@@ -1709,11 +1709,11 @@
             </a:avLst>
           </a:prstGeom>
           <a:solidFill>
-            <a:srgbClr val="161B22"/>
+            <a:srgbClr val="F5F1EB"/>
           </a:solidFill>
           <a:ln w="12700">
             <a:solidFill>
-              <a:srgbClr val="1F6FEB"/>
+              <a:srgbClr val="5B8DB8"/>
             </a:solidFill>
             <a:prstDash val="solid"/>
           </a:ln>
@@ -1746,13 +1746,13 @@
             <a:r>
               <a:rPr lang="en-US" sz="1000" b="1" dirty="0">
                 <a:solidFill>
-                  <a:srgbClr val="E6EDF3"/>
-                </a:solidFill>
-                <a:latin typeface="Calibri" pitchFamily="34" charset="0"/>
-                <a:ea typeface="Calibri" pitchFamily="34" charset="-122"/>
-                <a:cs typeface="Calibri" pitchFamily="34" charset="-120"/>
-              </a:rPr>
-              <a:t>💡 快速開發新功能</a:t>
+                  <a:srgbClr val="2D2926"/>
+                </a:solidFill>
+                <a:latin typeface="Calibri" pitchFamily="34" charset="0"/>
+                <a:ea typeface="Calibri" pitchFamily="34" charset="-122"/>
+                <a:cs typeface="Calibri" pitchFamily="34" charset="-120"/>
+              </a:rPr>
+              <a:t>💡 Rapidly develop new features</a:t>
             </a:r>
             <a:endParaRPr lang="en-US" sz="1000" dirty="0"/>
           </a:p>
@@ -1775,11 +1775,11 @@
             </a:avLst>
           </a:prstGeom>
           <a:solidFill>
-            <a:srgbClr val="161B22"/>
+            <a:srgbClr val="F5F1EB"/>
           </a:solidFill>
           <a:ln w="12700">
             <a:solidFill>
-              <a:srgbClr val="1F6FEB"/>
+              <a:srgbClr val="5B8DB8"/>
             </a:solidFill>
             <a:prstDash val="solid"/>
           </a:ln>
@@ -1812,13 +1812,13 @@
             <a:r>
               <a:rPr lang="en-US" sz="1000" dirty="0">
                 <a:solidFill>
-                  <a:srgbClr val="E6EDF3"/>
-                </a:solidFill>
-                <a:latin typeface="Calibri" pitchFamily="34" charset="0"/>
-                <a:ea typeface="Calibri" pitchFamily="34" charset="-122"/>
-                <a:cs typeface="Calibri" pitchFamily="34" charset="-120"/>
-              </a:rPr>
-              <a:t>🔀 頻繁合併代碼</a:t>
+                  <a:srgbClr val="2D2926"/>
+                </a:solidFill>
+                <a:latin typeface="Calibri" pitchFamily="34" charset="0"/>
+                <a:ea typeface="Calibri" pitchFamily="34" charset="-122"/>
+                <a:cs typeface="Calibri" pitchFamily="34" charset="-120"/>
+              </a:rPr>
+              <a:t>🔀 Frequently merge code</a:t>
             </a:r>
             <a:endParaRPr lang="en-US" sz="1000" dirty="0"/>
           </a:p>
@@ -1841,11 +1841,11 @@
             </a:avLst>
           </a:prstGeom>
           <a:solidFill>
-            <a:srgbClr val="161B22"/>
+            <a:srgbClr val="F5F1EB"/>
           </a:solidFill>
           <a:ln w="12700">
             <a:solidFill>
-              <a:srgbClr val="1F6FEB"/>
+              <a:srgbClr val="5B8DB8"/>
             </a:solidFill>
             <a:prstDash val="solid"/>
           </a:ln>
@@ -1878,13 +1878,13 @@
             <a:r>
               <a:rPr lang="en-US" sz="1000" dirty="0">
                 <a:solidFill>
-                  <a:srgbClr val="E6EDF3"/>
-                </a:solidFill>
-                <a:latin typeface="Calibri" pitchFamily="34" charset="0"/>
-                <a:ea typeface="Calibri" pitchFamily="34" charset="-122"/>
-                <a:cs typeface="Calibri" pitchFamily="34" charset="-120"/>
-              </a:rPr>
-              <a:t>⚡ 下午 5 點 push code</a:t>
+                  <a:srgbClr val="2D2926"/>
+                </a:solidFill>
+                <a:latin typeface="Calibri" pitchFamily="34" charset="0"/>
+                <a:ea typeface="Calibri" pitchFamily="34" charset="-122"/>
+                <a:cs typeface="Calibri" pitchFamily="34" charset="-120"/>
+              </a:rPr>
+              <a:t>⚡ Push code at 5 PM Friday</a:t>
             </a:r>
             <a:endParaRPr lang="en-US" sz="1000" dirty="0"/>
           </a:p>
@@ -1907,11 +1907,11 @@
             </a:avLst>
           </a:prstGeom>
           <a:solidFill>
-            <a:srgbClr val="161B22"/>
+            <a:srgbClr val="F5F1EB"/>
           </a:solidFill>
           <a:ln w="12700">
             <a:solidFill>
-              <a:srgbClr val="1F6FEB"/>
+              <a:srgbClr val="5B8DB8"/>
             </a:solidFill>
             <a:prstDash val="solid"/>
           </a:ln>
@@ -1944,13 +1944,13 @@
             <a:r>
               <a:rPr lang="en-US" sz="1000" dirty="0">
                 <a:solidFill>
-                  <a:srgbClr val="E6EDF3"/>
-                </a:solidFill>
-                <a:latin typeface="Calibri" pitchFamily="34" charset="0"/>
-                <a:ea typeface="Calibri" pitchFamily="34" charset="-122"/>
-                <a:cs typeface="Calibri" pitchFamily="34" charset="-120"/>
-              </a:rPr>
-              <a:t>🙏 「快點上線！」</a:t>
+                  <a:srgbClr val="2D2926"/>
+                </a:solidFill>
+                <a:latin typeface="Calibri" pitchFamily="34" charset="0"/>
+                <a:ea typeface="Calibri" pitchFamily="34" charset="-122"/>
+                <a:cs typeface="Calibri" pitchFamily="34" charset="-120"/>
+              </a:rPr>
+              <a:t>🙏 "Ship it now!"</a:t>
             </a:r>
             <a:endParaRPr lang="en-US" sz="1000" dirty="0"/>
           </a:p>
@@ -1973,11 +1973,11 @@
             </a:avLst>
           </a:prstGeom>
           <a:solidFill>
-            <a:srgbClr val="0F2A1A"/>
+            <a:srgbClr val="E5F0E9"/>
           </a:solidFill>
           <a:ln w="12700">
             <a:solidFill>
-              <a:srgbClr val="3FB950"/>
+              <a:srgbClr val="4A9968"/>
             </a:solidFill>
             <a:prstDash val="solid"/>
           </a:ln>
@@ -2010,7 +2010,7 @@
             <a:r>
               <a:rPr lang="en-US" sz="2200" b="1" dirty="0">
                 <a:solidFill>
-                  <a:srgbClr val="3FB950"/>
+                  <a:srgbClr val="4A9968"/>
                 </a:solidFill>
                 <a:latin typeface="Calibri" pitchFamily="34" charset="0"/>
                 <a:ea typeface="Calibri" pitchFamily="34" charset="-122"/>
@@ -2049,13 +2049,13 @@
             <a:r>
               <a:rPr lang="en-US" sz="750" dirty="0">
                 <a:solidFill>
-                  <a:srgbClr val="8B949E"/>
-                </a:solidFill>
-                <a:latin typeface="Calibri" pitchFamily="34" charset="0"/>
-                <a:ea typeface="Calibri" pitchFamily="34" charset="-122"/>
-                <a:cs typeface="Calibri" pitchFamily="34" charset="-120"/>
-              </a:rPr>
-              <a:t>feature/week  ·  功能開發速度</a:t>
+                  <a:srgbClr val="8A8078"/>
+                </a:solidFill>
+                <a:latin typeface="Calibri" pitchFamily="34" charset="0"/>
+                <a:ea typeface="Calibri" pitchFamily="34" charset="-122"/>
+                <a:cs typeface="Calibri" pitchFamily="34" charset="-120"/>
+              </a:rPr>
+              <a:t>feature/week  ·  Dev Velocity</a:t>
             </a:r>
             <a:endParaRPr lang="en-US" sz="750" dirty="0"/>
           </a:p>
@@ -2078,7 +2078,7 @@
           <a:noFill/>
           <a:ln w="38100">
             <a:solidFill>
-              <a:srgbClr val="F85149"/>
+              <a:srgbClr val="C4605B"/>
             </a:solidFill>
             <a:prstDash val="solid"/>
           </a:ln>
@@ -2111,7 +2111,7 @@
             <a:r>
               <a:rPr lang="en-US" sz="1100" b="1" dirty="0">
                 <a:solidFill>
-                  <a:srgbClr val="F85149"/>
+                  <a:srgbClr val="C4605B"/>
                 </a:solidFill>
                 <a:latin typeface="Calibri" pitchFamily="34" charset="0"/>
                 <a:ea typeface="Calibri" pitchFamily="34" charset="-122"/>
@@ -2140,7 +2140,7 @@
           <a:noFill/>
           <a:ln w="19050">
             <a:solidFill>
-              <a:srgbClr val="F85149"/>
+              <a:srgbClr val="C4605B"/>
             </a:solidFill>
             <a:prstDash val="solid"/>
             <a:tailEnd type="arrow"/>
@@ -2164,7 +2164,7 @@
           <a:noFill/>
           <a:ln w="19050">
             <a:solidFill>
-              <a:srgbClr val="F85149"/>
+              <a:srgbClr val="C4605B"/>
             </a:solidFill>
             <a:prstDash val="solid"/>
             <a:headEnd type="arrow"/>
@@ -2188,7 +2188,7 @@
           <a:noFill/>
           <a:ln w="19050">
             <a:solidFill>
-              <a:srgbClr val="F85149"/>
+              <a:srgbClr val="C4605B"/>
             </a:solidFill>
             <a:prstDash val="solid"/>
             <a:tailEnd type="arrow"/>
@@ -2212,7 +2212,7 @@
           <a:noFill/>
           <a:ln w="19050">
             <a:solidFill>
-              <a:srgbClr val="F85149"/>
+              <a:srgbClr val="C4605B"/>
             </a:solidFill>
             <a:prstDash val="solid"/>
             <a:headEnd type="arrow"/>
@@ -2236,7 +2236,7 @@
           <a:noFill/>
           <a:ln w="19050">
             <a:solidFill>
-              <a:srgbClr val="F85149"/>
+              <a:srgbClr val="C4605B"/>
             </a:solidFill>
             <a:prstDash val="solid"/>
             <a:tailEnd type="arrow"/>
@@ -2260,7 +2260,7 @@
           <a:noFill/>
           <a:ln w="19050">
             <a:solidFill>
-              <a:srgbClr val="F85149"/>
+              <a:srgbClr val="C4605B"/>
             </a:solidFill>
             <a:prstDash val="solid"/>
             <a:headEnd type="arrow"/>
@@ -2284,11 +2284,11 @@
             </a:avLst>
           </a:prstGeom>
           <a:solidFill>
-            <a:srgbClr val="2A0F0F"/>
+            <a:srgbClr val="F8ECEC"/>
           </a:solidFill>
           <a:ln w="12700">
             <a:solidFill>
-              <a:srgbClr val="F85149"/>
+              <a:srgbClr val="C4605B"/>
             </a:solidFill>
             <a:prstDash val="solid"/>
           </a:ln>
@@ -2321,13 +2321,13 @@
             <a:r>
               <a:rPr lang="en-US" sz="1200" b="1" dirty="0">
                 <a:solidFill>
-                  <a:srgbClr val="F85149"/>
-                </a:solidFill>
-                <a:latin typeface="Calibri" pitchFamily="34" charset="0"/>
-                <a:ea typeface="Calibri" pitchFamily="34" charset="-122"/>
-                <a:cs typeface="Calibri" pitchFamily="34" charset="-120"/>
-              </a:rPr>
-              <a:t>🔧 維運團隊 (Ops)</a:t>
+                  <a:srgbClr val="C4605B"/>
+                </a:solidFill>
+                <a:latin typeface="Calibri" pitchFamily="34" charset="0"/>
+                <a:ea typeface="Calibri" pitchFamily="34" charset="-122"/>
+                <a:cs typeface="Calibri" pitchFamily="34" charset="-120"/>
+              </a:rPr>
+              <a:t>🔧 Ops Team</a:t>
             </a:r>
             <a:endParaRPr lang="en-US" sz="1200" dirty="0"/>
           </a:p>
@@ -2350,11 +2350,11 @@
             </a:avLst>
           </a:prstGeom>
           <a:solidFill>
-            <a:srgbClr val="161B22"/>
+            <a:srgbClr val="F5F1EB"/>
           </a:solidFill>
           <a:ln w="12700">
             <a:solidFill>
-              <a:srgbClr val="F85149"/>
+              <a:srgbClr val="C4605B"/>
             </a:solidFill>
             <a:prstDash val="solid"/>
           </a:ln>
@@ -2387,13 +2387,13 @@
             <a:r>
               <a:rPr lang="en-US" sz="1000" dirty="0">
                 <a:solidFill>
-                  <a:srgbClr val="E6EDF3"/>
-                </a:solidFill>
-                <a:latin typeface="Calibri" pitchFamily="34" charset="0"/>
-                <a:ea typeface="Calibri" pitchFamily="34" charset="-122"/>
-                <a:cs typeface="Calibri" pitchFamily="34" charset="-120"/>
-              </a:rPr>
-              <a:t>🚨 穩定第一，不要動！</a:t>
+                  <a:srgbClr val="2D2926"/>
+                </a:solidFill>
+                <a:latin typeface="Calibri" pitchFamily="34" charset="0"/>
+                <a:ea typeface="Calibri" pitchFamily="34" charset="-122"/>
+                <a:cs typeface="Calibri" pitchFamily="34" charset="-120"/>
+              </a:rPr>
+              <a:t>🚨 Stability first, don't touch it!</a:t>
             </a:r>
             <a:endParaRPr lang="en-US" sz="1000" dirty="0"/>
           </a:p>
@@ -2416,11 +2416,11 @@
             </a:avLst>
           </a:prstGeom>
           <a:solidFill>
-            <a:srgbClr val="161B22"/>
+            <a:srgbClr val="F5F1EB"/>
           </a:solidFill>
           <a:ln w="12700">
             <a:solidFill>
-              <a:srgbClr val="F85149"/>
+              <a:srgbClr val="C4605B"/>
             </a:solidFill>
             <a:prstDash val="solid"/>
           </a:ln>
@@ -2453,13 +2453,13 @@
             <a:r>
               <a:rPr lang="en-US" sz="1000" dirty="0">
                 <a:solidFill>
-                  <a:srgbClr val="E6EDF3"/>
-                </a:solidFill>
-                <a:latin typeface="Calibri" pitchFamily="34" charset="0"/>
-                <a:ea typeface="Calibri" pitchFamily="34" charset="-122"/>
-                <a:cs typeface="Calibri" pitchFamily="34" charset="-120"/>
-              </a:rPr>
-              <a:t>😰 週五 5 點不能部署</a:t>
+                  <a:srgbClr val="2D2926"/>
+                </a:solidFill>
+                <a:latin typeface="Calibri" pitchFamily="34" charset="0"/>
+                <a:ea typeface="Calibri" pitchFamily="34" charset="-122"/>
+                <a:cs typeface="Calibri" pitchFamily="34" charset="-120"/>
+              </a:rPr>
+              <a:t>😰 No deploys on Friday at 5 PM</a:t>
             </a:r>
             <a:endParaRPr lang="en-US" sz="1000" dirty="0"/>
           </a:p>
@@ -2482,11 +2482,11 @@
             </a:avLst>
           </a:prstGeom>
           <a:solidFill>
-            <a:srgbClr val="161B22"/>
+            <a:srgbClr val="F5F1EB"/>
           </a:solidFill>
           <a:ln w="12700">
             <a:solidFill>
-              <a:srgbClr val="F85149"/>
+              <a:srgbClr val="C4605B"/>
             </a:solidFill>
             <a:prstDash val="solid"/>
           </a:ln>
@@ -2519,13 +2519,13 @@
             <a:r>
               <a:rPr lang="en-US" sz="1000" dirty="0">
                 <a:solidFill>
-                  <a:srgbClr val="E6EDF3"/>
-                </a:solidFill>
-                <a:latin typeface="Calibri" pitchFamily="34" charset="0"/>
-                <a:ea typeface="Calibri" pitchFamily="34" charset="-122"/>
-                <a:cs typeface="Calibri" pitchFamily="34" charset="-120"/>
-              </a:rPr>
-              <a:t>📋 變更管理需要審批</a:t>
+                  <a:srgbClr val="2D2926"/>
+                </a:solidFill>
+                <a:latin typeface="Calibri" pitchFamily="34" charset="0"/>
+                <a:ea typeface="Calibri" pitchFamily="34" charset="-122"/>
+                <a:cs typeface="Calibri" pitchFamily="34" charset="-120"/>
+              </a:rPr>
+              <a:t>📋 Change management requires approval</a:t>
             </a:r>
             <a:endParaRPr lang="en-US" sz="1000" dirty="0"/>
           </a:p>
@@ -2548,11 +2548,11 @@
             </a:avLst>
           </a:prstGeom>
           <a:solidFill>
-            <a:srgbClr val="161B22"/>
+            <a:srgbClr val="F5F1EB"/>
           </a:solidFill>
           <a:ln w="12700">
             <a:solidFill>
-              <a:srgbClr val="F85149"/>
+              <a:srgbClr val="C4605B"/>
             </a:solidFill>
             <a:prstDash val="solid"/>
           </a:ln>
@@ -2585,13 +2585,13 @@
             <a:r>
               <a:rPr lang="en-US" sz="1000" dirty="0">
                 <a:solidFill>
-                  <a:srgbClr val="E6EDF3"/>
-                </a:solidFill>
-                <a:latin typeface="Calibri" pitchFamily="34" charset="0"/>
-                <a:ea typeface="Calibri" pitchFamily="34" charset="-122"/>
-                <a:cs typeface="Calibri" pitchFamily="34" charset="-120"/>
-              </a:rPr>
-              <a:t>😤 「你們搞壞了 Prod！」</a:t>
+                  <a:srgbClr val="2D2926"/>
+                </a:solidFill>
+                <a:latin typeface="Calibri" pitchFamily="34" charset="0"/>
+                <a:ea typeface="Calibri" pitchFamily="34" charset="-122"/>
+                <a:cs typeface="Calibri" pitchFamily="34" charset="-120"/>
+              </a:rPr>
+              <a:t>😤 "You broke Prod!"</a:t>
             </a:r>
             <a:endParaRPr lang="en-US" sz="1000" dirty="0"/>
           </a:p>
@@ -2614,11 +2614,11 @@
             </a:avLst>
           </a:prstGeom>
           <a:solidFill>
-            <a:srgbClr val="2A1F00"/>
+            <a:srgbClr val="F3EDE0"/>
           </a:solidFill>
           <a:ln w="12700">
             <a:solidFill>
-              <a:srgbClr val="D29922"/>
+              <a:srgbClr val="B8892C"/>
             </a:solidFill>
             <a:prstDash val="solid"/>
           </a:ln>
@@ -2651,7 +2651,7 @@
             <a:r>
               <a:rPr lang="en-US" sz="2200" b="1" dirty="0">
                 <a:solidFill>
-                  <a:srgbClr val="D29922"/>
+                  <a:srgbClr val="B8892C"/>
                 </a:solidFill>
                 <a:latin typeface="Calibri" pitchFamily="34" charset="0"/>
                 <a:ea typeface="Calibri" pitchFamily="34" charset="-122"/>
@@ -2690,13 +2690,13 @@
             <a:r>
               <a:rPr lang="en-US" sz="750" dirty="0">
                 <a:solidFill>
-                  <a:srgbClr val="8B949E"/>
-                </a:solidFill>
-                <a:latin typeface="Calibri" pitchFamily="34" charset="0"/>
-                <a:ea typeface="Calibri" pitchFamily="34" charset="-122"/>
-                <a:cs typeface="Calibri" pitchFamily="34" charset="-120"/>
-              </a:rPr>
-              <a:t>MTTR  ·  平均故障恢復時間</a:t>
+                  <a:srgbClr val="8A8078"/>
+                </a:solidFill>
+                <a:latin typeface="Calibri" pitchFamily="34" charset="0"/>
+                <a:ea typeface="Calibri" pitchFamily="34" charset="-122"/>
+                <a:cs typeface="Calibri" pitchFamily="34" charset="-120"/>
+              </a:rPr>
+              <a:t>MTTR  ·  Mean Time To Restore</a:t>
             </a:r>
             <a:endParaRPr lang="en-US" sz="750" dirty="0"/>
           </a:p>
@@ -2719,11 +2719,11 @@
             </a:avLst>
           </a:prstGeom>
           <a:solidFill>
-            <a:srgbClr val="161B22"/>
+            <a:srgbClr val="F5F1EB"/>
           </a:solidFill>
           <a:ln w="15240">
             <a:solidFill>
-              <a:srgbClr val="3FB950"/>
+              <a:srgbClr val="4A9968"/>
             </a:solidFill>
             <a:prstDash val="solid"/>
           </a:ln>
@@ -2756,13 +2756,13 @@
             <a:r>
               <a:rPr lang="en-US" sz="1200" b="1" dirty="0">
                 <a:solidFill>
-                  <a:srgbClr val="3FB950"/>
-                </a:solidFill>
-                <a:latin typeface="Calibri" pitchFamily="34" charset="0"/>
-                <a:ea typeface="Calibri" pitchFamily="34" charset="-122"/>
-                <a:cs typeface="Calibri" pitchFamily="34" charset="-120"/>
-              </a:rPr>
-              <a:t>✅  DevOps 的核心目標：拆掉這道牆 — 讓開發、測試、部署、維運成為統一的連續流程</a:t>
+                  <a:srgbClr val="4A9968"/>
+                </a:solidFill>
+                <a:latin typeface="Calibri" pitchFamily="34" charset="0"/>
+                <a:ea typeface="Calibri" pitchFamily="34" charset="-122"/>
+                <a:cs typeface="Calibri" pitchFamily="34" charset="-120"/>
+              </a:rPr>
+              <a:t>✅  The core goal of DevOps: tear down this wall — unify dev, test, deploy, and ops into one continuous flow</a:t>
             </a:r>
             <a:endParaRPr lang="en-US" sz="1200" dirty="0"/>
           </a:p>
@@ -2785,11 +2785,11 @@
             </a:avLst>
           </a:prstGeom>
           <a:solidFill>
-            <a:srgbClr val="0A1929"/>
+            <a:srgbClr val="EAF0F7"/>
           </a:solidFill>
           <a:ln w="9525">
             <a:solidFill>
-              <a:srgbClr val="58A6FF"/>
+              <a:srgbClr val="4A7FB5"/>
             </a:solidFill>
             <a:prstDash val="solid"/>
           </a:ln>
@@ -2822,13 +2822,13 @@
             <a:r>
               <a:rPr lang="en-US" sz="1000" i="1" dirty="0">
                 <a:solidFill>
-                  <a:srgbClr val="8B949E"/>
-                </a:solidFill>
-                <a:latin typeface="Calibri" pitchFamily="34" charset="0"/>
-                <a:ea typeface="Calibri" pitchFamily="34" charset="-122"/>
-                <a:cs typeface="Calibri" pitchFamily="34" charset="-120"/>
-              </a:rPr>
-              <a:t>💡  DevOps 不是職稱，是文化和實踐 — Dev 懂 Ops，Ops 懂 Dev，自動化一切</a:t>
+                  <a:srgbClr val="8A8078"/>
+                </a:solidFill>
+                <a:latin typeface="Calibri" pitchFamily="34" charset="0"/>
+                <a:ea typeface="Calibri" pitchFamily="34" charset="-122"/>
+                <a:cs typeface="Calibri" pitchFamily="34" charset="-120"/>
+              </a:rPr>
+              <a:t>💡  DevOps is not a job title — it's a culture and practice. Dev understands Ops, Ops understands Dev, automate everything</a:t>
             </a:r>
             <a:endParaRPr lang="en-US" sz="1000" dirty="0"/>
           </a:p>
@@ -2848,7 +2848,7 @@
     <p:bg>
       <p:bgPr>
         <a:solidFill>
-          <a:srgbClr val="0D1117"/>
+          <a:srgbClr val="FFFDF8"/>
         </a:solidFill>
       </p:bgPr>
     </p:bg>
@@ -2881,11 +2881,11 @@
             <a:avLst/>
           </a:prstGeom>
           <a:solidFill>
-            <a:srgbClr val="161B22"/>
+            <a:srgbClr val="F5F1EB"/>
           </a:solidFill>
           <a:ln w="6350">
             <a:solidFill>
-              <a:srgbClr val="30363D"/>
+              <a:srgbClr val="D6CCBF"/>
             </a:solidFill>
             <a:prstDash val="solid"/>
           </a:ln>
@@ -2906,11 +2906,11 @@
             <a:avLst/>
           </a:prstGeom>
           <a:solidFill>
-            <a:srgbClr val="3FB950"/>
+            <a:srgbClr val="4A9968"/>
           </a:solidFill>
           <a:ln w="12700">
             <a:solidFill>
-              <a:srgbClr val="3FB950"/>
+              <a:srgbClr val="4A9968"/>
             </a:solidFill>
             <a:prstDash val="solid"/>
           </a:ln>
@@ -2943,13 +2943,13 @@
             <a:r>
               <a:rPr lang="en-US" sz="1600" b="1" dirty="0">
                 <a:solidFill>
-                  <a:srgbClr val="E6EDF3"/>
-                </a:solidFill>
-                <a:latin typeface="Calibri" pitchFamily="34" charset="0"/>
-                <a:ea typeface="Calibri" pitchFamily="34" charset="-122"/>
-                <a:cs typeface="Calibri" pitchFamily="34" charset="-120"/>
-              </a:rPr>
-              <a:t>CI/CD Pipeline：從 Commit 到 Production 全自動</a:t>
+                  <a:srgbClr val="2D2926"/>
+                </a:solidFill>
+                <a:latin typeface="Calibri" pitchFamily="34" charset="0"/>
+                <a:ea typeface="Calibri" pitchFamily="34" charset="-122"/>
+                <a:cs typeface="Calibri" pitchFamily="34" charset="-120"/>
+              </a:rPr>
+              <a:t>CI/CD Pipeline: Fully Automated from Commit to Production</a:t>
             </a:r>
             <a:endParaRPr lang="en-US" sz="1600" dirty="0"/>
           </a:p>
@@ -2982,13 +2982,13 @@
             <a:r>
               <a:rPr lang="en-US" sz="850" dirty="0">
                 <a:solidFill>
-                  <a:srgbClr val="8B949E"/>
-                </a:solidFill>
-                <a:latin typeface="Calibri" pitchFamily="34" charset="0"/>
-                <a:ea typeface="Calibri" pitchFamily="34" charset="-122"/>
-                <a:cs typeface="Calibri" pitchFamily="34" charset="-120"/>
-              </a:rPr>
-              <a:t>PART 5  ·  36 / 50</a:t>
+                  <a:srgbClr val="8A8078"/>
+                </a:solidFill>
+                <a:latin typeface="Calibri" pitchFamily="34" charset="0"/>
+                <a:ea typeface="Calibri" pitchFamily="34" charset="-122"/>
+                <a:cs typeface="Calibri" pitchFamily="34" charset="-120"/>
+              </a:rPr>
+              <a:t>PART 5</a:t>
             </a:r>
             <a:endParaRPr lang="en-US" sz="850" dirty="0"/>
           </a:p>
@@ -3011,18 +3011,18 @@
             </a:avLst>
           </a:prstGeom>
           <a:solidFill>
-            <a:srgbClr val="161B22"/>
+            <a:srgbClr val="F5F1EB"/>
           </a:solidFill>
           <a:ln w="19050">
             <a:solidFill>
-              <a:srgbClr val="8B949E"/>
+              <a:srgbClr val="908880"/>
             </a:solidFill>
             <a:prstDash val="solid"/>
           </a:ln>
           <a:effectLst>
             <a:outerShdw sx="100000" sy="100000" kx="0" ky="0" algn="bl" rotWithShape="0" blurRad="76200" dist="25400" dir="2700000">
-              <a:srgbClr val="000000">
-                <a:alpha val="30000"/>
+              <a:srgbClr val="9E9488">
+                <a:alpha val="15000"/>
               </a:srgbClr>
             </a:outerShdw>
           </a:effectLst>
@@ -3091,7 +3091,7 @@
             <a:r>
               <a:rPr lang="en-US" sz="1050" b="1" dirty="0">
                 <a:solidFill>
-                  <a:srgbClr val="E6EDF3"/>
+                  <a:srgbClr val="2D2926"/>
                 </a:solidFill>
                 <a:latin typeface="Calibri" pitchFamily="34" charset="0"/>
                 <a:ea typeface="Calibri" pitchFamily="34" charset="-122"/>
@@ -3130,7 +3130,7 @@
             <a:r>
               <a:rPr lang="en-US" sz="800" dirty="0">
                 <a:solidFill>
-                  <a:srgbClr val="8B949E"/>
+                  <a:srgbClr val="8A8078"/>
                 </a:solidFill>
                 <a:latin typeface="Consolas" pitchFamily="34" charset="0"/>
                 <a:ea typeface="Consolas" pitchFamily="34" charset="-122"/>
@@ -3159,18 +3159,18 @@
             </a:avLst>
           </a:prstGeom>
           <a:solidFill>
-            <a:srgbClr val="161B22"/>
+            <a:srgbClr val="F5F1EB"/>
           </a:solidFill>
           <a:ln w="19050">
             <a:solidFill>
-              <a:srgbClr val="58A6FF"/>
+              <a:srgbClr val="4A7FB5"/>
             </a:solidFill>
             <a:prstDash val="solid"/>
           </a:ln>
           <a:effectLst>
             <a:outerShdw sx="100000" sy="100000" kx="0" ky="0" algn="bl" rotWithShape="0" blurRad="76200" dist="25400" dir="2700000">
-              <a:srgbClr val="000000">
-                <a:alpha val="30000"/>
+              <a:srgbClr val="9E9488">
+                <a:alpha val="15000"/>
               </a:srgbClr>
             </a:outerShdw>
           </a:effectLst>
@@ -3239,7 +3239,7 @@
             <a:r>
               <a:rPr lang="en-US" sz="1050" b="1" dirty="0">
                 <a:solidFill>
-                  <a:srgbClr val="E6EDF3"/>
+                  <a:srgbClr val="2D2926"/>
                 </a:solidFill>
                 <a:latin typeface="Calibri" pitchFamily="34" charset="0"/>
                 <a:ea typeface="Calibri" pitchFamily="34" charset="-122"/>
@@ -3278,7 +3278,7 @@
             <a:r>
               <a:rPr lang="en-US" sz="800" dirty="0">
                 <a:solidFill>
-                  <a:srgbClr val="8B949E"/>
+                  <a:srgbClr val="8A8078"/>
                 </a:solidFill>
                 <a:latin typeface="Consolas" pitchFamily="34" charset="0"/>
                 <a:ea typeface="Consolas" pitchFamily="34" charset="-122"/>
@@ -3295,7 +3295,7 @@
             <a:r>
               <a:rPr lang="en-US" sz="800" dirty="0">
                 <a:solidFill>
-                  <a:srgbClr val="8B949E"/>
+                  <a:srgbClr val="8A8078"/>
                 </a:solidFill>
                 <a:latin typeface="Consolas" pitchFamily="34" charset="0"/>
                 <a:ea typeface="Consolas" pitchFamily="34" charset="-122"/>
@@ -3324,18 +3324,18 @@
             </a:avLst>
           </a:prstGeom>
           <a:solidFill>
-            <a:srgbClr val="161B22"/>
+            <a:srgbClr val="F5F1EB"/>
           </a:solidFill>
           <a:ln w="19050">
             <a:solidFill>
-              <a:srgbClr val="D29922"/>
+              <a:srgbClr val="B8892C"/>
             </a:solidFill>
             <a:prstDash val="solid"/>
           </a:ln>
           <a:effectLst>
             <a:outerShdw sx="100000" sy="100000" kx="0" ky="0" algn="bl" rotWithShape="0" blurRad="76200" dist="25400" dir="2700000">
-              <a:srgbClr val="000000">
-                <a:alpha val="30000"/>
+              <a:srgbClr val="9E9488">
+                <a:alpha val="15000"/>
               </a:srgbClr>
             </a:outerShdw>
           </a:effectLst>
@@ -3404,7 +3404,7 @@
             <a:r>
               <a:rPr lang="en-US" sz="1050" b="1" dirty="0">
                 <a:solidFill>
-                  <a:srgbClr val="E6EDF3"/>
+                  <a:srgbClr val="2D2926"/>
                 </a:solidFill>
                 <a:latin typeface="Calibri" pitchFamily="34" charset="0"/>
                 <a:ea typeface="Calibri" pitchFamily="34" charset="-122"/>
@@ -3443,7 +3443,7 @@
             <a:r>
               <a:rPr lang="en-US" sz="800" dirty="0">
                 <a:solidFill>
-                  <a:srgbClr val="8B949E"/>
+                  <a:srgbClr val="8A8078"/>
                 </a:solidFill>
                 <a:latin typeface="Consolas" pitchFamily="34" charset="0"/>
                 <a:ea typeface="Consolas" pitchFamily="34" charset="-122"/>
@@ -3460,7 +3460,7 @@
             <a:r>
               <a:rPr lang="en-US" sz="800" dirty="0">
                 <a:solidFill>
-                  <a:srgbClr val="8B949E"/>
+                  <a:srgbClr val="8A8078"/>
                 </a:solidFill>
                 <a:latin typeface="Consolas" pitchFamily="34" charset="0"/>
                 <a:ea typeface="Consolas" pitchFamily="34" charset="-122"/>
@@ -3489,18 +3489,18 @@
             </a:avLst>
           </a:prstGeom>
           <a:solidFill>
-            <a:srgbClr val="161B22"/>
+            <a:srgbClr val="F5F1EB"/>
           </a:solidFill>
           <a:ln w="19050">
             <a:solidFill>
-              <a:srgbClr val="0D8A6C"/>
+              <a:srgbClr val="4A9B8E"/>
             </a:solidFill>
             <a:prstDash val="solid"/>
           </a:ln>
           <a:effectLst>
             <a:outerShdw sx="100000" sy="100000" kx="0" ky="0" algn="bl" rotWithShape="0" blurRad="76200" dist="25400" dir="2700000">
-              <a:srgbClr val="000000">
-                <a:alpha val="30000"/>
+              <a:srgbClr val="9E9488">
+                <a:alpha val="15000"/>
               </a:srgbClr>
             </a:outerShdw>
           </a:effectLst>
@@ -3569,7 +3569,7 @@
             <a:r>
               <a:rPr lang="en-US" sz="1050" b="1" dirty="0">
                 <a:solidFill>
-                  <a:srgbClr val="E6EDF3"/>
+                  <a:srgbClr val="2D2926"/>
                 </a:solidFill>
                 <a:latin typeface="Calibri" pitchFamily="34" charset="0"/>
                 <a:ea typeface="Calibri" pitchFamily="34" charset="-122"/>
@@ -3608,7 +3608,7 @@
             <a:r>
               <a:rPr lang="en-US" sz="800" dirty="0">
                 <a:solidFill>
-                  <a:srgbClr val="8B949E"/>
+                  <a:srgbClr val="8A8078"/>
                 </a:solidFill>
                 <a:latin typeface="Consolas" pitchFamily="34" charset="0"/>
                 <a:ea typeface="Consolas" pitchFamily="34" charset="-122"/>
@@ -3625,7 +3625,7 @@
             <a:r>
               <a:rPr lang="en-US" sz="800" dirty="0">
                 <a:solidFill>
-                  <a:srgbClr val="8B949E"/>
+                  <a:srgbClr val="8A8078"/>
                 </a:solidFill>
                 <a:latin typeface="Consolas" pitchFamily="34" charset="0"/>
                 <a:ea typeface="Consolas" pitchFamily="34" charset="-122"/>
@@ -3654,18 +3654,18 @@
             </a:avLst>
           </a:prstGeom>
           <a:solidFill>
-            <a:srgbClr val="161B22"/>
+            <a:srgbClr val="F5F1EB"/>
           </a:solidFill>
           <a:ln w="19050">
             <a:solidFill>
-              <a:srgbClr val="6E40C9"/>
+              <a:srgbClr val="8B6AB5"/>
             </a:solidFill>
             <a:prstDash val="solid"/>
           </a:ln>
           <a:effectLst>
             <a:outerShdw sx="100000" sy="100000" kx="0" ky="0" algn="bl" rotWithShape="0" blurRad="76200" dist="25400" dir="2700000">
-              <a:srgbClr val="000000">
-                <a:alpha val="30000"/>
+              <a:srgbClr val="9E9488">
+                <a:alpha val="15000"/>
               </a:srgbClr>
             </a:outerShdw>
           </a:effectLst>
@@ -3734,7 +3734,7 @@
             <a:r>
               <a:rPr lang="en-US" sz="1050" b="1" dirty="0">
                 <a:solidFill>
-                  <a:srgbClr val="E6EDF3"/>
+                  <a:srgbClr val="2D2926"/>
                 </a:solidFill>
                 <a:latin typeface="Calibri" pitchFamily="34" charset="0"/>
                 <a:ea typeface="Calibri" pitchFamily="34" charset="-122"/>
@@ -3773,7 +3773,7 @@
             <a:r>
               <a:rPr lang="en-US" sz="800" dirty="0">
                 <a:solidFill>
-                  <a:srgbClr val="8B949E"/>
+                  <a:srgbClr val="8A8078"/>
                 </a:solidFill>
                 <a:latin typeface="Consolas" pitchFamily="34" charset="0"/>
                 <a:ea typeface="Consolas" pitchFamily="34" charset="-122"/>
@@ -3790,7 +3790,7 @@
             <a:r>
               <a:rPr lang="en-US" sz="800" dirty="0">
                 <a:solidFill>
-                  <a:srgbClr val="8B949E"/>
+                  <a:srgbClr val="8A8078"/>
                 </a:solidFill>
                 <a:latin typeface="Consolas" pitchFamily="34" charset="0"/>
                 <a:ea typeface="Consolas" pitchFamily="34" charset="-122"/>
@@ -3819,18 +3819,18 @@
             </a:avLst>
           </a:prstGeom>
           <a:solidFill>
-            <a:srgbClr val="161B22"/>
+            <a:srgbClr val="F5F1EB"/>
           </a:solidFill>
           <a:ln w="19050">
             <a:solidFill>
-              <a:srgbClr val="3FB950"/>
+              <a:srgbClr val="4A9968"/>
             </a:solidFill>
             <a:prstDash val="solid"/>
           </a:ln>
           <a:effectLst>
             <a:outerShdw sx="100000" sy="100000" kx="0" ky="0" algn="bl" rotWithShape="0" blurRad="76200" dist="25400" dir="2700000">
-              <a:srgbClr val="000000">
-                <a:alpha val="30000"/>
+              <a:srgbClr val="9E9488">
+                <a:alpha val="15000"/>
               </a:srgbClr>
             </a:outerShdw>
           </a:effectLst>
@@ -3899,7 +3899,7 @@
             <a:r>
               <a:rPr lang="en-US" sz="1050" b="1" dirty="0">
                 <a:solidFill>
-                  <a:srgbClr val="E6EDF3"/>
+                  <a:srgbClr val="2D2926"/>
                 </a:solidFill>
                 <a:latin typeface="Calibri" pitchFamily="34" charset="0"/>
                 <a:ea typeface="Calibri" pitchFamily="34" charset="-122"/>
@@ -3938,7 +3938,7 @@
             <a:r>
               <a:rPr lang="en-US" sz="800" dirty="0">
                 <a:solidFill>
-                  <a:srgbClr val="8B949E"/>
+                  <a:srgbClr val="8A8078"/>
                 </a:solidFill>
                 <a:latin typeface="Consolas" pitchFamily="34" charset="0"/>
                 <a:ea typeface="Consolas" pitchFamily="34" charset="-122"/>
@@ -3967,7 +3967,7 @@
           <a:noFill/>
           <a:ln w="19050">
             <a:solidFill>
-              <a:srgbClr val="58A6FF"/>
+              <a:srgbClr val="4A7FB5"/>
             </a:solidFill>
             <a:prstDash val="solid"/>
             <a:tailEnd type="arrow"/>
@@ -4001,7 +4001,7 @@
             <a:r>
               <a:rPr lang="en-US" sz="750" dirty="0">
                 <a:solidFill>
-                  <a:srgbClr val="58A6FF"/>
+                  <a:srgbClr val="4A7FB5"/>
                 </a:solidFill>
                 <a:latin typeface="Consolas" pitchFamily="34" charset="0"/>
                 <a:ea typeface="Consolas" pitchFamily="34" charset="-122"/>
@@ -4030,7 +4030,7 @@
           <a:noFill/>
           <a:ln w="19050">
             <a:solidFill>
-              <a:srgbClr val="58A6FF"/>
+              <a:srgbClr val="4A7FB5"/>
             </a:solidFill>
             <a:prstDash val="solid"/>
             <a:tailEnd type="arrow"/>
@@ -4064,7 +4064,7 @@
             <a:r>
               <a:rPr lang="en-US" sz="750" dirty="0">
                 <a:solidFill>
-                  <a:srgbClr val="58A6FF"/>
+                  <a:srgbClr val="4A7FB5"/>
                 </a:solidFill>
                 <a:latin typeface="Consolas" pitchFamily="34" charset="0"/>
                 <a:ea typeface="Consolas" pitchFamily="34" charset="-122"/>
@@ -4093,7 +4093,7 @@
           <a:noFill/>
           <a:ln w="19050">
             <a:solidFill>
-              <a:srgbClr val="D29922"/>
+              <a:srgbClr val="B8892C"/>
             </a:solidFill>
             <a:prstDash val="solid"/>
             <a:tailEnd type="arrow"/>
@@ -4127,7 +4127,7 @@
             <a:r>
               <a:rPr lang="en-US" sz="750" dirty="0">
                 <a:solidFill>
-                  <a:srgbClr val="D29922"/>
+                  <a:srgbClr val="B8892C"/>
                 </a:solidFill>
                 <a:latin typeface="Consolas" pitchFamily="34" charset="0"/>
                 <a:ea typeface="Consolas" pitchFamily="34" charset="-122"/>
@@ -4156,7 +4156,7 @@
           <a:noFill/>
           <a:ln w="19050">
             <a:solidFill>
-              <a:srgbClr val="0D8A6C"/>
+              <a:srgbClr val="4A9B8E"/>
             </a:solidFill>
             <a:prstDash val="solid"/>
             <a:tailEnd type="arrow"/>
@@ -4190,7 +4190,7 @@
             <a:r>
               <a:rPr lang="en-US" sz="750" dirty="0">
                 <a:solidFill>
-                  <a:srgbClr val="0D8A6C"/>
+                  <a:srgbClr val="4A9B8E"/>
                 </a:solidFill>
                 <a:latin typeface="Consolas" pitchFamily="34" charset="0"/>
                 <a:ea typeface="Consolas" pitchFamily="34" charset="-122"/>
@@ -4219,7 +4219,7 @@
           <a:noFill/>
           <a:ln w="19050">
             <a:solidFill>
-              <a:srgbClr val="3FB950"/>
+              <a:srgbClr val="4A9968"/>
             </a:solidFill>
             <a:prstDash val="solid"/>
             <a:tailEnd type="arrow"/>
@@ -4253,7 +4253,7 @@
             <a:r>
               <a:rPr lang="en-US" sz="750" dirty="0">
                 <a:solidFill>
-                  <a:srgbClr val="3FB950"/>
+                  <a:srgbClr val="4A9968"/>
                 </a:solidFill>
                 <a:latin typeface="Consolas" pitchFamily="34" charset="0"/>
                 <a:ea typeface="Consolas" pitchFamily="34" charset="-122"/>
@@ -4283,7 +4283,7 @@
           </a:prstGeom>
           <a:ln w="12700">
             <a:solidFill>
-              <a:srgbClr val="58A6FF"/>
+              <a:srgbClr val="4A7FB5"/>
             </a:solidFill>
             <a:prstDash val="dash"/>
           </a:ln>
@@ -4306,11 +4306,11 @@
             </a:avLst>
           </a:prstGeom>
           <a:solidFill>
-            <a:srgbClr val="0D1117"/>
+            <a:srgbClr val="FFFDF8"/>
           </a:solidFill>
           <a:ln w="6350">
             <a:solidFill>
-              <a:srgbClr val="58A6FF"/>
+              <a:srgbClr val="4A7FB5"/>
             </a:solidFill>
             <a:prstDash val="solid"/>
           </a:ln>
@@ -4343,7 +4343,7 @@
             <a:r>
               <a:rPr lang="en-US" sz="750" b="1" dirty="0">
                 <a:solidFill>
-                  <a:srgbClr val="58A6FF"/>
+                  <a:srgbClr val="4A7FB5"/>
                 </a:solidFill>
                 <a:latin typeface="Calibri" pitchFamily="34" charset="0"/>
                 <a:ea typeface="Calibri" pitchFamily="34" charset="-122"/>
@@ -4373,7 +4373,7 @@
           </a:prstGeom>
           <a:ln w="12700">
             <a:solidFill>
-              <a:srgbClr val="3FB950"/>
+              <a:srgbClr val="4A9968"/>
             </a:solidFill>
             <a:prstDash val="dash"/>
           </a:ln>
@@ -4396,11 +4396,11 @@
             </a:avLst>
           </a:prstGeom>
           <a:solidFill>
-            <a:srgbClr val="0D1117"/>
+            <a:srgbClr val="FFFDF8"/>
           </a:solidFill>
           <a:ln w="6350">
             <a:solidFill>
-              <a:srgbClr val="3FB950"/>
+              <a:srgbClr val="4A9968"/>
             </a:solidFill>
             <a:prstDash val="solid"/>
           </a:ln>
@@ -4433,7 +4433,7 @@
             <a:r>
               <a:rPr lang="en-US" sz="750" b="1" dirty="0">
                 <a:solidFill>
-                  <a:srgbClr val="3FB950"/>
+                  <a:srgbClr val="4A9968"/>
                 </a:solidFill>
                 <a:latin typeface="Calibri" pitchFamily="34" charset="0"/>
                 <a:ea typeface="Calibri" pitchFamily="34" charset="-122"/>
@@ -4462,18 +4462,18 @@
             </a:avLst>
           </a:prstGeom>
           <a:solidFill>
-            <a:srgbClr val="0D1117"/>
+            <a:srgbClr val="2D2926"/>
           </a:solidFill>
           <a:ln w="12700">
             <a:solidFill>
-              <a:srgbClr val="30363D"/>
+              <a:srgbClr val="D6CCBF"/>
             </a:solidFill>
             <a:prstDash val="solid"/>
           </a:ln>
           <a:effectLst>
             <a:outerShdw sx="100000" sy="100000" kx="0" ky="0" algn="bl" rotWithShape="0" blurRad="127000" dist="50800" dir="2700000">
-              <a:srgbClr val="000000">
-                <a:alpha val="50000"/>
+              <a:srgbClr val="9E9488">
+                <a:alpha val="15000"/>
               </a:srgbClr>
             </a:outerShdw>
           </a:effectLst>
@@ -4496,11 +4496,11 @@
             </a:avLst>
           </a:prstGeom>
           <a:solidFill>
-            <a:srgbClr val="1C2128"/>
+            <a:srgbClr val="ECE6DD"/>
           </a:solidFill>
           <a:ln w="6350">
             <a:solidFill>
-              <a:srgbClr val="30363D"/>
+              <a:srgbClr val="D6CCBF"/>
             </a:solidFill>
             <a:prstDash val="solid"/>
           </a:ln>
@@ -4533,7 +4533,7 @@
             <a:r>
               <a:rPr lang="en-US" sz="800" b="1" dirty="0">
                 <a:solidFill>
-                  <a:srgbClr val="8B949E"/>
+                  <a:srgbClr val="8A8078"/>
                 </a:solidFill>
                 <a:latin typeface="Consolas" pitchFamily="34" charset="0"/>
                 <a:ea typeface="Consolas" pitchFamily="34" charset="-122"/>
@@ -4575,7 +4575,7 @@
             <a:r>
               <a:rPr lang="en-US" sz="950" dirty="0">
                 <a:solidFill>
-                  <a:srgbClr val="E6EDF3"/>
+                  <a:srgbClr val="2D2926"/>
                 </a:solidFill>
                 <a:latin typeface="Consolas" pitchFamily="34" charset="0"/>
                 <a:ea typeface="Consolas" pitchFamily="34" charset="-122"/>
@@ -4595,7 +4595,7 @@
             <a:r>
               <a:rPr lang="en-US" sz="950" dirty="0">
                 <a:solidFill>
-                  <a:srgbClr val="E6EDF3"/>
+                  <a:srgbClr val="2D2926"/>
                 </a:solidFill>
                 <a:latin typeface="Consolas" pitchFamily="34" charset="0"/>
                 <a:ea typeface="Consolas" pitchFamily="34" charset="-122"/>
@@ -4624,7 +4624,7 @@
             <a:r>
               <a:rPr lang="en-US" sz="950" dirty="0">
                 <a:solidFill>
-                  <a:srgbClr val="E6EDF3"/>
+                  <a:srgbClr val="2D2926"/>
                 </a:solidFill>
                 <a:latin typeface="Consolas" pitchFamily="34" charset="0"/>
                 <a:ea typeface="Consolas" pitchFamily="34" charset="-122"/>
@@ -4644,7 +4644,7 @@
             <a:r>
               <a:rPr lang="en-US" sz="950" dirty="0">
                 <a:solidFill>
-                  <a:srgbClr val="E6EDF3"/>
+                  <a:srgbClr val="2D2926"/>
                 </a:solidFill>
                 <a:latin typeface="Consolas" pitchFamily="34" charset="0"/>
                 <a:ea typeface="Consolas" pitchFamily="34" charset="-122"/>
@@ -4664,7 +4664,7 @@
             <a:r>
               <a:rPr lang="en-US" sz="950" dirty="0">
                 <a:solidFill>
-                  <a:srgbClr val="E6EDF3"/>
+                  <a:srgbClr val="2D2926"/>
                 </a:solidFill>
                 <a:latin typeface="Consolas" pitchFamily="34" charset="0"/>
                 <a:ea typeface="Consolas" pitchFamily="34" charset="-122"/>
@@ -4684,7 +4684,7 @@
             <a:r>
               <a:rPr lang="en-US" sz="950" dirty="0">
                 <a:solidFill>
-                  <a:srgbClr val="E6EDF3"/>
+                  <a:srgbClr val="2D2926"/>
                 </a:solidFill>
                 <a:latin typeface="Consolas" pitchFamily="34" charset="0"/>
                 <a:ea typeface="Consolas" pitchFamily="34" charset="-122"/>
@@ -4704,7 +4704,7 @@
             <a:r>
               <a:rPr lang="en-US" sz="950" dirty="0">
                 <a:solidFill>
-                  <a:srgbClr val="E6EDF3"/>
+                  <a:srgbClr val="2D2926"/>
                 </a:solidFill>
                 <a:latin typeface="Consolas" pitchFamily="34" charset="0"/>
                 <a:ea typeface="Consolas" pitchFamily="34" charset="-122"/>
@@ -4724,7 +4724,7 @@
             <a:r>
               <a:rPr lang="en-US" sz="950" dirty="0">
                 <a:solidFill>
-                  <a:srgbClr val="E6EDF3"/>
+                  <a:srgbClr val="2D2926"/>
                 </a:solidFill>
                 <a:latin typeface="Consolas" pitchFamily="34" charset="0"/>
                 <a:ea typeface="Consolas" pitchFamily="34" charset="-122"/>
@@ -4744,7 +4744,7 @@
             <a:r>
               <a:rPr lang="en-US" sz="950" dirty="0">
                 <a:solidFill>
-                  <a:srgbClr val="E6EDF3"/>
+                  <a:srgbClr val="2D2926"/>
                 </a:solidFill>
                 <a:latin typeface="Consolas" pitchFamily="34" charset="0"/>
                 <a:ea typeface="Consolas" pitchFamily="34" charset="-122"/>
@@ -4773,7 +4773,7 @@
             <a:r>
               <a:rPr lang="en-US" sz="950" dirty="0">
                 <a:solidFill>
-                  <a:srgbClr val="E6EDF3"/>
+                  <a:srgbClr val="2D2926"/>
                 </a:solidFill>
                 <a:latin typeface="Consolas" pitchFamily="34" charset="0"/>
                 <a:ea typeface="Consolas" pitchFamily="34" charset="-122"/>
@@ -4793,7 +4793,7 @@
             <a:r>
               <a:rPr lang="en-US" sz="950" dirty="0">
                 <a:solidFill>
-                  <a:srgbClr val="E6EDF3"/>
+                  <a:srgbClr val="2D2926"/>
                 </a:solidFill>
                 <a:latin typeface="Consolas" pitchFamily="34" charset="0"/>
                 <a:ea typeface="Consolas" pitchFamily="34" charset="-122"/>
@@ -4813,7 +4813,7 @@
             <a:r>
               <a:rPr lang="en-US" sz="950" dirty="0">
                 <a:solidFill>
-                  <a:srgbClr val="E6EDF3"/>
+                  <a:srgbClr val="2D2926"/>
                 </a:solidFill>
                 <a:latin typeface="Consolas" pitchFamily="34" charset="0"/>
                 <a:ea typeface="Consolas" pitchFamily="34" charset="-122"/>
@@ -4833,7 +4833,7 @@
             <a:r>
               <a:rPr lang="en-US" sz="950" dirty="0">
                 <a:solidFill>
-                  <a:srgbClr val="E6EDF3"/>
+                  <a:srgbClr val="2D2926"/>
                 </a:solidFill>
                 <a:latin typeface="Consolas" pitchFamily="34" charset="0"/>
                 <a:ea typeface="Consolas" pitchFamily="34" charset="-122"/>
@@ -4853,7 +4853,7 @@
             <a:r>
               <a:rPr lang="en-US" sz="950" dirty="0">
                 <a:solidFill>
-                  <a:srgbClr val="E6EDF3"/>
+                  <a:srgbClr val="2D2926"/>
                 </a:solidFill>
                 <a:latin typeface="Consolas" pitchFamily="34" charset="0"/>
                 <a:ea typeface="Consolas" pitchFamily="34" charset="-122"/>
@@ -4873,7 +4873,7 @@
             <a:r>
               <a:rPr lang="en-US" sz="950" dirty="0">
                 <a:solidFill>
-                  <a:srgbClr val="E6EDF3"/>
+                  <a:srgbClr val="2D2926"/>
                 </a:solidFill>
                 <a:latin typeface="Consolas" pitchFamily="34" charset="0"/>
                 <a:ea typeface="Consolas" pitchFamily="34" charset="-122"/>
@@ -4902,18 +4902,18 @@
             </a:avLst>
           </a:prstGeom>
           <a:solidFill>
-            <a:srgbClr val="161B22"/>
+            <a:srgbClr val="F5F1EB"/>
           </a:solidFill>
           <a:ln w="19050">
             <a:solidFill>
-              <a:srgbClr val="3FB950"/>
+              <a:srgbClr val="4A9968"/>
             </a:solidFill>
             <a:prstDash val="solid"/>
           </a:ln>
           <a:effectLst>
             <a:outerShdw sx="100000" sy="100000" kx="0" ky="0" algn="bl" rotWithShape="0" blurRad="101600" dist="38100" dir="2700000">
-              <a:srgbClr val="000000">
-                <a:alpha val="35000"/>
+              <a:srgbClr val="9E9488">
+                <a:alpha val="15000"/>
               </a:srgbClr>
             </a:outerShdw>
           </a:effectLst>
@@ -4946,7 +4946,7 @@
             <a:r>
               <a:rPr lang="en-US" sz="3400" b="1" dirty="0">
                 <a:solidFill>
-                  <a:srgbClr val="3FB950"/>
+                  <a:srgbClr val="4A9968"/>
                 </a:solidFill>
                 <a:latin typeface="Calibri" pitchFamily="34" charset="0"/>
                 <a:ea typeface="Calibri" pitchFamily="34" charset="-122"/>
@@ -4985,13 +4985,13 @@
             <a:r>
               <a:rPr lang="en-US" sz="1200" b="1" dirty="0">
                 <a:solidFill>
-                  <a:srgbClr val="E6EDF3"/>
-                </a:solidFill>
-                <a:latin typeface="Calibri" pitchFamily="34" charset="0"/>
-                <a:ea typeface="Calibri" pitchFamily="34" charset="-122"/>
-                <a:cs typeface="Calibri" pitchFamily="34" charset="-120"/>
-              </a:rPr>
-              <a:t>Pipeline 時間目標</a:t>
+                  <a:srgbClr val="2D2926"/>
+                </a:solidFill>
+                <a:latin typeface="Calibri" pitchFamily="34" charset="0"/>
+                <a:ea typeface="Calibri" pitchFamily="34" charset="-122"/>
+                <a:cs typeface="Calibri" pitchFamily="34" charset="-120"/>
+              </a:rPr>
+              <a:t>Pipeline Time Target</a:t>
             </a:r>
             <a:endParaRPr lang="en-US" sz="1200" dirty="0"/>
           </a:p>
@@ -5014,18 +5014,18 @@
             </a:avLst>
           </a:prstGeom>
           <a:solidFill>
-            <a:srgbClr val="161B22"/>
+            <a:srgbClr val="F5F1EB"/>
           </a:solidFill>
           <a:ln w="19050">
             <a:solidFill>
-              <a:srgbClr val="58A6FF"/>
+              <a:srgbClr val="4A7FB5"/>
             </a:solidFill>
             <a:prstDash val="solid"/>
           </a:ln>
           <a:effectLst>
             <a:outerShdw sx="100000" sy="100000" kx="0" ky="0" algn="bl" rotWithShape="0" blurRad="101600" dist="38100" dir="2700000">
-              <a:srgbClr val="000000">
-                <a:alpha val="35000"/>
+              <a:srgbClr val="9E9488">
+                <a:alpha val="15000"/>
               </a:srgbClr>
             </a:outerShdw>
           </a:effectLst>
@@ -5058,7 +5058,7 @@
             <a:r>
               <a:rPr lang="en-US" sz="3400" b="1" dirty="0">
                 <a:solidFill>
-                  <a:srgbClr val="58A6FF"/>
+                  <a:srgbClr val="4A7FB5"/>
                 </a:solidFill>
                 <a:latin typeface="Calibri" pitchFamily="34" charset="0"/>
                 <a:ea typeface="Calibri" pitchFamily="34" charset="-122"/>
@@ -5097,13 +5097,13 @@
             <a:r>
               <a:rPr lang="en-US" sz="1200" b="1" dirty="0">
                 <a:solidFill>
-                  <a:srgbClr val="E6EDF3"/>
-                </a:solidFill>
-                <a:latin typeface="Calibri" pitchFamily="34" charset="0"/>
-                <a:ea typeface="Calibri" pitchFamily="34" charset="-122"/>
-                <a:cs typeface="Calibri" pitchFamily="34" charset="-120"/>
-              </a:rPr>
-              <a:t>自動化測試覆蓋</a:t>
+                  <a:srgbClr val="2D2926"/>
+                </a:solidFill>
+                <a:latin typeface="Calibri" pitchFamily="34" charset="0"/>
+                <a:ea typeface="Calibri" pitchFamily="34" charset="-122"/>
+                <a:cs typeface="Calibri" pitchFamily="34" charset="-120"/>
+              </a:rPr>
+              <a:t>Automated Test Coverage</a:t>
             </a:r>
             <a:endParaRPr lang="en-US" sz="1200" dirty="0"/>
           </a:p>
@@ -5126,18 +5126,18 @@
             </a:avLst>
           </a:prstGeom>
           <a:solidFill>
-            <a:srgbClr val="161B22"/>
+            <a:srgbClr val="F5F1EB"/>
           </a:solidFill>
           <a:ln w="19050">
             <a:solidFill>
-              <a:srgbClr val="D29922"/>
+              <a:srgbClr val="B8892C"/>
             </a:solidFill>
             <a:prstDash val="solid"/>
           </a:ln>
           <a:effectLst>
             <a:outerShdw sx="100000" sy="100000" kx="0" ky="0" algn="bl" rotWithShape="0" blurRad="101600" dist="38100" dir="2700000">
-              <a:srgbClr val="000000">
-                <a:alpha val="35000"/>
+              <a:srgbClr val="9E9488">
+                <a:alpha val="15000"/>
               </a:srgbClr>
             </a:outerShdw>
           </a:effectLst>
@@ -5170,7 +5170,7 @@
             <a:r>
               <a:rPr lang="en-US" sz="3400" b="1" dirty="0">
                 <a:solidFill>
-                  <a:srgbClr val="D29922"/>
+                  <a:srgbClr val="B8892C"/>
                 </a:solidFill>
                 <a:latin typeface="Calibri" pitchFamily="34" charset="0"/>
                 <a:ea typeface="Calibri" pitchFamily="34" charset="-122"/>
@@ -5209,13 +5209,13 @@
             <a:r>
               <a:rPr lang="en-US" sz="1200" b="1" dirty="0">
                 <a:solidFill>
-                  <a:srgbClr val="E6EDF3"/>
-                </a:solidFill>
-                <a:latin typeface="Calibri" pitchFamily="34" charset="0"/>
-                <a:ea typeface="Calibri" pitchFamily="34" charset="-122"/>
-                <a:cs typeface="Calibri" pitchFamily="34" charset="-120"/>
-              </a:rPr>
-              <a:t>每天部署次數 (Netflix)</a:t>
+                  <a:srgbClr val="2D2926"/>
+                </a:solidFill>
+                <a:latin typeface="Calibri" pitchFamily="34" charset="0"/>
+                <a:ea typeface="Calibri" pitchFamily="34" charset="-122"/>
+                <a:cs typeface="Calibri" pitchFamily="34" charset="-120"/>
+              </a:rPr>
+              <a:t>Deploys/Day (Netflix)</a:t>
             </a:r>
             <a:endParaRPr lang="en-US" sz="1200" dirty="0"/>
           </a:p>
@@ -5238,18 +5238,18 @@
             </a:avLst>
           </a:prstGeom>
           <a:solidFill>
-            <a:srgbClr val="161B22"/>
+            <a:srgbClr val="F5F1EB"/>
           </a:solidFill>
           <a:ln w="19050">
             <a:solidFill>
-              <a:srgbClr val="3FB950"/>
+              <a:srgbClr val="4A9968"/>
             </a:solidFill>
             <a:prstDash val="solid"/>
           </a:ln>
           <a:effectLst>
             <a:outerShdw sx="100000" sy="100000" kx="0" ky="0" algn="bl" rotWithShape="0" blurRad="101600" dist="38100" dir="2700000">
-              <a:srgbClr val="000000">
-                <a:alpha val="35000"/>
+              <a:srgbClr val="9E9488">
+                <a:alpha val="15000"/>
               </a:srgbClr>
             </a:outerShdw>
           </a:effectLst>
@@ -5282,7 +5282,7 @@
             <a:r>
               <a:rPr lang="en-US" sz="3400" b="1" dirty="0">
                 <a:solidFill>
-                  <a:srgbClr val="3FB950"/>
+                  <a:srgbClr val="4A9968"/>
                 </a:solidFill>
                 <a:latin typeface="Calibri" pitchFamily="34" charset="0"/>
                 <a:ea typeface="Calibri" pitchFamily="34" charset="-122"/>
@@ -5321,13 +5321,13 @@
             <a:r>
               <a:rPr lang="en-US" sz="1200" b="1" dirty="0">
                 <a:solidFill>
-                  <a:srgbClr val="E6EDF3"/>
-                </a:solidFill>
-                <a:latin typeface="Calibri" pitchFamily="34" charset="0"/>
-                <a:ea typeface="Calibri" pitchFamily="34" charset="-122"/>
-                <a:cs typeface="Calibri" pitchFamily="34" charset="-120"/>
-              </a:rPr>
-              <a:t>Commit→Prod 時間</a:t>
+                  <a:srgbClr val="2D2926"/>
+                </a:solidFill>
+                <a:latin typeface="Calibri" pitchFamily="34" charset="0"/>
+                <a:ea typeface="Calibri" pitchFamily="34" charset="-122"/>
+                <a:cs typeface="Calibri" pitchFamily="34" charset="-120"/>
+              </a:rPr>
+              <a:t>Commit→Prod Time</a:t>
             </a:r>
             <a:endParaRPr lang="en-US" sz="1200" dirty="0"/>
           </a:p>
@@ -5347,7 +5347,7 @@
     <p:bg>
       <p:bgPr>
         <a:solidFill>
-          <a:srgbClr val="0D1117"/>
+          <a:srgbClr val="FFFDF8"/>
         </a:solidFill>
       </p:bgPr>
     </p:bg>
@@ -5380,11 +5380,11 @@
             <a:avLst/>
           </a:prstGeom>
           <a:solidFill>
-            <a:srgbClr val="161B22"/>
+            <a:srgbClr val="F5F1EB"/>
           </a:solidFill>
           <a:ln w="6350">
             <a:solidFill>
-              <a:srgbClr val="30363D"/>
+              <a:srgbClr val="D6CCBF"/>
             </a:solidFill>
             <a:prstDash val="solid"/>
           </a:ln>
@@ -5405,11 +5405,11 @@
             <a:avLst/>
           </a:prstGeom>
           <a:solidFill>
-            <a:srgbClr val="6E40C9"/>
+            <a:srgbClr val="8B6AB5"/>
           </a:solidFill>
           <a:ln w="12700">
             <a:solidFill>
-              <a:srgbClr val="6E40C9"/>
+              <a:srgbClr val="8B6AB5"/>
             </a:solidFill>
             <a:prstDash val="solid"/>
           </a:ln>
@@ -5442,13 +5442,13 @@
             <a:r>
               <a:rPr lang="en-US" sz="1600" b="1" dirty="0">
                 <a:solidFill>
-                  <a:srgbClr val="E6EDF3"/>
-                </a:solidFill>
-                <a:latin typeface="Calibri" pitchFamily="34" charset="0"/>
-                <a:ea typeface="Calibri" pitchFamily="34" charset="-122"/>
-                <a:cs typeface="Calibri" pitchFamily="34" charset="-120"/>
-              </a:rPr>
-              <a:t>GitOps：Git 作為唯一真相來源</a:t>
+                  <a:srgbClr val="2D2926"/>
+                </a:solidFill>
+                <a:latin typeface="Calibri" pitchFamily="34" charset="0"/>
+                <a:ea typeface="Calibri" pitchFamily="34" charset="-122"/>
+                <a:cs typeface="Calibri" pitchFamily="34" charset="-120"/>
+              </a:rPr>
+              <a:t>GitOps: Git as the Single Source of Truth</a:t>
             </a:r>
             <a:endParaRPr lang="en-US" sz="1600" dirty="0"/>
           </a:p>
@@ -5481,13 +5481,13 @@
             <a:r>
               <a:rPr lang="en-US" sz="850" dirty="0">
                 <a:solidFill>
-                  <a:srgbClr val="8B949E"/>
-                </a:solidFill>
-                <a:latin typeface="Calibri" pitchFamily="34" charset="0"/>
-                <a:ea typeface="Calibri" pitchFamily="34" charset="-122"/>
-                <a:cs typeface="Calibri" pitchFamily="34" charset="-120"/>
-              </a:rPr>
-              <a:t>PART 5  ·  37 / 50</a:t>
+                  <a:srgbClr val="8A8078"/>
+                </a:solidFill>
+                <a:latin typeface="Calibri" pitchFamily="34" charset="0"/>
+                <a:ea typeface="Calibri" pitchFamily="34" charset="-122"/>
+                <a:cs typeface="Calibri" pitchFamily="34" charset="-120"/>
+              </a:rPr>
+              <a:t>PART 5</a:t>
             </a:r>
             <a:endParaRPr lang="en-US" sz="850" dirty="0"/>
           </a:p>
@@ -5510,11 +5510,11 @@
             </a:avLst>
           </a:prstGeom>
           <a:solidFill>
-            <a:srgbClr val="0F2A1A"/>
+            <a:srgbClr val="E5F0E9"/>
           </a:solidFill>
           <a:ln w="12700">
             <a:solidFill>
-              <a:srgbClr val="3FB950"/>
+              <a:srgbClr val="4A9968"/>
             </a:solidFill>
             <a:prstDash val="solid"/>
           </a:ln>
@@ -5547,13 +5547,13 @@
             <a:r>
               <a:rPr lang="en-US" sz="1200" b="1" dirty="0">
                 <a:solidFill>
-                  <a:srgbClr val="3FB950"/>
-                </a:solidFill>
-                <a:latin typeface="Calibri" pitchFamily="34" charset="0"/>
-                <a:ea typeface="Calibri" pitchFamily="34" charset="-122"/>
-                <a:cs typeface="Calibri" pitchFamily="34" charset="-120"/>
-              </a:rPr>
-              <a:t>GitOps 核心原則</a:t>
+                  <a:srgbClr val="4A9968"/>
+                </a:solidFill>
+                <a:latin typeface="Calibri" pitchFamily="34" charset="0"/>
+                <a:ea typeface="Calibri" pitchFamily="34" charset="-122"/>
+                <a:cs typeface="Calibri" pitchFamily="34" charset="-120"/>
+              </a:rPr>
+              <a:t>GitOps Core Principles</a:t>
             </a:r>
             <a:endParaRPr lang="en-US" sz="1200" dirty="0"/>
           </a:p>
@@ -5576,11 +5576,11 @@
             </a:avLst>
           </a:prstGeom>
           <a:solidFill>
-            <a:srgbClr val="161B22"/>
+            <a:srgbClr val="F5F1EB"/>
           </a:solidFill>
           <a:ln w="12700">
             <a:solidFill>
-              <a:srgbClr val="6E40C9"/>
+              <a:srgbClr val="8B6AB5"/>
             </a:solidFill>
             <a:prstDash val="solid"/>
           </a:ln>
@@ -5613,13 +5613,13 @@
             <a:r>
               <a:rPr lang="en-US" sz="1000" b="1" dirty="0">
                 <a:solidFill>
-                  <a:srgbClr val="E6EDF3"/>
-                </a:solidFill>
-                <a:latin typeface="Calibri" pitchFamily="34" charset="0"/>
-                <a:ea typeface="Calibri" pitchFamily="34" charset="-122"/>
-                <a:cs typeface="Calibri" pitchFamily="34" charset="-120"/>
-              </a:rPr>
-              <a:t>① Git 是唯一真相來源 (Single Source of Truth)</a:t>
+                  <a:srgbClr val="2D2926"/>
+                </a:solidFill>
+                <a:latin typeface="Calibri" pitchFamily="34" charset="0"/>
+                <a:ea typeface="Calibri" pitchFamily="34" charset="-122"/>
+                <a:cs typeface="Calibri" pitchFamily="34" charset="-120"/>
+              </a:rPr>
+              <a:t>① Git is the Single Source of Truth</a:t>
             </a:r>
             <a:endParaRPr lang="en-US" sz="1000" dirty="0"/>
           </a:p>
@@ -5642,11 +5642,11 @@
             </a:avLst>
           </a:prstGeom>
           <a:solidFill>
-            <a:srgbClr val="161B22"/>
+            <a:srgbClr val="F5F1EB"/>
           </a:solidFill>
           <a:ln w="12700">
             <a:solidFill>
-              <a:srgbClr val="6E40C9"/>
+              <a:srgbClr val="8B6AB5"/>
             </a:solidFill>
             <a:prstDash val="solid"/>
           </a:ln>
@@ -5679,13 +5679,13 @@
             <a:r>
               <a:rPr lang="en-US" sz="1000" b="1" dirty="0">
                 <a:solidFill>
-                  <a:srgbClr val="E6EDF3"/>
-                </a:solidFill>
-                <a:latin typeface="Calibri" pitchFamily="34" charset="0"/>
-                <a:ea typeface="Calibri" pitchFamily="34" charset="-122"/>
-                <a:cs typeface="Calibri" pitchFamily="34" charset="-120"/>
-              </a:rPr>
-              <a:t>② 所有變更通過 Pull Request</a:t>
+                  <a:srgbClr val="2D2926"/>
+                </a:solidFill>
+                <a:latin typeface="Calibri" pitchFamily="34" charset="0"/>
+                <a:ea typeface="Calibri" pitchFamily="34" charset="-122"/>
+                <a:cs typeface="Calibri" pitchFamily="34" charset="-120"/>
+              </a:rPr>
+              <a:t>② All changes go through Pull Requests</a:t>
             </a:r>
             <a:endParaRPr lang="en-US" sz="1000" dirty="0"/>
           </a:p>
@@ -5708,11 +5708,11 @@
             </a:avLst>
           </a:prstGeom>
           <a:solidFill>
-            <a:srgbClr val="161B22"/>
+            <a:srgbClr val="F5F1EB"/>
           </a:solidFill>
           <a:ln w="12700">
             <a:solidFill>
-              <a:srgbClr val="6E40C9"/>
+              <a:srgbClr val="8B6AB5"/>
             </a:solidFill>
             <a:prstDash val="solid"/>
           </a:ln>
@@ -5745,13 +5745,13 @@
             <a:r>
               <a:rPr lang="en-US" sz="1000" b="1" dirty="0">
                 <a:solidFill>
-                  <a:srgbClr val="E6EDF3"/>
-                </a:solidFill>
-                <a:latin typeface="Calibri" pitchFamily="34" charset="0"/>
-                <a:ea typeface="Calibri" pitchFamily="34" charset="-122"/>
-                <a:cs typeface="Calibri" pitchFamily="34" charset="-120"/>
-              </a:rPr>
-              <a:t>③ 自動同步 — Git state = Cluster state</a:t>
+                  <a:srgbClr val="2D2926"/>
+                </a:solidFill>
+                <a:latin typeface="Calibri" pitchFamily="34" charset="0"/>
+                <a:ea typeface="Calibri" pitchFamily="34" charset="-122"/>
+                <a:cs typeface="Calibri" pitchFamily="34" charset="-120"/>
+              </a:rPr>
+              <a:t>③ Auto-sync — Git state = Cluster state</a:t>
             </a:r>
             <a:endParaRPr lang="en-US" sz="1000" dirty="0"/>
           </a:p>
@@ -5774,11 +5774,11 @@
             </a:avLst>
           </a:prstGeom>
           <a:solidFill>
-            <a:srgbClr val="161B22"/>
+            <a:srgbClr val="F5F1EB"/>
           </a:solidFill>
           <a:ln w="12700">
             <a:solidFill>
-              <a:srgbClr val="6E40C9"/>
+              <a:srgbClr val="8B6AB5"/>
             </a:solidFill>
             <a:prstDash val="solid"/>
           </a:ln>
@@ -5811,13 +5811,13 @@
             <a:r>
               <a:rPr lang="en-US" sz="1000" b="1" dirty="0">
                 <a:solidFill>
-                  <a:srgbClr val="E6EDF3"/>
-                </a:solidFill>
-                <a:latin typeface="Calibri" pitchFamily="34" charset="0"/>
-                <a:ea typeface="Calibri" pitchFamily="34" charset="-122"/>
-                <a:cs typeface="Calibri" pitchFamily="34" charset="-120"/>
-              </a:rPr>
-              <a:t>④ 可審計、可回滾 — git revert 即回滾</a:t>
+                  <a:srgbClr val="2D2926"/>
+                </a:solidFill>
+                <a:latin typeface="Calibri" pitchFamily="34" charset="0"/>
+                <a:ea typeface="Calibri" pitchFamily="34" charset="-122"/>
+                <a:cs typeface="Calibri" pitchFamily="34" charset="-120"/>
+              </a:rPr>
+              <a:t>④ Auditable &amp; rollbackable — git revert = rollback</a:t>
             </a:r>
             <a:endParaRPr lang="en-US" sz="1000" dirty="0"/>
           </a:p>
@@ -5840,11 +5840,11 @@
             </a:avLst>
           </a:prstGeom>
           <a:solidFill>
-            <a:srgbClr val="161B22"/>
+            <a:srgbClr val="F5F1EB"/>
           </a:solidFill>
           <a:ln w="12700">
             <a:solidFill>
-              <a:srgbClr val="3FB950"/>
+              <a:srgbClr val="4A9968"/>
             </a:solidFill>
             <a:prstDash val="solid"/>
           </a:ln>
@@ -5877,7 +5877,7 @@
             <a:r>
               <a:rPr lang="en-US" sz="1000" b="1" dirty="0">
                 <a:solidFill>
-                  <a:srgbClr val="3FB950"/>
+                  <a:srgbClr val="4A9968"/>
                 </a:solidFill>
                 <a:latin typeface="Calibri" pitchFamily="34" charset="0"/>
                 <a:ea typeface="Calibri" pitchFamily="34" charset="-122"/>
@@ -5906,11 +5906,11 @@
             </a:avLst>
           </a:prstGeom>
           <a:solidFill>
-            <a:srgbClr val="161B22"/>
+            <a:srgbClr val="F5F1EB"/>
           </a:solidFill>
           <a:ln w="12700">
             <a:solidFill>
-              <a:srgbClr val="3FB950"/>
+              <a:srgbClr val="4A9968"/>
             </a:solidFill>
             <a:prstDash val="solid"/>
           </a:ln>
@@ -5943,7 +5943,7 @@
             <a:r>
               <a:rPr lang="en-US" sz="1000" b="1" dirty="0">
                 <a:solidFill>
-                  <a:srgbClr val="3FB950"/>
+                  <a:srgbClr val="4A9968"/>
                 </a:solidFill>
                 <a:latin typeface="Calibri" pitchFamily="34" charset="0"/>
                 <a:ea typeface="Calibri" pitchFamily="34" charset="-122"/>
@@ -5972,11 +5972,11 @@
             </a:avLst>
           </a:prstGeom>
           <a:solidFill>
-            <a:srgbClr val="161B22"/>
+            <a:srgbClr val="F5F1EB"/>
           </a:solidFill>
           <a:ln w="12700">
             <a:solidFill>
-              <a:srgbClr val="58A6FF"/>
+              <a:srgbClr val="4A7FB5"/>
             </a:solidFill>
             <a:prstDash val="solid"/>
           </a:ln>
@@ -6009,7 +6009,7 @@
             <a:r>
               <a:rPr lang="en-US" sz="1000" b="1" dirty="0">
                 <a:solidFill>
-                  <a:srgbClr val="58A6FF"/>
+                  <a:srgbClr val="4A7FB5"/>
                 </a:solidFill>
                 <a:latin typeface="Calibri" pitchFamily="34" charset="0"/>
                 <a:ea typeface="Calibri" pitchFamily="34" charset="-122"/>
@@ -6038,18 +6038,18 @@
             </a:avLst>
           </a:prstGeom>
           <a:solidFill>
-            <a:srgbClr val="161B22"/>
+            <a:srgbClr val="F5F1EB"/>
           </a:solidFill>
           <a:ln w="19050">
             <a:solidFill>
-              <a:srgbClr val="8B949E"/>
+              <a:srgbClr val="908880"/>
             </a:solidFill>
             <a:prstDash val="solid"/>
           </a:ln>
           <a:effectLst>
             <a:outerShdw sx="100000" sy="100000" kx="0" ky="0" algn="bl" rotWithShape="0" blurRad="76200" dist="25400" dir="2700000">
-              <a:srgbClr val="000000">
-                <a:alpha val="30000"/>
+              <a:srgbClr val="9E9488">
+                <a:alpha val="15000"/>
               </a:srgbClr>
             </a:outerShdw>
           </a:effectLst>
@@ -6118,7 +6118,7 @@
             <a:r>
               <a:rPr lang="en-US" sz="1050" b="1" dirty="0">
                 <a:solidFill>
-                  <a:srgbClr val="E6EDF3"/>
+                  <a:srgbClr val="2D2926"/>
                 </a:solidFill>
                 <a:latin typeface="Calibri" pitchFamily="34" charset="0"/>
                 <a:ea typeface="Calibri" pitchFamily="34" charset="-122"/>
@@ -6157,7 +6157,7 @@
             <a:r>
               <a:rPr lang="en-US" sz="800" dirty="0">
                 <a:solidFill>
-                  <a:srgbClr val="8B949E"/>
+                  <a:srgbClr val="8A8078"/>
                 </a:solidFill>
                 <a:latin typeface="Consolas" pitchFamily="34" charset="0"/>
                 <a:ea typeface="Consolas" pitchFamily="34" charset="-122"/>
@@ -6186,7 +6186,7 @@
           <a:noFill/>
           <a:ln w="19050">
             <a:solidFill>
-              <a:srgbClr val="58A6FF"/>
+              <a:srgbClr val="4A7FB5"/>
             </a:solidFill>
             <a:prstDash val="solid"/>
             <a:tailEnd type="arrow"/>
@@ -6220,7 +6220,7 @@
             <a:r>
               <a:rPr lang="en-US" sz="800" dirty="0">
                 <a:solidFill>
-                  <a:srgbClr val="58A6FF"/>
+                  <a:srgbClr val="4A7FB5"/>
                 </a:solidFill>
                 <a:latin typeface="Consolas" pitchFamily="34" charset="0"/>
                 <a:ea typeface="Consolas" pitchFamily="34" charset="-122"/>
@@ -6249,18 +6249,18 @@
             </a:avLst>
           </a:prstGeom>
           <a:solidFill>
-            <a:srgbClr val="161B22"/>
+            <a:srgbClr val="F5F1EB"/>
           </a:solidFill>
           <a:ln w="19050">
             <a:solidFill>
-              <a:srgbClr val="58A6FF"/>
+              <a:srgbClr val="4A7FB5"/>
             </a:solidFill>
             <a:prstDash val="solid"/>
           </a:ln>
           <a:effectLst>
             <a:outerShdw sx="100000" sy="100000" kx="0" ky="0" algn="bl" rotWithShape="0" blurRad="76200" dist="25400" dir="2700000">
-              <a:srgbClr val="000000">
-                <a:alpha val="30000"/>
+              <a:srgbClr val="9E9488">
+                <a:alpha val="15000"/>
               </a:srgbClr>
             </a:outerShdw>
           </a:effectLst>
@@ -6329,7 +6329,7 @@
             <a:r>
               <a:rPr lang="en-US" sz="1050" b="1" dirty="0">
                 <a:solidFill>
-                  <a:srgbClr val="E6EDF3"/>
+                  <a:srgbClr val="2D2926"/>
                 </a:solidFill>
                 <a:latin typeface="Calibri" pitchFamily="34" charset="0"/>
                 <a:ea typeface="Calibri" pitchFamily="34" charset="-122"/>
@@ -6368,7 +6368,7 @@
             <a:r>
               <a:rPr lang="en-US" sz="800" dirty="0">
                 <a:solidFill>
-                  <a:srgbClr val="8B949E"/>
+                  <a:srgbClr val="8A8078"/>
                 </a:solidFill>
                 <a:latin typeface="Consolas" pitchFamily="34" charset="0"/>
                 <a:ea typeface="Consolas" pitchFamily="34" charset="-122"/>
@@ -6397,7 +6397,7 @@
           <a:noFill/>
           <a:ln w="19050">
             <a:solidFill>
-              <a:srgbClr val="6E40C9"/>
+              <a:srgbClr val="8B6AB5"/>
             </a:solidFill>
             <a:prstDash val="solid"/>
             <a:tailEnd type="arrow"/>
@@ -6431,7 +6431,7 @@
             <a:r>
               <a:rPr lang="en-US" sz="750" dirty="0">
                 <a:solidFill>
-                  <a:srgbClr val="6E40C9"/>
+                  <a:srgbClr val="8B6AB5"/>
                 </a:solidFill>
                 <a:latin typeface="Consolas" pitchFamily="34" charset="0"/>
                 <a:ea typeface="Consolas" pitchFamily="34" charset="-122"/>
@@ -6460,18 +6460,18 @@
             </a:avLst>
           </a:prstGeom>
           <a:solidFill>
-            <a:srgbClr val="161B22"/>
+            <a:srgbClr val="F5F1EB"/>
           </a:solidFill>
           <a:ln w="19050">
             <a:solidFill>
-              <a:srgbClr val="6E40C9"/>
+              <a:srgbClr val="8B6AB5"/>
             </a:solidFill>
             <a:prstDash val="solid"/>
           </a:ln>
           <a:effectLst>
             <a:outerShdw sx="100000" sy="100000" kx="0" ky="0" algn="bl" rotWithShape="0" blurRad="76200" dist="25400" dir="2700000">
-              <a:srgbClr val="000000">
-                <a:alpha val="30000"/>
+              <a:srgbClr val="9E9488">
+                <a:alpha val="15000"/>
               </a:srgbClr>
             </a:outerShdw>
           </a:effectLst>
@@ -6540,7 +6540,7 @@
             <a:r>
               <a:rPr lang="en-US" sz="1050" b="1" dirty="0">
                 <a:solidFill>
-                  <a:srgbClr val="E6EDF3"/>
+                  <a:srgbClr val="2D2926"/>
                 </a:solidFill>
                 <a:latin typeface="Calibri" pitchFamily="34" charset="0"/>
                 <a:ea typeface="Calibri" pitchFamily="34" charset="-122"/>
@@ -6579,7 +6579,7 @@
             <a:r>
               <a:rPr lang="en-US" sz="800" dirty="0">
                 <a:solidFill>
-                  <a:srgbClr val="8B949E"/>
+                  <a:srgbClr val="8A8078"/>
                 </a:solidFill>
                 <a:latin typeface="Consolas" pitchFamily="34" charset="0"/>
                 <a:ea typeface="Consolas" pitchFamily="34" charset="-122"/>
@@ -6608,7 +6608,7 @@
           <a:noFill/>
           <a:ln w="19050">
             <a:solidFill>
-              <a:srgbClr val="3FB950"/>
+              <a:srgbClr val="4A9968"/>
             </a:solidFill>
             <a:prstDash val="solid"/>
             <a:tailEnd type="arrow"/>
@@ -6642,7 +6642,7 @@
             <a:r>
               <a:rPr lang="en-US" sz="750" dirty="0">
                 <a:solidFill>
-                  <a:srgbClr val="3FB950"/>
+                  <a:srgbClr val="4A9968"/>
                 </a:solidFill>
                 <a:latin typeface="Consolas" pitchFamily="34" charset="0"/>
                 <a:ea typeface="Consolas" pitchFamily="34" charset="-122"/>
@@ -6671,18 +6671,18 @@
             </a:avLst>
           </a:prstGeom>
           <a:solidFill>
-            <a:srgbClr val="161B22"/>
+            <a:srgbClr val="F5F1EB"/>
           </a:solidFill>
           <a:ln w="19050">
             <a:solidFill>
-              <a:srgbClr val="3FB950"/>
+              <a:srgbClr val="4A9968"/>
             </a:solidFill>
             <a:prstDash val="solid"/>
           </a:ln>
           <a:effectLst>
             <a:outerShdw sx="100000" sy="100000" kx="0" ky="0" algn="bl" rotWithShape="0" blurRad="76200" dist="25400" dir="2700000">
-              <a:srgbClr val="000000">
-                <a:alpha val="30000"/>
+              <a:srgbClr val="9E9488">
+                <a:alpha val="15000"/>
               </a:srgbClr>
             </a:outerShdw>
           </a:effectLst>
@@ -6751,7 +6751,7 @@
             <a:r>
               <a:rPr lang="en-US" sz="1050" b="1" dirty="0">
                 <a:solidFill>
-                  <a:srgbClr val="E6EDF3"/>
+                  <a:srgbClr val="2D2926"/>
                 </a:solidFill>
                 <a:latin typeface="Calibri" pitchFamily="34" charset="0"/>
                 <a:ea typeface="Calibri" pitchFamily="34" charset="-122"/>
@@ -6790,7 +6790,7 @@
             <a:r>
               <a:rPr lang="en-US" sz="800" dirty="0">
                 <a:solidFill>
-                  <a:srgbClr val="8B949E"/>
+                  <a:srgbClr val="8A8078"/>
                 </a:solidFill>
                 <a:latin typeface="Consolas" pitchFamily="34" charset="0"/>
                 <a:ea typeface="Consolas" pitchFamily="34" charset="-122"/>
@@ -6819,7 +6819,7 @@
           <a:noFill/>
           <a:ln w="15240">
             <a:solidFill>
-              <a:srgbClr val="D29922"/>
+              <a:srgbClr val="B8892C"/>
             </a:solidFill>
             <a:prstDash val="dash"/>
           </a:ln>
@@ -6842,7 +6842,7 @@
           <a:noFill/>
           <a:ln w="15240">
             <a:solidFill>
-              <a:srgbClr val="D29922"/>
+              <a:srgbClr val="B8892C"/>
             </a:solidFill>
             <a:prstDash val="dash"/>
           </a:ln>
@@ -6865,7 +6865,7 @@
           <a:noFill/>
           <a:ln w="15240">
             <a:solidFill>
-              <a:srgbClr val="D29922"/>
+              <a:srgbClr val="B8892C"/>
             </a:solidFill>
             <a:prstDash val="dash"/>
             <a:tailEnd type="arrow"/>
@@ -6899,7 +6899,7 @@
             <a:r>
               <a:rPr lang="en-US" sz="750" dirty="0">
                 <a:solidFill>
-                  <a:srgbClr val="D29922"/>
+                  <a:srgbClr val="B8892C"/>
                 </a:solidFill>
                 <a:latin typeface="Consolas" pitchFamily="34" charset="0"/>
                 <a:ea typeface="Consolas" pitchFamily="34" charset="-122"/>
@@ -6928,11 +6928,11 @@
             </a:avLst>
           </a:prstGeom>
           <a:solidFill>
-            <a:srgbClr val="0A1929"/>
+            <a:srgbClr val="EAF0F7"/>
           </a:solidFill>
           <a:ln w="9525">
             <a:solidFill>
-              <a:srgbClr val="58A6FF"/>
+              <a:srgbClr val="4A7FB5"/>
             </a:solidFill>
             <a:prstDash val="solid"/>
           </a:ln>
@@ -6965,13 +6965,13 @@
             <a:r>
               <a:rPr lang="en-US" sz="1000" i="1" dirty="0">
                 <a:solidFill>
-                  <a:srgbClr val="8B949E"/>
-                </a:solidFill>
-                <a:latin typeface="Calibri" pitchFamily="34" charset="0"/>
-                <a:ea typeface="Calibri" pitchFamily="34" charset="-122"/>
-                <a:cs typeface="Calibri" pitchFamily="34" charset="-120"/>
-              </a:rPr>
-              <a:t>💡  GitOps 讓基礎設施變成 Code — 每次 Prod 變更都有 git commit 記錄，可審計可回滾</a:t>
+                  <a:srgbClr val="8A8078"/>
+                </a:solidFill>
+                <a:latin typeface="Calibri" pitchFamily="34" charset="0"/>
+                <a:ea typeface="Calibri" pitchFamily="34" charset="-122"/>
+                <a:cs typeface="Calibri" pitchFamily="34" charset="-120"/>
+              </a:rPr>
+              <a:t>💡  GitOps turns infrastructure into code — every Prod change has a git commit record, auditable and rollbackable</a:t>
             </a:r>
             <a:endParaRPr lang="en-US" sz="1000" dirty="0"/>
           </a:p>
@@ -6991,7 +6991,7 @@
     <p:bg>
       <p:bgPr>
         <a:solidFill>
-          <a:srgbClr val="0D1117"/>
+          <a:srgbClr val="FFFDF8"/>
         </a:solidFill>
       </p:bgPr>
     </p:bg>
@@ -7024,11 +7024,11 @@
             <a:avLst/>
           </a:prstGeom>
           <a:solidFill>
-            <a:srgbClr val="161B22"/>
+            <a:srgbClr val="F5F1EB"/>
           </a:solidFill>
           <a:ln w="6350">
             <a:solidFill>
-              <a:srgbClr val="30363D"/>
+              <a:srgbClr val="D6CCBF"/>
             </a:solidFill>
             <a:prstDash val="solid"/>
           </a:ln>
@@ -7049,11 +7049,11 @@
             <a:avLst/>
           </a:prstGeom>
           <a:solidFill>
-            <a:srgbClr val="D29922"/>
+            <a:srgbClr val="B8892C"/>
           </a:solidFill>
           <a:ln w="12700">
             <a:solidFill>
-              <a:srgbClr val="D29922"/>
+              <a:srgbClr val="B8892C"/>
             </a:solidFill>
             <a:prstDash val="solid"/>
           </a:ln>
@@ -7086,13 +7086,13 @@
             <a:r>
               <a:rPr lang="en-US" sz="1600" b="1" dirty="0">
                 <a:solidFill>
-                  <a:srgbClr val="E6EDF3"/>
-                </a:solidFill>
-                <a:latin typeface="Calibri" pitchFamily="34" charset="0"/>
-                <a:ea typeface="Calibri" pitchFamily="34" charset="-122"/>
-                <a:cs typeface="Calibri" pitchFamily="34" charset="-120"/>
-              </a:rPr>
-              <a:t>Feature Flags：從部署中解放功能發布</a:t>
+                  <a:srgbClr val="2D2926"/>
+                </a:solidFill>
+                <a:latin typeface="Calibri" pitchFamily="34" charset="0"/>
+                <a:ea typeface="Calibri" pitchFamily="34" charset="-122"/>
+                <a:cs typeface="Calibri" pitchFamily="34" charset="-120"/>
+              </a:rPr>
+              <a:t>Feature Flags: Decouple Deployment from Feature Release</a:t>
             </a:r>
             <a:endParaRPr lang="en-US" sz="1600" dirty="0"/>
           </a:p>
@@ -7125,13 +7125,13 @@
             <a:r>
               <a:rPr lang="en-US" sz="850" dirty="0">
                 <a:solidFill>
-                  <a:srgbClr val="8B949E"/>
-                </a:solidFill>
-                <a:latin typeface="Calibri" pitchFamily="34" charset="0"/>
-                <a:ea typeface="Calibri" pitchFamily="34" charset="-122"/>
-                <a:cs typeface="Calibri" pitchFamily="34" charset="-120"/>
-              </a:rPr>
-              <a:t>PART 5  ·  38 / 50</a:t>
+                  <a:srgbClr val="8A8078"/>
+                </a:solidFill>
+                <a:latin typeface="Calibri" pitchFamily="34" charset="0"/>
+                <a:ea typeface="Calibri" pitchFamily="34" charset="-122"/>
+                <a:cs typeface="Calibri" pitchFamily="34" charset="-120"/>
+              </a:rPr>
+              <a:t>PART 5</a:t>
             </a:r>
             <a:endParaRPr lang="en-US" sz="850" dirty="0"/>
           </a:p>
@@ -7154,11 +7154,11 @@
             </a:avLst>
           </a:prstGeom>
           <a:solidFill>
-            <a:srgbClr val="2A0F0F"/>
+            <a:srgbClr val="F8ECEC"/>
           </a:solidFill>
           <a:ln w="12700">
             <a:solidFill>
-              <a:srgbClr val="F85149"/>
+              <a:srgbClr val="C4605B"/>
             </a:solidFill>
             <a:prstDash val="solid"/>
           </a:ln>
@@ -7191,13 +7191,13 @@
             <a:r>
               <a:rPr lang="en-US" sz="1200" b="1" dirty="0">
                 <a:solidFill>
-                  <a:srgbClr val="F85149"/>
-                </a:solidFill>
-                <a:latin typeface="Calibri" pitchFamily="34" charset="0"/>
-                <a:ea typeface="Calibri" pitchFamily="34" charset="-122"/>
-                <a:cs typeface="Calibri" pitchFamily="34" charset="-120"/>
-              </a:rPr>
-              <a:t>❌ 傳統做法：部署 = 上線</a:t>
+                  <a:srgbClr val="C4605B"/>
+                </a:solidFill>
+                <a:latin typeface="Calibri" pitchFamily="34" charset="0"/>
+                <a:ea typeface="Calibri" pitchFamily="34" charset="-122"/>
+                <a:cs typeface="Calibri" pitchFamily="34" charset="-120"/>
+              </a:rPr>
+              <a:t>❌ Traditional: Deploy = Release</a:t>
             </a:r>
             <a:endParaRPr lang="en-US" sz="1200" dirty="0"/>
           </a:p>
@@ -7220,11 +7220,11 @@
             </a:avLst>
           </a:prstGeom>
           <a:solidFill>
-            <a:srgbClr val="161B22"/>
+            <a:srgbClr val="F5F1EB"/>
           </a:solidFill>
           <a:ln w="12700">
             <a:solidFill>
-              <a:srgbClr val="F85149"/>
+              <a:srgbClr val="C4605B"/>
             </a:solidFill>
             <a:prstDash val="solid"/>
           </a:ln>
@@ -7257,13 +7257,13 @@
             <a:r>
               <a:rPr lang="en-US" sz="1000" dirty="0">
                 <a:solidFill>
-                  <a:srgbClr val="E6EDF3"/>
-                </a:solidFill>
-                <a:latin typeface="Calibri" pitchFamily="34" charset="0"/>
-                <a:ea typeface="Calibri" pitchFamily="34" charset="-122"/>
-                <a:cs typeface="Calibri" pitchFamily="34" charset="-120"/>
-              </a:rPr>
-              <a:t>😱 每次部署都影響所有用戶</a:t>
+                  <a:srgbClr val="2D2926"/>
+                </a:solidFill>
+                <a:latin typeface="Calibri" pitchFamily="34" charset="0"/>
+                <a:ea typeface="Calibri" pitchFamily="34" charset="-122"/>
+                <a:cs typeface="Calibri" pitchFamily="34" charset="-120"/>
+              </a:rPr>
+              <a:t>😱 Every deploy impacts all users</a:t>
             </a:r>
             <a:endParaRPr lang="en-US" sz="1000" dirty="0"/>
           </a:p>
@@ -7286,11 +7286,11 @@
             </a:avLst>
           </a:prstGeom>
           <a:solidFill>
-            <a:srgbClr val="161B22"/>
+            <a:srgbClr val="F5F1EB"/>
           </a:solidFill>
           <a:ln w="12700">
             <a:solidFill>
-              <a:srgbClr val="F85149"/>
+              <a:srgbClr val="C4605B"/>
             </a:solidFill>
             <a:prstDash val="solid"/>
           </a:ln>
@@ -7323,13 +7323,13 @@
             <a:r>
               <a:rPr lang="en-US" sz="1000" dirty="0">
                 <a:solidFill>
-                  <a:srgbClr val="E6EDF3"/>
-                </a:solidFill>
-                <a:latin typeface="Calibri" pitchFamily="34" charset="0"/>
-                <a:ea typeface="Calibri" pitchFamily="34" charset="-122"/>
-                <a:cs typeface="Calibri" pitchFamily="34" charset="-120"/>
-              </a:rPr>
-              <a:t>⏱️ 發現問題只能全量回滾</a:t>
+                  <a:srgbClr val="2D2926"/>
+                </a:solidFill>
+                <a:latin typeface="Calibri" pitchFamily="34" charset="0"/>
+                <a:ea typeface="Calibri" pitchFamily="34" charset="-122"/>
+                <a:cs typeface="Calibri" pitchFamily="34" charset="-120"/>
+              </a:rPr>
+              <a:t>⏱️ Issues require a full rollback</a:t>
             </a:r>
             <a:endParaRPr lang="en-US" sz="1000" dirty="0"/>
           </a:p>
@@ -7352,11 +7352,11 @@
             </a:avLst>
           </a:prstGeom>
           <a:solidFill>
-            <a:srgbClr val="161B22"/>
+            <a:srgbClr val="F5F1EB"/>
           </a:solidFill>
           <a:ln w="12700">
             <a:solidFill>
-              <a:srgbClr val="D29922"/>
+              <a:srgbClr val="B8892C"/>
             </a:solidFill>
             <a:prstDash val="solid"/>
           </a:ln>
@@ -7389,13 +7389,13 @@
             <a:r>
               <a:rPr lang="en-US" sz="1000" dirty="0">
                 <a:solidFill>
-                  <a:srgbClr val="E6EDF3"/>
-                </a:solidFill>
-                <a:latin typeface="Calibri" pitchFamily="34" charset="0"/>
-                <a:ea typeface="Calibri" pitchFamily="34" charset="-122"/>
-                <a:cs typeface="Calibri" pitchFamily="34" charset="-120"/>
-              </a:rPr>
-              <a:t>🚫 無法針對特定用戶測試</a:t>
+                  <a:srgbClr val="2D2926"/>
+                </a:solidFill>
+                <a:latin typeface="Calibri" pitchFamily="34" charset="0"/>
+                <a:ea typeface="Calibri" pitchFamily="34" charset="-122"/>
+                <a:cs typeface="Calibri" pitchFamily="34" charset="-120"/>
+              </a:rPr>
+              <a:t>🚫 Cannot test with specific users</a:t>
             </a:r>
             <a:endParaRPr lang="en-US" sz="1000" dirty="0"/>
           </a:p>
@@ -7418,7 +7418,7 @@
           <a:noFill/>
           <a:ln w="9525">
             <a:solidFill>
-              <a:srgbClr val="30363D"/>
+              <a:srgbClr val="D6CCBF"/>
             </a:solidFill>
             <a:prstDash val="solid"/>
           </a:ln>
@@ -7441,11 +7441,11 @@
             </a:avLst>
           </a:prstGeom>
           <a:solidFill>
-            <a:srgbClr val="0F2A1A"/>
+            <a:srgbClr val="E5F0E9"/>
           </a:solidFill>
           <a:ln w="12700">
             <a:solidFill>
-              <a:srgbClr val="3FB950"/>
+              <a:srgbClr val="4A9968"/>
             </a:solidFill>
             <a:prstDash val="solid"/>
           </a:ln>
@@ -7478,13 +7478,13 @@
             <a:r>
               <a:rPr lang="en-US" sz="1200" b="1" dirty="0">
                 <a:solidFill>
-                  <a:srgbClr val="3FB950"/>
-                </a:solidFill>
-                <a:latin typeface="Calibri" pitchFamily="34" charset="0"/>
-                <a:ea typeface="Calibri" pitchFamily="34" charset="-122"/>
-                <a:cs typeface="Calibri" pitchFamily="34" charset="-120"/>
-              </a:rPr>
-              <a:t>✅ Feature Flags：部署 ≠ 上線</a:t>
+                  <a:srgbClr val="4A9968"/>
+                </a:solidFill>
+                <a:latin typeface="Calibri" pitchFamily="34" charset="0"/>
+                <a:ea typeface="Calibri" pitchFamily="34" charset="-122"/>
+                <a:cs typeface="Calibri" pitchFamily="34" charset="-120"/>
+              </a:rPr>
+              <a:t>✅ Feature Flags: Deploy ≠ Release</a:t>
             </a:r>
             <a:endParaRPr lang="en-US" sz="1200" dirty="0"/>
           </a:p>
@@ -7507,18 +7507,18 @@
             </a:avLst>
           </a:prstGeom>
           <a:solidFill>
-            <a:srgbClr val="0D1117"/>
+            <a:srgbClr val="2D2926"/>
           </a:solidFill>
           <a:ln w="12700">
             <a:solidFill>
-              <a:srgbClr val="30363D"/>
+              <a:srgbClr val="D6CCBF"/>
             </a:solidFill>
             <a:prstDash val="solid"/>
           </a:ln>
           <a:effectLst>
             <a:outerShdw sx="100000" sy="100000" kx="0" ky="0" algn="bl" rotWithShape="0" blurRad="127000" dist="50800" dir="2700000">
-              <a:srgbClr val="000000">
-                <a:alpha val="50000"/>
+              <a:srgbClr val="9E9488">
+                <a:alpha val="15000"/>
               </a:srgbClr>
             </a:outerShdw>
           </a:effectLst>
@@ -7541,11 +7541,11 @@
             </a:avLst>
           </a:prstGeom>
           <a:solidFill>
-            <a:srgbClr val="1C2128"/>
+            <a:srgbClr val="ECE6DD"/>
           </a:solidFill>
           <a:ln w="6350">
             <a:solidFill>
-              <a:srgbClr val="30363D"/>
+              <a:srgbClr val="D6CCBF"/>
             </a:solidFill>
             <a:prstDash val="solid"/>
           </a:ln>
@@ -7578,7 +7578,7 @@
             <a:r>
               <a:rPr lang="en-US" sz="800" b="1" dirty="0">
                 <a:solidFill>
-                  <a:srgbClr val="8B949E"/>
+                  <a:srgbClr val="8A8078"/>
                 </a:solidFill>
                 <a:latin typeface="Consolas" pitchFamily="34" charset="0"/>
                 <a:ea typeface="Consolas" pitchFamily="34" charset="-122"/>
@@ -7620,13 +7620,13 @@
             <a:r>
               <a:rPr lang="en-US" sz="950" dirty="0">
                 <a:solidFill>
-                  <a:srgbClr val="E6EDF3"/>
+                  <a:srgbClr val="2D2926"/>
                 </a:solidFill>
                 <a:latin typeface="Consolas" pitchFamily="34" charset="0"/>
                 <a:ea typeface="Consolas" pitchFamily="34" charset="-122"/>
                 <a:cs typeface="Consolas" pitchFamily="34" charset="-120"/>
               </a:rPr>
-              <a:t># Feature Flag 控制</a:t>
+              <a:t># Feature Flag control</a:t>
             </a:r>
             <a:endParaRPr lang="en-US" sz="950" dirty="0"/>
           </a:p>
@@ -7640,7 +7640,7 @@
             <a:r>
               <a:rPr lang="en-US" sz="950" dirty="0">
                 <a:solidFill>
-                  <a:srgbClr val="E6EDF3"/>
+                  <a:srgbClr val="2D2926"/>
                 </a:solidFill>
                 <a:latin typeface="Consolas" pitchFamily="34" charset="0"/>
                 <a:ea typeface="Consolas" pitchFamily="34" charset="-122"/>
@@ -7660,7 +7660,7 @@
             <a:r>
               <a:rPr lang="en-US" sz="950" dirty="0">
                 <a:solidFill>
-                  <a:srgbClr val="E6EDF3"/>
+                  <a:srgbClr val="2D2926"/>
                 </a:solidFill>
                 <a:latin typeface="Consolas" pitchFamily="34" charset="0"/>
                 <a:ea typeface="Consolas" pitchFamily="34" charset="-122"/>
@@ -7680,7 +7680,7 @@
             <a:r>
               <a:rPr lang="en-US" sz="950" dirty="0">
                 <a:solidFill>
-                  <a:srgbClr val="E6EDF3"/>
+                  <a:srgbClr val="2D2926"/>
                 </a:solidFill>
                 <a:latin typeface="Consolas" pitchFamily="34" charset="0"/>
                 <a:ea typeface="Consolas" pitchFamily="34" charset="-122"/>
@@ -7700,7 +7700,7 @@
             <a:r>
               <a:rPr lang="en-US" sz="950" dirty="0">
                 <a:solidFill>
-                  <a:srgbClr val="E6EDF3"/>
+                  <a:srgbClr val="2D2926"/>
                 </a:solidFill>
                 <a:latin typeface="Consolas" pitchFamily="34" charset="0"/>
                 <a:ea typeface="Consolas" pitchFamily="34" charset="-122"/>
@@ -7729,11 +7729,11 @@
             </a:avLst>
           </a:prstGeom>
           <a:solidFill>
-            <a:srgbClr val="161B22"/>
+            <a:srgbClr val="F5F1EB"/>
           </a:solidFill>
           <a:ln w="12700">
             <a:solidFill>
-              <a:srgbClr val="D29922"/>
+              <a:srgbClr val="B8892C"/>
             </a:solidFill>
             <a:prstDash val="solid"/>
           </a:ln>
@@ -7766,7 +7766,7 @@
             <a:r>
               <a:rPr lang="en-US" sz="950" b="1" dirty="0">
                 <a:solidFill>
-                  <a:srgbClr val="D29922"/>
+                  <a:srgbClr val="B8892C"/>
                 </a:solidFill>
                 <a:latin typeface="Calibri" pitchFamily="34" charset="0"/>
                 <a:ea typeface="Calibri" pitchFamily="34" charset="-122"/>
@@ -7795,11 +7795,11 @@
             </a:avLst>
           </a:prstGeom>
           <a:solidFill>
-            <a:srgbClr val="161B22"/>
+            <a:srgbClr val="F5F1EB"/>
           </a:solidFill>
           <a:ln w="12700">
             <a:solidFill>
-              <a:srgbClr val="D29922"/>
+              <a:srgbClr val="B8892C"/>
             </a:solidFill>
             <a:prstDash val="solid"/>
           </a:ln>
@@ -7832,7 +7832,7 @@
             <a:r>
               <a:rPr lang="en-US" sz="950" b="1" dirty="0">
                 <a:solidFill>
-                  <a:srgbClr val="D29922"/>
+                  <a:srgbClr val="B8892C"/>
                 </a:solidFill>
                 <a:latin typeface="Calibri" pitchFamily="34" charset="0"/>
                 <a:ea typeface="Calibri" pitchFamily="34" charset="-122"/>
@@ -7861,11 +7861,11 @@
             </a:avLst>
           </a:prstGeom>
           <a:solidFill>
-            <a:srgbClr val="161B22"/>
+            <a:srgbClr val="F5F1EB"/>
           </a:solidFill>
           <a:ln w="12700">
             <a:solidFill>
-              <a:srgbClr val="D29922"/>
+              <a:srgbClr val="B8892C"/>
             </a:solidFill>
             <a:prstDash val="solid"/>
           </a:ln>
@@ -7898,7 +7898,7 @@
             <a:r>
               <a:rPr lang="en-US" sz="950" b="1" dirty="0">
                 <a:solidFill>
-                  <a:srgbClr val="D29922"/>
+                  <a:srgbClr val="B8892C"/>
                 </a:solidFill>
                 <a:latin typeface="Calibri" pitchFamily="34" charset="0"/>
                 <a:ea typeface="Calibri" pitchFamily="34" charset="-122"/>
@@ -7927,11 +7927,11 @@
             </a:avLst>
           </a:prstGeom>
           <a:solidFill>
-            <a:srgbClr val="161B22"/>
+            <a:srgbClr val="F5F1EB"/>
           </a:solidFill>
           <a:ln w="15240">
             <a:solidFill>
-              <a:srgbClr val="D29922"/>
+              <a:srgbClr val="B8892C"/>
             </a:solidFill>
             <a:prstDash val="solid"/>
           </a:ln>
@@ -7964,13 +7964,13 @@
             <a:r>
               <a:rPr lang="en-US" sz="1200" b="1" dirty="0">
                 <a:solidFill>
-                  <a:srgbClr val="58A6FF"/>
-                </a:solidFill>
-                <a:latin typeface="Calibri" pitchFamily="34" charset="0"/>
-                <a:ea typeface="Calibri" pitchFamily="34" charset="-122"/>
-                <a:cs typeface="Calibri" pitchFamily="34" charset="-120"/>
-              </a:rPr>
-              <a:t>🚀 部署 (Deploy)</a:t>
+                  <a:srgbClr val="4A7FB5"/>
+                </a:solidFill>
+                <a:latin typeface="Calibri" pitchFamily="34" charset="0"/>
+                <a:ea typeface="Calibri" pitchFamily="34" charset="-122"/>
+                <a:cs typeface="Calibri" pitchFamily="34" charset="-120"/>
+              </a:rPr>
+              <a:t>🚀 Deploy</a:t>
             </a:r>
             <a:endParaRPr lang="en-US" sz="1200" dirty="0"/>
           </a:p>
@@ -8003,13 +8003,13 @@
             <a:r>
               <a:rPr lang="en-US" sz="950" dirty="0">
                 <a:solidFill>
-                  <a:srgbClr val="8B949E"/>
-                </a:solidFill>
-                <a:latin typeface="Calibri" pitchFamily="34" charset="0"/>
-                <a:ea typeface="Calibri" pitchFamily="34" charset="-122"/>
-                <a:cs typeface="Calibri" pitchFamily="34" charset="-120"/>
-              </a:rPr>
-              <a:t>把 Code 放到 Prod Server — 但 Flag = OFF，用戶看不到</a:t>
+                  <a:srgbClr val="8A8078"/>
+                </a:solidFill>
+                <a:latin typeface="Calibri" pitchFamily="34" charset="0"/>
+                <a:ea typeface="Calibri" pitchFamily="34" charset="-122"/>
+                <a:cs typeface="Calibri" pitchFamily="34" charset="-120"/>
+              </a:rPr>
+              <a:t>Code is on Prod server — but Flag = OFF, users can't see it</a:t>
             </a:r>
             <a:endParaRPr lang="en-US" sz="950" dirty="0"/>
           </a:p>
@@ -8032,7 +8032,7 @@
           <a:noFill/>
           <a:ln w="9525">
             <a:solidFill>
-              <a:srgbClr val="30363D"/>
+              <a:srgbClr val="D6CCBF"/>
             </a:solidFill>
             <a:prstDash val="solid"/>
           </a:ln>
@@ -8065,13 +8065,13 @@
             <a:r>
               <a:rPr lang="en-US" sz="1200" b="1" dirty="0">
                 <a:solidFill>
-                  <a:srgbClr val="3FB950"/>
-                </a:solidFill>
-                <a:latin typeface="Calibri" pitchFamily="34" charset="0"/>
-                <a:ea typeface="Calibri" pitchFamily="34" charset="-122"/>
-                <a:cs typeface="Calibri" pitchFamily="34" charset="-120"/>
-              </a:rPr>
-              <a:t>🎉 發布 (Release)</a:t>
+                  <a:srgbClr val="4A9968"/>
+                </a:solidFill>
+                <a:latin typeface="Calibri" pitchFamily="34" charset="0"/>
+                <a:ea typeface="Calibri" pitchFamily="34" charset="-122"/>
+                <a:cs typeface="Calibri" pitchFamily="34" charset="-120"/>
+              </a:rPr>
+              <a:t>🎉 Release</a:t>
             </a:r>
             <a:endParaRPr lang="en-US" sz="1200" dirty="0"/>
           </a:p>
@@ -8104,13 +8104,13 @@
             <a:r>
               <a:rPr lang="en-US" sz="950" dirty="0">
                 <a:solidFill>
-                  <a:srgbClr val="8B949E"/>
-                </a:solidFill>
-                <a:latin typeface="Calibri" pitchFamily="34" charset="0"/>
-                <a:ea typeface="Calibri" pitchFamily="34" charset="-122"/>
-                <a:cs typeface="Calibri" pitchFamily="34" charset="-120"/>
-              </a:rPr>
-              <a:t>把 Flag 切到 ON — 功能對用戶可見 (隨時可關)</a:t>
+                  <a:srgbClr val="8A8078"/>
+                </a:solidFill>
+                <a:latin typeface="Calibri" pitchFamily="34" charset="0"/>
+                <a:ea typeface="Calibri" pitchFamily="34" charset="-122"/>
+                <a:cs typeface="Calibri" pitchFamily="34" charset="-120"/>
+              </a:rPr>
+              <a:t>Flip the Flag to ON — feature visible to users (can turn off anytime)</a:t>
             </a:r>
             <a:endParaRPr lang="en-US" sz="950" dirty="0"/>
           </a:p>
@@ -8133,11 +8133,11 @@
             </a:avLst>
           </a:prstGeom>
           <a:solidFill>
-            <a:srgbClr val="0A1929"/>
+            <a:srgbClr val="EAF0F7"/>
           </a:solidFill>
           <a:ln w="9525">
             <a:solidFill>
-              <a:srgbClr val="58A6FF"/>
+              <a:srgbClr val="4A7FB5"/>
             </a:solidFill>
             <a:prstDash val="solid"/>
           </a:ln>
@@ -8170,13 +8170,13 @@
             <a:r>
               <a:rPr lang="en-US" sz="1000" i="1" dirty="0">
                 <a:solidFill>
-                  <a:srgbClr val="8B949E"/>
-                </a:solidFill>
-                <a:latin typeface="Calibri" pitchFamily="34" charset="0"/>
-                <a:ea typeface="Calibri" pitchFamily="34" charset="-122"/>
-                <a:cs typeface="Calibri" pitchFamily="34" charset="-120"/>
-              </a:rPr>
-              <a:t>💡  Feature Flag 讓你做到 Continuous Deployment — 每天部署數十次，功能上線時機由 PM 決定</a:t>
+                  <a:srgbClr val="8A8078"/>
+                </a:solidFill>
+                <a:latin typeface="Calibri" pitchFamily="34" charset="0"/>
+                <a:ea typeface="Calibri" pitchFamily="34" charset="-122"/>
+                <a:cs typeface="Calibri" pitchFamily="34" charset="-120"/>
+              </a:rPr>
+              <a:t>💡  Feature Flags enable Continuous Deployment — deploy dozens of times a day, let PM decide when to release</a:t>
             </a:r>
             <a:endParaRPr lang="en-US" sz="1000" dirty="0"/>
           </a:p>
@@ -8196,7 +8196,7 @@
     <p:bg>
       <p:bgPr>
         <a:solidFill>
-          <a:srgbClr val="0D1117"/>
+          <a:srgbClr val="FFFDF8"/>
         </a:solidFill>
       </p:bgPr>
     </p:bg>
@@ -8229,11 +8229,11 @@
             <a:avLst/>
           </a:prstGeom>
           <a:solidFill>
-            <a:srgbClr val="161B22"/>
+            <a:srgbClr val="F5F1EB"/>
           </a:solidFill>
           <a:ln w="6350">
             <a:solidFill>
-              <a:srgbClr val="30363D"/>
+              <a:srgbClr val="D6CCBF"/>
             </a:solidFill>
             <a:prstDash val="solid"/>
           </a:ln>
@@ -8254,11 +8254,11 @@
             <a:avLst/>
           </a:prstGeom>
           <a:solidFill>
-            <a:srgbClr val="58A6FF"/>
+            <a:srgbClr val="4A7FB5"/>
           </a:solidFill>
           <a:ln w="12700">
             <a:solidFill>
-              <a:srgbClr val="58A6FF"/>
+              <a:srgbClr val="4A7FB5"/>
             </a:solidFill>
             <a:prstDash val="solid"/>
           </a:ln>
@@ -8291,13 +8291,13 @@
             <a:r>
               <a:rPr lang="en-US" sz="1600" b="1" dirty="0">
                 <a:solidFill>
-                  <a:srgbClr val="E6EDF3"/>
-                </a:solidFill>
-                <a:latin typeface="Calibri" pitchFamily="34" charset="0"/>
-                <a:ea typeface="Calibri" pitchFamily="34" charset="-122"/>
-                <a:cs typeface="Calibri" pitchFamily="34" charset="-120"/>
-              </a:rPr>
-              <a:t>部署策略：Blue/Green vs Canary Release</a:t>
+                  <a:srgbClr val="2D2926"/>
+                </a:solidFill>
+                <a:latin typeface="Calibri" pitchFamily="34" charset="0"/>
+                <a:ea typeface="Calibri" pitchFamily="34" charset="-122"/>
+                <a:cs typeface="Calibri" pitchFamily="34" charset="-120"/>
+              </a:rPr>
+              <a:t>Deployment Strategies: Blue/Green vs Canary Release</a:t>
             </a:r>
             <a:endParaRPr lang="en-US" sz="1600" dirty="0"/>
           </a:p>
@@ -8330,13 +8330,13 @@
             <a:r>
               <a:rPr lang="en-US" sz="850" dirty="0">
                 <a:solidFill>
-                  <a:srgbClr val="8B949E"/>
-                </a:solidFill>
-                <a:latin typeface="Calibri" pitchFamily="34" charset="0"/>
-                <a:ea typeface="Calibri" pitchFamily="34" charset="-122"/>
-                <a:cs typeface="Calibri" pitchFamily="34" charset="-120"/>
-              </a:rPr>
-              <a:t>PART 5  ·  39 / 50</a:t>
+                  <a:srgbClr val="8A8078"/>
+                </a:solidFill>
+                <a:latin typeface="Calibri" pitchFamily="34" charset="0"/>
+                <a:ea typeface="Calibri" pitchFamily="34" charset="-122"/>
+                <a:cs typeface="Calibri" pitchFamily="34" charset="-120"/>
+              </a:rPr>
+              <a:t>PART 5</a:t>
             </a:r>
             <a:endParaRPr lang="en-US" sz="850" dirty="0"/>
           </a:p>
@@ -8369,13 +8369,13 @@
             <a:r>
               <a:rPr lang="en-US" sz="1300" b="1" dirty="0">
                 <a:solidFill>
-                  <a:srgbClr val="58A6FF"/>
-                </a:solidFill>
-                <a:latin typeface="Calibri" pitchFamily="34" charset="0"/>
-                <a:ea typeface="Calibri" pitchFamily="34" charset="-122"/>
-                <a:cs typeface="Calibri" pitchFamily="34" charset="-120"/>
-              </a:rPr>
-              <a:t>🔵🟢 Blue/Green 部署</a:t>
+                  <a:srgbClr val="4A7FB5"/>
+                </a:solidFill>
+                <a:latin typeface="Calibri" pitchFamily="34" charset="0"/>
+                <a:ea typeface="Calibri" pitchFamily="34" charset="-122"/>
+                <a:cs typeface="Calibri" pitchFamily="34" charset="-120"/>
+              </a:rPr>
+              <a:t>🔵🟢 Blue/Green Deployment</a:t>
             </a:r>
             <a:endParaRPr lang="en-US" sz="1300" dirty="0"/>
           </a:p>
@@ -8408,13 +8408,13 @@
             <a:r>
               <a:rPr lang="en-US" sz="850" dirty="0">
                 <a:solidFill>
-                  <a:srgbClr val="8B949E"/>
-                </a:solidFill>
-                <a:latin typeface="Calibri" pitchFamily="34" charset="0"/>
-                <a:ea typeface="Calibri" pitchFamily="34" charset="-122"/>
-                <a:cs typeface="Calibri" pitchFamily="34" charset="-120"/>
-              </a:rPr>
-              <a:t>Step 1：部署新版本到 Green</a:t>
+                  <a:srgbClr val="8A8078"/>
+                </a:solidFill>
+                <a:latin typeface="Calibri" pitchFamily="34" charset="0"/>
+                <a:ea typeface="Calibri" pitchFamily="34" charset="-122"/>
+                <a:cs typeface="Calibri" pitchFamily="34" charset="-120"/>
+              </a:rPr>
+              <a:t>Step 1: Deploy new version to Green</a:t>
             </a:r>
             <a:endParaRPr lang="en-US" sz="850" dirty="0"/>
           </a:p>
@@ -8437,11 +8437,11 @@
             </a:avLst>
           </a:prstGeom>
           <a:solidFill>
-            <a:srgbClr val="0F2A1A"/>
+            <a:srgbClr val="E5F0E9"/>
           </a:solidFill>
           <a:ln w="15240">
             <a:solidFill>
-              <a:srgbClr val="3FB950"/>
+              <a:srgbClr val="4A9968"/>
             </a:solidFill>
             <a:prstDash val="solid"/>
           </a:ln>
@@ -8474,13 +8474,13 @@
             <a:r>
               <a:rPr lang="en-US" sz="900" b="1" dirty="0">
                 <a:solidFill>
-                  <a:srgbClr val="3FB950"/>
-                </a:solidFill>
-                <a:latin typeface="Calibri" pitchFamily="34" charset="0"/>
-                <a:ea typeface="Calibri" pitchFamily="34" charset="-122"/>
-                <a:cs typeface="Calibri" pitchFamily="34" charset="-120"/>
-              </a:rPr>
-              <a:t>🔵 Blue (v1) — 100% 流量</a:t>
+                  <a:srgbClr val="4A9968"/>
+                </a:solidFill>
+                <a:latin typeface="Calibri" pitchFamily="34" charset="0"/>
+                <a:ea typeface="Calibri" pitchFamily="34" charset="-122"/>
+                <a:cs typeface="Calibri" pitchFamily="34" charset="-120"/>
+              </a:rPr>
+              <a:t>🔵 Blue (v1) — 100% Traffic</a:t>
             </a:r>
             <a:endParaRPr lang="en-US" sz="900" dirty="0"/>
           </a:p>
@@ -8503,11 +8503,11 @@
             </a:avLst>
           </a:prstGeom>
           <a:solidFill>
-            <a:srgbClr val="161B22"/>
+            <a:srgbClr val="F5F1EB"/>
           </a:solidFill>
           <a:ln w="12700">
             <a:solidFill>
-              <a:srgbClr val="8B949E"/>
+              <a:srgbClr val="8A8078"/>
             </a:solidFill>
             <a:prstDash val="solid"/>
           </a:ln>
@@ -8540,13 +8540,13 @@
             <a:r>
               <a:rPr lang="en-US" sz="900" dirty="0">
                 <a:solidFill>
-                  <a:srgbClr val="8B949E"/>
-                </a:solidFill>
-                <a:latin typeface="Calibri" pitchFamily="34" charset="0"/>
-                <a:ea typeface="Calibri" pitchFamily="34" charset="-122"/>
-                <a:cs typeface="Calibri" pitchFamily="34" charset="-120"/>
-              </a:rPr>
-              <a:t>🟢 Green (v2) — 0% 流量</a:t>
+                  <a:srgbClr val="8A8078"/>
+                </a:solidFill>
+                <a:latin typeface="Calibri" pitchFamily="34" charset="0"/>
+                <a:ea typeface="Calibri" pitchFamily="34" charset="-122"/>
+                <a:cs typeface="Calibri" pitchFamily="34" charset="-120"/>
+              </a:rPr>
+              <a:t>🟢 Green (v2) — 0% Traffic</a:t>
             </a:r>
             <a:endParaRPr lang="en-US" sz="900" dirty="0"/>
           </a:p>
@@ -8579,13 +8579,13 @@
             <a:r>
               <a:rPr lang="en-US" sz="850" b="1" dirty="0">
                 <a:solidFill>
-                  <a:srgbClr val="58A6FF"/>
-                </a:solidFill>
-                <a:latin typeface="Calibri" pitchFamily="34" charset="0"/>
-                <a:ea typeface="Calibri" pitchFamily="34" charset="-122"/>
-                <a:cs typeface="Calibri" pitchFamily="34" charset="-120"/>
-              </a:rPr>
-              <a:t>Step 2：LB 切換流量至 Green</a:t>
+                  <a:srgbClr val="4A7FB5"/>
+                </a:solidFill>
+                <a:latin typeface="Calibri" pitchFamily="34" charset="0"/>
+                <a:ea typeface="Calibri" pitchFamily="34" charset="-122"/>
+                <a:cs typeface="Calibri" pitchFamily="34" charset="-120"/>
+              </a:rPr>
+              <a:t>Step 2: LB switches traffic to Green</a:t>
             </a:r>
             <a:endParaRPr lang="en-US" sz="850" dirty="0"/>
           </a:p>
@@ -8608,7 +8608,7 @@
           <a:noFill/>
           <a:ln w="19050">
             <a:solidFill>
-              <a:srgbClr val="58A6FF"/>
+              <a:srgbClr val="4A7FB5"/>
             </a:solidFill>
             <a:prstDash val="solid"/>
             <a:tailEnd type="arrow"/>
@@ -8632,11 +8632,11 @@
             </a:avLst>
           </a:prstGeom>
           <a:solidFill>
-            <a:srgbClr val="161B22"/>
+            <a:srgbClr val="F5F1EB"/>
           </a:solidFill>
           <a:ln w="12700">
             <a:solidFill>
-              <a:srgbClr val="8B949E"/>
+              <a:srgbClr val="8A8078"/>
             </a:solidFill>
             <a:prstDash val="solid"/>
           </a:ln>
@@ -8669,7 +8669,7 @@
             <a:r>
               <a:rPr lang="en-US" sz="900" dirty="0">
                 <a:solidFill>
-                  <a:srgbClr val="8B949E"/>
+                  <a:srgbClr val="8A8078"/>
                 </a:solidFill>
                 <a:latin typeface="Calibri" pitchFamily="34" charset="0"/>
                 <a:ea typeface="Calibri" pitchFamily="34" charset="-122"/>
@@ -8698,11 +8698,11 @@
             </a:avLst>
           </a:prstGeom>
           <a:solidFill>
-            <a:srgbClr val="0F2A1A"/>
+            <a:srgbClr val="E5F0E9"/>
           </a:solidFill>
           <a:ln w="15240">
             <a:solidFill>
-              <a:srgbClr val="3FB950"/>
+              <a:srgbClr val="4A9968"/>
             </a:solidFill>
             <a:prstDash val="solid"/>
           </a:ln>
@@ -8735,7 +8735,7 @@
             <a:r>
               <a:rPr lang="en-US" sz="900" b="1" dirty="0">
                 <a:solidFill>
-                  <a:srgbClr val="3FB950"/>
+                  <a:srgbClr val="4A9968"/>
                 </a:solidFill>
                 <a:latin typeface="Calibri" pitchFamily="34" charset="0"/>
                 <a:ea typeface="Calibri" pitchFamily="34" charset="-122"/>
@@ -8774,13 +8774,13 @@
             <a:r>
               <a:rPr lang="en-US" sz="1050" b="1" dirty="0">
                 <a:solidFill>
-                  <a:srgbClr val="3FB950"/>
-                </a:solidFill>
-                <a:latin typeface="Calibri" pitchFamily="34" charset="0"/>
-                <a:ea typeface="Calibri" pitchFamily="34" charset="-122"/>
-                <a:cs typeface="Calibri" pitchFamily="34" charset="-120"/>
-              </a:rPr>
-              <a:t>✅ 零停機時間</a:t>
+                  <a:srgbClr val="4A9968"/>
+                </a:solidFill>
+                <a:latin typeface="Calibri" pitchFamily="34" charset="0"/>
+                <a:ea typeface="Calibri" pitchFamily="34" charset="-122"/>
+                <a:cs typeface="Calibri" pitchFamily="34" charset="-120"/>
+              </a:rPr>
+              <a:t>✅ Zero downtime</a:t>
             </a:r>
             <a:endParaRPr lang="en-US" sz="1050" dirty="0"/>
           </a:p>
@@ -8813,13 +8813,13 @@
             <a:r>
               <a:rPr lang="en-US" sz="1050" b="1" dirty="0">
                 <a:solidFill>
-                  <a:srgbClr val="3FB950"/>
-                </a:solidFill>
-                <a:latin typeface="Calibri" pitchFamily="34" charset="0"/>
-                <a:ea typeface="Calibri" pitchFamily="34" charset="-122"/>
-                <a:cs typeface="Calibri" pitchFamily="34" charset="-120"/>
-              </a:rPr>
-              <a:t>✅ 回滾只需切 LB</a:t>
+                  <a:srgbClr val="4A9968"/>
+                </a:solidFill>
+                <a:latin typeface="Calibri" pitchFamily="34" charset="0"/>
+                <a:ea typeface="Calibri" pitchFamily="34" charset="-122"/>
+                <a:cs typeface="Calibri" pitchFamily="34" charset="-120"/>
+              </a:rPr>
+              <a:t>✅ Rollback by switching LB</a:t>
             </a:r>
             <a:endParaRPr lang="en-US" sz="1050" dirty="0"/>
           </a:p>
@@ -8852,13 +8852,13 @@
             <a:r>
               <a:rPr lang="en-US" sz="1050" dirty="0">
                 <a:solidFill>
-                  <a:srgbClr val="D29922"/>
-                </a:solidFill>
-                <a:latin typeface="Calibri" pitchFamily="34" charset="0"/>
-                <a:ea typeface="Calibri" pitchFamily="34" charset="-122"/>
-                <a:cs typeface="Calibri" pitchFamily="34" charset="-120"/>
-              </a:rPr>
-              <a:t>⚠️ 需要兩套環境 (成本)</a:t>
+                  <a:srgbClr val="B8892C"/>
+                </a:solidFill>
+                <a:latin typeface="Calibri" pitchFamily="34" charset="0"/>
+                <a:ea typeface="Calibri" pitchFamily="34" charset="-122"/>
+                <a:cs typeface="Calibri" pitchFamily="34" charset="-120"/>
+              </a:rPr>
+              <a:t>⚠️ Requires two environments (cost)</a:t>
             </a:r>
             <a:endParaRPr lang="en-US" sz="1050" dirty="0"/>
           </a:p>
@@ -8881,7 +8881,7 @@
           <a:noFill/>
           <a:ln w="9525">
             <a:solidFill>
-              <a:srgbClr val="30363D"/>
+              <a:srgbClr val="D6CCBF"/>
             </a:solidFill>
             <a:prstDash val="solid"/>
           </a:ln>
@@ -8914,7 +8914,7 @@
             <a:r>
               <a:rPr lang="en-US" sz="1300" b="1" dirty="0">
                 <a:solidFill>
-                  <a:srgbClr val="D29922"/>
+                  <a:srgbClr val="B8892C"/>
                 </a:solidFill>
                 <a:latin typeface="Calibri" pitchFamily="34" charset="0"/>
                 <a:ea typeface="Calibri" pitchFamily="34" charset="-122"/>
@@ -8943,11 +8943,11 @@
             </a:avLst>
           </a:prstGeom>
           <a:solidFill>
-            <a:srgbClr val="161B22"/>
+            <a:srgbClr val="F5F1EB"/>
           </a:solidFill>
           <a:ln w="12700">
             <a:solidFill>
-              <a:srgbClr val="6E40C9"/>
+              <a:srgbClr val="8B6AB5"/>
             </a:solidFill>
             <a:prstDash val="solid"/>
           </a:ln>
@@ -9016,7 +9016,7 @@
             <a:r>
               <a:rPr lang="en-US" sz="950" b="1" dirty="0">
                 <a:solidFill>
-                  <a:srgbClr val="E6EDF3"/>
+                  <a:srgbClr val="2D2926"/>
                 </a:solidFill>
                 <a:latin typeface="Calibri" pitchFamily="34" charset="0"/>
                 <a:ea typeface="Calibri" pitchFamily="34" charset="-122"/>
@@ -9045,7 +9045,7 @@
           <a:noFill/>
           <a:ln w="15240">
             <a:solidFill>
-              <a:srgbClr val="8B949E"/>
+              <a:srgbClr val="908880"/>
             </a:solidFill>
             <a:prstDash val="solid"/>
           </a:ln>
@@ -9068,7 +9068,7 @@
           <a:noFill/>
           <a:ln w="15240">
             <a:solidFill>
-              <a:srgbClr val="8B949E"/>
+              <a:srgbClr val="908880"/>
             </a:solidFill>
             <a:prstDash val="solid"/>
             <a:tailEnd type="arrow"/>
@@ -9092,7 +9092,7 @@
           <a:noFill/>
           <a:ln w="15240">
             <a:solidFill>
-              <a:srgbClr val="D29922"/>
+              <a:srgbClr val="B8892C"/>
             </a:solidFill>
             <a:prstDash val="solid"/>
           </a:ln>
@@ -9115,7 +9115,7 @@
           <a:noFill/>
           <a:ln w="15240">
             <a:solidFill>
-              <a:srgbClr val="D29922"/>
+              <a:srgbClr val="B8892C"/>
             </a:solidFill>
             <a:prstDash val="solid"/>
             <a:tailEnd type="arrow"/>
@@ -9139,18 +9139,18 @@
             </a:avLst>
           </a:prstGeom>
           <a:solidFill>
-            <a:srgbClr val="161B22"/>
+            <a:srgbClr val="F5F1EB"/>
           </a:solidFill>
           <a:ln w="19050">
             <a:solidFill>
-              <a:srgbClr val="8B949E"/>
+              <a:srgbClr val="908880"/>
             </a:solidFill>
             <a:prstDash val="solid"/>
           </a:ln>
           <a:effectLst>
             <a:outerShdw sx="100000" sy="100000" kx="0" ky="0" algn="bl" rotWithShape="0" blurRad="76200" dist="25400" dir="2700000">
-              <a:srgbClr val="000000">
-                <a:alpha val="30000"/>
+              <a:srgbClr val="9E9488">
+                <a:alpha val="15000"/>
               </a:srgbClr>
             </a:outerShdw>
           </a:effectLst>
@@ -9219,7 +9219,7 @@
             <a:r>
               <a:rPr lang="en-US" sz="1050" b="1" dirty="0">
                 <a:solidFill>
-                  <a:srgbClr val="E6EDF3"/>
+                  <a:srgbClr val="2D2926"/>
                 </a:solidFill>
                 <a:latin typeface="Calibri" pitchFamily="34" charset="0"/>
                 <a:ea typeface="Calibri" pitchFamily="34" charset="-122"/>
@@ -9258,13 +9258,13 @@
             <a:r>
               <a:rPr lang="en-US" sz="800" dirty="0">
                 <a:solidFill>
-                  <a:srgbClr val="8B949E"/>
+                  <a:srgbClr val="8A8078"/>
                 </a:solidFill>
                 <a:latin typeface="Consolas" pitchFamily="34" charset="0"/>
                 <a:ea typeface="Consolas" pitchFamily="34" charset="-122"/>
                 <a:cs typeface="Consolas" pitchFamily="34" charset="-120"/>
               </a:rPr>
-              <a:t>90% 流量</a:t>
+              <a:t>90% Traffic</a:t>
             </a:r>
             <a:endParaRPr lang="en-US" sz="800" dirty="0"/>
           </a:p>
@@ -9287,18 +9287,18 @@
             </a:avLst>
           </a:prstGeom>
           <a:solidFill>
-            <a:srgbClr val="161B22"/>
+            <a:srgbClr val="F5F1EB"/>
           </a:solidFill>
           <a:ln w="19050">
             <a:solidFill>
-              <a:srgbClr val="D29922"/>
+              <a:srgbClr val="B8892C"/>
             </a:solidFill>
             <a:prstDash val="solid"/>
           </a:ln>
           <a:effectLst>
             <a:outerShdw sx="100000" sy="100000" kx="0" ky="0" algn="bl" rotWithShape="0" blurRad="76200" dist="25400" dir="2700000">
-              <a:srgbClr val="000000">
-                <a:alpha val="30000"/>
+              <a:srgbClr val="9E9488">
+                <a:alpha val="15000"/>
               </a:srgbClr>
             </a:outerShdw>
           </a:effectLst>
@@ -9367,7 +9367,7 @@
             <a:r>
               <a:rPr lang="en-US" sz="1050" b="1" dirty="0">
                 <a:solidFill>
-                  <a:srgbClr val="E6EDF3"/>
+                  <a:srgbClr val="2D2926"/>
                 </a:solidFill>
                 <a:latin typeface="Calibri" pitchFamily="34" charset="0"/>
                 <a:ea typeface="Calibri" pitchFamily="34" charset="-122"/>
@@ -9406,13 +9406,13 @@
             <a:r>
               <a:rPr lang="en-US" sz="800" dirty="0">
                 <a:solidFill>
-                  <a:srgbClr val="8B949E"/>
+                  <a:srgbClr val="8A8078"/>
                 </a:solidFill>
                 <a:latin typeface="Consolas" pitchFamily="34" charset="0"/>
                 <a:ea typeface="Consolas" pitchFamily="34" charset="-122"/>
                 <a:cs typeface="Consolas" pitchFamily="34" charset="-120"/>
               </a:rPr>
-              <a:t>10% 流量 (Canary)</a:t>
+              <a:t>10% Traffic (Canary)</a:t>
             </a:r>
             <a:endParaRPr lang="en-US" sz="800" dirty="0"/>
           </a:p>
@@ -9435,18 +9435,18 @@
             </a:avLst>
           </a:prstGeom>
           <a:solidFill>
-            <a:srgbClr val="161B22"/>
+            <a:srgbClr val="F5F1EB"/>
           </a:solidFill>
           <a:ln w="19050">
             <a:solidFill>
-              <a:srgbClr val="6E40C9"/>
+              <a:srgbClr val="8B6AB5"/>
             </a:solidFill>
             <a:prstDash val="solid"/>
           </a:ln>
           <a:effectLst>
             <a:outerShdw sx="100000" sy="100000" kx="0" ky="0" algn="bl" rotWithShape="0" blurRad="76200" dist="25400" dir="2700000">
-              <a:srgbClr val="000000">
-                <a:alpha val="30000"/>
+              <a:srgbClr val="9E9488">
+                <a:alpha val="15000"/>
               </a:srgbClr>
             </a:outerShdw>
           </a:effectLst>
@@ -9515,7 +9515,7 @@
             <a:r>
               <a:rPr lang="en-US" sz="1050" b="1" dirty="0">
                 <a:solidFill>
-                  <a:srgbClr val="E6EDF3"/>
+                  <a:srgbClr val="2D2926"/>
                 </a:solidFill>
                 <a:latin typeface="Calibri" pitchFamily="34" charset="0"/>
                 <a:ea typeface="Calibri" pitchFamily="34" charset="-122"/>
@@ -9554,7 +9554,7 @@
             <a:r>
               <a:rPr lang="en-US" sz="800" dirty="0">
                 <a:solidFill>
-                  <a:srgbClr val="8B949E"/>
+                  <a:srgbClr val="8A8078"/>
                 </a:solidFill>
                 <a:latin typeface="Consolas" pitchFamily="34" charset="0"/>
                 <a:ea typeface="Consolas" pitchFamily="34" charset="-122"/>
@@ -9571,7 +9571,7 @@
             <a:r>
               <a:rPr lang="en-US" sz="800" dirty="0">
                 <a:solidFill>
-                  <a:srgbClr val="8B949E"/>
+                  <a:srgbClr val="8A8078"/>
                 </a:solidFill>
                 <a:latin typeface="Consolas" pitchFamily="34" charset="0"/>
                 <a:ea typeface="Consolas" pitchFamily="34" charset="-122"/>
@@ -9600,7 +9600,7 @@
           <a:noFill/>
           <a:ln w="19050">
             <a:solidFill>
-              <a:srgbClr val="6E40C9"/>
+              <a:srgbClr val="8B6AB5"/>
             </a:solidFill>
             <a:prstDash val="solid"/>
             <a:tailEnd type="arrow"/>
@@ -9634,13 +9634,13 @@
             <a:r>
               <a:rPr lang="en-US" sz="950" b="1" dirty="0">
                 <a:solidFill>
-                  <a:srgbClr val="3FB950"/>
-                </a:solidFill>
-                <a:latin typeface="Calibri" pitchFamily="34" charset="0"/>
-                <a:ea typeface="Calibri" pitchFamily="34" charset="-122"/>
-                <a:cs typeface="Calibri" pitchFamily="34" charset="-120"/>
-              </a:rPr>
-              <a:t>✅ 自動增加 Canary 流量</a:t>
+                  <a:srgbClr val="4A9968"/>
+                </a:solidFill>
+                <a:latin typeface="Calibri" pitchFamily="34" charset="0"/>
+                <a:ea typeface="Calibri" pitchFamily="34" charset="-122"/>
+                <a:cs typeface="Calibri" pitchFamily="34" charset="-120"/>
+              </a:rPr>
+              <a:t>✅ Auto-increase Canary traffic</a:t>
             </a:r>
             <a:endParaRPr lang="en-US" sz="950" dirty="0"/>
           </a:p>
@@ -9673,13 +9673,13 @@
             <a:r>
               <a:rPr lang="en-US" sz="950" b="1" dirty="0">
                 <a:solidFill>
-                  <a:srgbClr val="F85149"/>
-                </a:solidFill>
-                <a:latin typeface="Calibri" pitchFamily="34" charset="0"/>
-                <a:ea typeface="Calibri" pitchFamily="34" charset="-122"/>
-                <a:cs typeface="Calibri" pitchFamily="34" charset="-120"/>
-              </a:rPr>
-              <a:t>❌ 自動回滾 Canary</a:t>
+                  <a:srgbClr val="C4605B"/>
+                </a:solidFill>
+                <a:latin typeface="Calibri" pitchFamily="34" charset="0"/>
+                <a:ea typeface="Calibri" pitchFamily="34" charset="-122"/>
+                <a:cs typeface="Calibri" pitchFamily="34" charset="-120"/>
+              </a:rPr>
+              <a:t>❌ Auto-rollback Canary</a:t>
             </a:r>
             <a:endParaRPr lang="en-US" sz="950" dirty="0"/>
           </a:p>
@@ -9712,13 +9712,13 @@
             <a:r>
               <a:rPr lang="en-US" sz="1050" b="1" dirty="0">
                 <a:solidFill>
-                  <a:srgbClr val="3FB950"/>
-                </a:solidFill>
-                <a:latin typeface="Calibri" pitchFamily="34" charset="0"/>
-                <a:ea typeface="Calibri" pitchFamily="34" charset="-122"/>
-                <a:cs typeface="Calibri" pitchFamily="34" charset="-120"/>
-              </a:rPr>
-              <a:t>✅ 小範圍驗證新版本</a:t>
+                  <a:srgbClr val="4A9968"/>
+                </a:solidFill>
+                <a:latin typeface="Calibri" pitchFamily="34" charset="0"/>
+                <a:ea typeface="Calibri" pitchFamily="34" charset="-122"/>
+                <a:cs typeface="Calibri" pitchFamily="34" charset="-120"/>
+              </a:rPr>
+              <a:t>✅ Validate new version at small scale</a:t>
             </a:r>
             <a:endParaRPr lang="en-US" sz="1050" dirty="0"/>
           </a:p>
@@ -9751,13 +9751,13 @@
             <a:r>
               <a:rPr lang="en-US" sz="1050" dirty="0">
                 <a:solidFill>
-                  <a:srgbClr val="3FB950"/>
-                </a:solidFill>
-                <a:latin typeface="Calibri" pitchFamily="34" charset="0"/>
-                <a:ea typeface="Calibri" pitchFamily="34" charset="-122"/>
-                <a:cs typeface="Calibri" pitchFamily="34" charset="-120"/>
-              </a:rPr>
-              <a:t>✅ 問題只影響少數用戶</a:t>
+                  <a:srgbClr val="4A9968"/>
+                </a:solidFill>
+                <a:latin typeface="Calibri" pitchFamily="34" charset="0"/>
+                <a:ea typeface="Calibri" pitchFamily="34" charset="-122"/>
+                <a:cs typeface="Calibri" pitchFamily="34" charset="-120"/>
+              </a:rPr>
+              <a:t>✅ Issues only affect a small subset of users</a:t>
             </a:r>
             <a:endParaRPr lang="en-US" sz="1050" dirty="0"/>
           </a:p>
@@ -9777,7 +9777,7 @@
     <p:bg>
       <p:bgPr>
         <a:solidFill>
-          <a:srgbClr val="0D1117"/>
+          <a:srgbClr val="FFFDF8"/>
         </a:solidFill>
       </p:bgPr>
     </p:bg>
@@ -9810,11 +9810,11 @@
             <a:avLst/>
           </a:prstGeom>
           <a:solidFill>
-            <a:srgbClr val="161B22"/>
+            <a:srgbClr val="F5F1EB"/>
           </a:solidFill>
           <a:ln w="6350">
             <a:solidFill>
-              <a:srgbClr val="30363D"/>
+              <a:srgbClr val="D6CCBF"/>
             </a:solidFill>
             <a:prstDash val="solid"/>
           </a:ln>
@@ -9835,11 +9835,11 @@
             <a:avLst/>
           </a:prstGeom>
           <a:solidFill>
-            <a:srgbClr val="3FB950"/>
+            <a:srgbClr val="4A9968"/>
           </a:solidFill>
           <a:ln w="12700">
             <a:solidFill>
-              <a:srgbClr val="3FB950"/>
+              <a:srgbClr val="4A9968"/>
             </a:solidFill>
             <a:prstDash val="solid"/>
           </a:ln>
@@ -9872,13 +9872,13 @@
             <a:r>
               <a:rPr lang="en-US" sz="1600" b="1" dirty="0">
                 <a:solidFill>
-                  <a:srgbClr val="E6EDF3"/>
-                </a:solidFill>
-                <a:latin typeface="Calibri" pitchFamily="34" charset="0"/>
-                <a:ea typeface="Calibri" pitchFamily="34" charset="-122"/>
-                <a:cs typeface="Calibri" pitchFamily="34" charset="-120"/>
-              </a:rPr>
-              <a:t>DORA Metrics：衡量 DevOps 成熟度的四個指標</a:t>
+                  <a:srgbClr val="2D2926"/>
+                </a:solidFill>
+                <a:latin typeface="Calibri" pitchFamily="34" charset="0"/>
+                <a:ea typeface="Calibri" pitchFamily="34" charset="-122"/>
+                <a:cs typeface="Calibri" pitchFamily="34" charset="-120"/>
+              </a:rPr>
+              <a:t>DORA Metrics: Four Indicators of DevOps Maturity</a:t>
             </a:r>
             <a:endParaRPr lang="en-US" sz="1600" dirty="0"/>
           </a:p>
@@ -9911,13 +9911,13 @@
             <a:r>
               <a:rPr lang="en-US" sz="850" dirty="0">
                 <a:solidFill>
-                  <a:srgbClr val="8B949E"/>
-                </a:solidFill>
-                <a:latin typeface="Calibri" pitchFamily="34" charset="0"/>
-                <a:ea typeface="Calibri" pitchFamily="34" charset="-122"/>
-                <a:cs typeface="Calibri" pitchFamily="34" charset="-120"/>
-              </a:rPr>
-              <a:t>PART 5  ·  40 / 50</a:t>
+                  <a:srgbClr val="8A8078"/>
+                </a:solidFill>
+                <a:latin typeface="Calibri" pitchFamily="34" charset="0"/>
+                <a:ea typeface="Calibri" pitchFamily="34" charset="-122"/>
+                <a:cs typeface="Calibri" pitchFamily="34" charset="-120"/>
+              </a:rPr>
+              <a:t>PART 5</a:t>
             </a:r>
             <a:endParaRPr lang="en-US" sz="850" dirty="0"/>
           </a:p>
@@ -9940,11 +9940,11 @@
             </a:avLst>
           </a:prstGeom>
           <a:solidFill>
-            <a:srgbClr val="161B22"/>
+            <a:srgbClr val="F5F1EB"/>
           </a:solidFill>
           <a:ln w="19050">
             <a:solidFill>
-              <a:srgbClr val="3FB950"/>
+              <a:srgbClr val="4A9968"/>
             </a:solidFill>
             <a:prstDash val="solid"/>
           </a:ln>
@@ -10020,7 +10020,7 @@
             <a:r>
               <a:rPr lang="en-US" sz="1300" b="1" dirty="0">
                 <a:solidFill>
-                  <a:srgbClr val="3FB950"/>
+                  <a:srgbClr val="4A9968"/>
                 </a:solidFill>
                 <a:latin typeface="Calibri" pitchFamily="34" charset="0"/>
                 <a:ea typeface="Calibri" pitchFamily="34" charset="-122"/>
@@ -10059,13 +10059,13 @@
             <a:r>
               <a:rPr lang="en-US" sz="950" dirty="0">
                 <a:solidFill>
-                  <a:srgbClr val="8B949E"/>
-                </a:solidFill>
-                <a:latin typeface="Calibri" pitchFamily="34" charset="0"/>
-                <a:ea typeface="Calibri" pitchFamily="34" charset="-122"/>
-                <a:cs typeface="Calibri" pitchFamily="34" charset="-120"/>
-              </a:rPr>
-              <a:t>部署頻率</a:t>
+                  <a:srgbClr val="8A8078"/>
+                </a:solidFill>
+                <a:latin typeface="Calibri" pitchFamily="34" charset="0"/>
+                <a:ea typeface="Calibri" pitchFamily="34" charset="-122"/>
+                <a:cs typeface="Calibri" pitchFamily="34" charset="-120"/>
+              </a:rPr>
+              <a:t>How often you deploy</a:t>
             </a:r>
             <a:endParaRPr lang="en-US" sz="950" dirty="0"/>
           </a:p>
@@ -10098,13 +10098,13 @@
             <a:r>
               <a:rPr lang="en-US" sz="1050" b="1" dirty="0">
                 <a:solidFill>
-                  <a:srgbClr val="3FB950"/>
-                </a:solidFill>
-                <a:latin typeface="Calibri" pitchFamily="34" charset="0"/>
-                <a:ea typeface="Calibri" pitchFamily="34" charset="-122"/>
-                <a:cs typeface="Calibri" pitchFamily="34" charset="-120"/>
-              </a:rPr>
-              <a:t>Elite: 多次/天</a:t>
+                  <a:srgbClr val="4A9968"/>
+                </a:solidFill>
+                <a:latin typeface="Calibri" pitchFamily="34" charset="0"/>
+                <a:ea typeface="Calibri" pitchFamily="34" charset="-122"/>
+                <a:cs typeface="Calibri" pitchFamily="34" charset="-120"/>
+              </a:rPr>
+              <a:t>Elite: Multiple/day</a:t>
             </a:r>
             <a:endParaRPr lang="en-US" sz="1050" dirty="0"/>
           </a:p>
@@ -10137,13 +10137,13 @@
             <a:r>
               <a:rPr lang="en-US" sz="1050" b="1" dirty="0">
                 <a:solidFill>
-                  <a:srgbClr val="58A6FF"/>
-                </a:solidFill>
-                <a:latin typeface="Calibri" pitchFamily="34" charset="0"/>
-                <a:ea typeface="Calibri" pitchFamily="34" charset="-122"/>
-                <a:cs typeface="Calibri" pitchFamily="34" charset="-120"/>
-              </a:rPr>
-              <a:t>High: 每天~每週</a:t>
+                  <a:srgbClr val="4A7FB5"/>
+                </a:solidFill>
+                <a:latin typeface="Calibri" pitchFamily="34" charset="0"/>
+                <a:ea typeface="Calibri" pitchFamily="34" charset="-122"/>
+                <a:cs typeface="Calibri" pitchFamily="34" charset="-120"/>
+              </a:rPr>
+              <a:t>High: Daily to weekly</a:t>
             </a:r>
             <a:endParaRPr lang="en-US" sz="1050" dirty="0"/>
           </a:p>
@@ -10176,13 +10176,13 @@
             <a:r>
               <a:rPr lang="en-US" sz="1050" b="1" dirty="0">
                 <a:solidFill>
-                  <a:srgbClr val="D29922"/>
-                </a:solidFill>
-                <a:latin typeface="Calibri" pitchFamily="34" charset="0"/>
-                <a:ea typeface="Calibri" pitchFamily="34" charset="-122"/>
-                <a:cs typeface="Calibri" pitchFamily="34" charset="-120"/>
-              </a:rPr>
-              <a:t>Medium: 每週~每月</a:t>
+                  <a:srgbClr val="B8892C"/>
+                </a:solidFill>
+                <a:latin typeface="Calibri" pitchFamily="34" charset="0"/>
+                <a:ea typeface="Calibri" pitchFamily="34" charset="-122"/>
+                <a:cs typeface="Calibri" pitchFamily="34" charset="-120"/>
+              </a:rPr>
+              <a:t>Medium: Weekly to monthly</a:t>
             </a:r>
             <a:endParaRPr lang="en-US" sz="1050" dirty="0"/>
           </a:p>
@@ -10205,11 +10205,11 @@
             </a:avLst>
           </a:prstGeom>
           <a:solidFill>
-            <a:srgbClr val="161B22"/>
+            <a:srgbClr val="F5F1EB"/>
           </a:solidFill>
           <a:ln w="19050">
             <a:solidFill>
-              <a:srgbClr val="58A6FF"/>
+              <a:srgbClr val="4A7FB5"/>
             </a:solidFill>
             <a:prstDash val="solid"/>
           </a:ln>
@@ -10285,7 +10285,7 @@
             <a:r>
               <a:rPr lang="en-US" sz="1300" b="1" dirty="0">
                 <a:solidFill>
-                  <a:srgbClr val="58A6FF"/>
+                  <a:srgbClr val="4A7FB5"/>
                 </a:solidFill>
                 <a:latin typeface="Calibri" pitchFamily="34" charset="0"/>
                 <a:ea typeface="Calibri" pitchFamily="34" charset="-122"/>
@@ -10324,13 +10324,13 @@
             <a:r>
               <a:rPr lang="en-US" sz="950" dirty="0">
                 <a:solidFill>
-                  <a:srgbClr val="8B949E"/>
-                </a:solidFill>
-                <a:latin typeface="Calibri" pitchFamily="34" charset="0"/>
-                <a:ea typeface="Calibri" pitchFamily="34" charset="-122"/>
-                <a:cs typeface="Calibri" pitchFamily="34" charset="-120"/>
-              </a:rPr>
-              <a:t>從 Commit 到 Prod 的時間</a:t>
+                  <a:srgbClr val="8A8078"/>
+                </a:solidFill>
+                <a:latin typeface="Calibri" pitchFamily="34" charset="0"/>
+                <a:ea typeface="Calibri" pitchFamily="34" charset="-122"/>
+                <a:cs typeface="Calibri" pitchFamily="34" charset="-120"/>
+              </a:rPr>
+              <a:t>Time from Commit to Prod</a:t>
             </a:r>
             <a:endParaRPr lang="en-US" sz="950" dirty="0"/>
           </a:p>
@@ -10363,13 +10363,13 @@
             <a:r>
               <a:rPr lang="en-US" sz="1050" b="1" dirty="0">
                 <a:solidFill>
-                  <a:srgbClr val="3FB950"/>
-                </a:solidFill>
-                <a:latin typeface="Calibri" pitchFamily="34" charset="0"/>
-                <a:ea typeface="Calibri" pitchFamily="34" charset="-122"/>
-                <a:cs typeface="Calibri" pitchFamily="34" charset="-120"/>
-              </a:rPr>
-              <a:t>Elite: &lt; 1 小時</a:t>
+                  <a:srgbClr val="4A9968"/>
+                </a:solidFill>
+                <a:latin typeface="Calibri" pitchFamily="34" charset="0"/>
+                <a:ea typeface="Calibri" pitchFamily="34" charset="-122"/>
+                <a:cs typeface="Calibri" pitchFamily="34" charset="-120"/>
+              </a:rPr>
+              <a:t>Elite: &lt; 1 hour</a:t>
             </a:r>
             <a:endParaRPr lang="en-US" sz="1050" dirty="0"/>
           </a:p>
@@ -10402,13 +10402,13 @@
             <a:r>
               <a:rPr lang="en-US" sz="1050" b="1" dirty="0">
                 <a:solidFill>
-                  <a:srgbClr val="58A6FF"/>
-                </a:solidFill>
-                <a:latin typeface="Calibri" pitchFamily="34" charset="0"/>
-                <a:ea typeface="Calibri" pitchFamily="34" charset="-122"/>
-                <a:cs typeface="Calibri" pitchFamily="34" charset="-120"/>
-              </a:rPr>
-              <a:t>High: &lt; 1 天</a:t>
+                  <a:srgbClr val="4A7FB5"/>
+                </a:solidFill>
+                <a:latin typeface="Calibri" pitchFamily="34" charset="0"/>
+                <a:ea typeface="Calibri" pitchFamily="34" charset="-122"/>
+                <a:cs typeface="Calibri" pitchFamily="34" charset="-120"/>
+              </a:rPr>
+              <a:t>High: &lt; 1 day</a:t>
             </a:r>
             <a:endParaRPr lang="en-US" sz="1050" dirty="0"/>
           </a:p>
@@ -10441,13 +10441,13 @@
             <a:r>
               <a:rPr lang="en-US" sz="1050" b="1" dirty="0">
                 <a:solidFill>
-                  <a:srgbClr val="D29922"/>
-                </a:solidFill>
-                <a:latin typeface="Calibri" pitchFamily="34" charset="0"/>
-                <a:ea typeface="Calibri" pitchFamily="34" charset="-122"/>
-                <a:cs typeface="Calibri" pitchFamily="34" charset="-120"/>
-              </a:rPr>
-              <a:t>Medium: 1週~1月</a:t>
+                  <a:srgbClr val="B8892C"/>
+                </a:solidFill>
+                <a:latin typeface="Calibri" pitchFamily="34" charset="0"/>
+                <a:ea typeface="Calibri" pitchFamily="34" charset="-122"/>
+                <a:cs typeface="Calibri" pitchFamily="34" charset="-120"/>
+              </a:rPr>
+              <a:t>Medium: 1 week to 1 month</a:t>
             </a:r>
             <a:endParaRPr lang="en-US" sz="1050" dirty="0"/>
           </a:p>
@@ -10470,11 +10470,11 @@
             </a:avLst>
           </a:prstGeom>
           <a:solidFill>
-            <a:srgbClr val="161B22"/>
+            <a:srgbClr val="F5F1EB"/>
           </a:solidFill>
           <a:ln w="19050">
             <a:solidFill>
-              <a:srgbClr val="F85149"/>
+              <a:srgbClr val="C4605B"/>
             </a:solidFill>
             <a:prstDash val="solid"/>
           </a:ln>
@@ -10550,7 +10550,7 @@
             <a:r>
               <a:rPr lang="en-US" sz="1300" b="1" dirty="0">
                 <a:solidFill>
-                  <a:srgbClr val="F85149"/>
+                  <a:srgbClr val="C4605B"/>
                 </a:solidFill>
                 <a:latin typeface="Calibri" pitchFamily="34" charset="0"/>
                 <a:ea typeface="Calibri" pitchFamily="34" charset="-122"/>
@@ -10589,13 +10589,13 @@
             <a:r>
               <a:rPr lang="en-US" sz="950" dirty="0">
                 <a:solidFill>
-                  <a:srgbClr val="8B949E"/>
-                </a:solidFill>
-                <a:latin typeface="Calibri" pitchFamily="34" charset="0"/>
-                <a:ea typeface="Calibri" pitchFamily="34" charset="-122"/>
-                <a:cs typeface="Calibri" pitchFamily="34" charset="-120"/>
-              </a:rPr>
-              <a:t>部署導致 Prod 問題的比率</a:t>
+                  <a:srgbClr val="8A8078"/>
+                </a:solidFill>
+                <a:latin typeface="Calibri" pitchFamily="34" charset="0"/>
+                <a:ea typeface="Calibri" pitchFamily="34" charset="-122"/>
+                <a:cs typeface="Calibri" pitchFamily="34" charset="-120"/>
+              </a:rPr>
+              <a:t>Rate of deploys causing Prod issues</a:t>
             </a:r>
             <a:endParaRPr lang="en-US" sz="950" dirty="0"/>
           </a:p>
@@ -10628,7 +10628,7 @@
             <a:r>
               <a:rPr lang="en-US" sz="1050" b="1" dirty="0">
                 <a:solidFill>
-                  <a:srgbClr val="3FB950"/>
+                  <a:srgbClr val="4A9968"/>
                 </a:solidFill>
                 <a:latin typeface="Calibri" pitchFamily="34" charset="0"/>
                 <a:ea typeface="Calibri" pitchFamily="34" charset="-122"/>
@@ -10667,7 +10667,7 @@
             <a:r>
               <a:rPr lang="en-US" sz="1050" b="1" dirty="0">
                 <a:solidFill>
-                  <a:srgbClr val="58A6FF"/>
+                  <a:srgbClr val="4A7FB5"/>
                 </a:solidFill>
                 <a:latin typeface="Calibri" pitchFamily="34" charset="0"/>
                 <a:ea typeface="Calibri" pitchFamily="34" charset="-122"/>
@@ -10706,7 +10706,7 @@
             <a:r>
               <a:rPr lang="en-US" sz="1050" b="1" dirty="0">
                 <a:solidFill>
-                  <a:srgbClr val="D29922"/>
+                  <a:srgbClr val="B8892C"/>
                 </a:solidFill>
                 <a:latin typeface="Calibri" pitchFamily="34" charset="0"/>
                 <a:ea typeface="Calibri" pitchFamily="34" charset="-122"/>
@@ -10735,11 +10735,11 @@
             </a:avLst>
           </a:prstGeom>
           <a:solidFill>
-            <a:srgbClr val="161B22"/>
+            <a:srgbClr val="F5F1EB"/>
           </a:solidFill>
           <a:ln w="19050">
             <a:solidFill>
-              <a:srgbClr val="D29922"/>
+              <a:srgbClr val="B8892C"/>
             </a:solidFill>
             <a:prstDash val="solid"/>
           </a:ln>
@@ -10815,7 +10815,7 @@
             <a:r>
               <a:rPr lang="en-US" sz="1300" b="1" dirty="0">
                 <a:solidFill>
-                  <a:srgbClr val="D29922"/>
+                  <a:srgbClr val="B8892C"/>
                 </a:solidFill>
                 <a:latin typeface="Calibri" pitchFamily="34" charset="0"/>
                 <a:ea typeface="Calibri" pitchFamily="34" charset="-122"/>
@@ -10854,13 +10854,13 @@
             <a:r>
               <a:rPr lang="en-US" sz="950" dirty="0">
                 <a:solidFill>
-                  <a:srgbClr val="8B949E"/>
-                </a:solidFill>
-                <a:latin typeface="Calibri" pitchFamily="34" charset="0"/>
-                <a:ea typeface="Calibri" pitchFamily="34" charset="-122"/>
-                <a:cs typeface="Calibri" pitchFamily="34" charset="-120"/>
-              </a:rPr>
-              <a:t>Mean Time To Restore — 恢復時間</a:t>
+                  <a:srgbClr val="8A8078"/>
+                </a:solidFill>
+                <a:latin typeface="Calibri" pitchFamily="34" charset="0"/>
+                <a:ea typeface="Calibri" pitchFamily="34" charset="-122"/>
+                <a:cs typeface="Calibri" pitchFamily="34" charset="-120"/>
+              </a:rPr>
+              <a:t>Mean Time To Restore</a:t>
             </a:r>
             <a:endParaRPr lang="en-US" sz="950" dirty="0"/>
           </a:p>
@@ -10893,13 +10893,13 @@
             <a:r>
               <a:rPr lang="en-US" sz="1050" b="1" dirty="0">
                 <a:solidFill>
-                  <a:srgbClr val="3FB950"/>
-                </a:solidFill>
-                <a:latin typeface="Calibri" pitchFamily="34" charset="0"/>
-                <a:ea typeface="Calibri" pitchFamily="34" charset="-122"/>
-                <a:cs typeface="Calibri" pitchFamily="34" charset="-120"/>
-              </a:rPr>
-              <a:t>Elite: &lt; 1 小時</a:t>
+                  <a:srgbClr val="4A9968"/>
+                </a:solidFill>
+                <a:latin typeface="Calibri" pitchFamily="34" charset="0"/>
+                <a:ea typeface="Calibri" pitchFamily="34" charset="-122"/>
+                <a:cs typeface="Calibri" pitchFamily="34" charset="-120"/>
+              </a:rPr>
+              <a:t>Elite: &lt; 1 hour</a:t>
             </a:r>
             <a:endParaRPr lang="en-US" sz="1050" dirty="0"/>
           </a:p>
@@ -10932,13 +10932,13 @@
             <a:r>
               <a:rPr lang="en-US" sz="1050" b="1" dirty="0">
                 <a:solidFill>
-                  <a:srgbClr val="58A6FF"/>
-                </a:solidFill>
-                <a:latin typeface="Calibri" pitchFamily="34" charset="0"/>
-                <a:ea typeface="Calibri" pitchFamily="34" charset="-122"/>
-                <a:cs typeface="Calibri" pitchFamily="34" charset="-120"/>
-              </a:rPr>
-              <a:t>High: &lt; 1 天</a:t>
+                  <a:srgbClr val="4A7FB5"/>
+                </a:solidFill>
+                <a:latin typeface="Calibri" pitchFamily="34" charset="0"/>
+                <a:ea typeface="Calibri" pitchFamily="34" charset="-122"/>
+                <a:cs typeface="Calibri" pitchFamily="34" charset="-120"/>
+              </a:rPr>
+              <a:t>High: &lt; 1 day</a:t>
             </a:r>
             <a:endParaRPr lang="en-US" sz="1050" dirty="0"/>
           </a:p>
@@ -10971,13 +10971,13 @@
             <a:r>
               <a:rPr lang="en-US" sz="1050" b="1" dirty="0">
                 <a:solidFill>
-                  <a:srgbClr val="D29922"/>
-                </a:solidFill>
-                <a:latin typeface="Calibri" pitchFamily="34" charset="0"/>
-                <a:ea typeface="Calibri" pitchFamily="34" charset="-122"/>
-                <a:cs typeface="Calibri" pitchFamily="34" charset="-120"/>
-              </a:rPr>
-              <a:t>Medium: 1天~1週</a:t>
+                  <a:srgbClr val="B8892C"/>
+                </a:solidFill>
+                <a:latin typeface="Calibri" pitchFamily="34" charset="0"/>
+                <a:ea typeface="Calibri" pitchFamily="34" charset="-122"/>
+                <a:cs typeface="Calibri" pitchFamily="34" charset="-120"/>
+              </a:rPr>
+              <a:t>Medium: 1 day to 1 week</a:t>
             </a:r>
             <a:endParaRPr lang="en-US" sz="1050" dirty="0"/>
           </a:p>
@@ -11000,11 +11000,11 @@
             </a:avLst>
           </a:prstGeom>
           <a:solidFill>
-            <a:srgbClr val="0A1929"/>
+            <a:srgbClr val="EAF0F7"/>
           </a:solidFill>
           <a:ln w="9525">
             <a:solidFill>
-              <a:srgbClr val="58A6FF"/>
+              <a:srgbClr val="4A7FB5"/>
             </a:solidFill>
             <a:prstDash val="solid"/>
           </a:ln>
@@ -11037,13 +11037,13 @@
             <a:r>
               <a:rPr lang="en-US" sz="1000" i="1" dirty="0">
                 <a:solidFill>
-                  <a:srgbClr val="8B949E"/>
-                </a:solidFill>
-                <a:latin typeface="Calibri" pitchFamily="34" charset="0"/>
-                <a:ea typeface="Calibri" pitchFamily="34" charset="-122"/>
-                <a:cs typeface="Calibri" pitchFamily="34" charset="-120"/>
-              </a:rPr>
-              <a:t>💡  DORA Research (2019): Elite 表現者比低表現者 — 部署快 208x，故障恢復快 2604x</a:t>
+                  <a:srgbClr val="8A8078"/>
+                </a:solidFill>
+                <a:latin typeface="Calibri" pitchFamily="34" charset="0"/>
+                <a:ea typeface="Calibri" pitchFamily="34" charset="-122"/>
+                <a:cs typeface="Calibri" pitchFamily="34" charset="-120"/>
+              </a:rPr>
+              <a:t>💡  DORA Research (2019): Elite performers vs low performers — 208x faster deploys, 2604x faster recovery</a:t>
             </a:r>
             <a:endParaRPr lang="en-US" sz="1000" dirty="0"/>
           </a:p>
@@ -11063,7 +11063,7 @@
     <p:bg>
       <p:bgPr>
         <a:solidFill>
-          <a:srgbClr val="0D1117"/>
+          <a:srgbClr val="FFFDF8"/>
         </a:solidFill>
       </p:bgPr>
     </p:bg>
@@ -11096,11 +11096,11 @@
             <a:avLst/>
           </a:prstGeom>
           <a:solidFill>
-            <a:srgbClr val="161B22"/>
+            <a:srgbClr val="F5F1EB"/>
           </a:solidFill>
           <a:ln w="6350">
             <a:solidFill>
-              <a:srgbClr val="30363D"/>
+              <a:srgbClr val="D6CCBF"/>
             </a:solidFill>
             <a:prstDash val="solid"/>
           </a:ln>
@@ -11121,11 +11121,11 @@
             <a:avLst/>
           </a:prstGeom>
           <a:solidFill>
-            <a:srgbClr val="D29922"/>
+            <a:srgbClr val="B8892C"/>
           </a:solidFill>
           <a:ln w="12700">
             <a:solidFill>
-              <a:srgbClr val="D29922"/>
+              <a:srgbClr val="B8892C"/>
             </a:solidFill>
             <a:prstDash val="solid"/>
           </a:ln>
@@ -11158,13 +11158,13 @@
             <a:r>
               <a:rPr lang="en-US" sz="1600" b="1" dirty="0">
                 <a:solidFill>
-                  <a:srgbClr val="E6EDF3"/>
-                </a:solidFill>
-                <a:latin typeface="Calibri" pitchFamily="34" charset="0"/>
-                <a:ea typeface="Calibri" pitchFamily="34" charset="-122"/>
-                <a:cs typeface="Calibri" pitchFamily="34" charset="-120"/>
-              </a:rPr>
-              <a:t>持續測試金字塔：測試的層次與速度</a:t>
+                  <a:srgbClr val="2D2926"/>
+                </a:solidFill>
+                <a:latin typeface="Calibri" pitchFamily="34" charset="0"/>
+                <a:ea typeface="Calibri" pitchFamily="34" charset="-122"/>
+                <a:cs typeface="Calibri" pitchFamily="34" charset="-120"/>
+              </a:rPr>
+              <a:t>Testing Pyramid: Layers and Speed of Testing</a:t>
             </a:r>
             <a:endParaRPr lang="en-US" sz="1600" dirty="0"/>
           </a:p>
@@ -11197,13 +11197,13 @@
             <a:r>
               <a:rPr lang="en-US" sz="850" dirty="0">
                 <a:solidFill>
-                  <a:srgbClr val="8B949E"/>
-                </a:solidFill>
-                <a:latin typeface="Calibri" pitchFamily="34" charset="0"/>
-                <a:ea typeface="Calibri" pitchFamily="34" charset="-122"/>
-                <a:cs typeface="Calibri" pitchFamily="34" charset="-120"/>
-              </a:rPr>
-              <a:t>PART 5  ·  41 / 50</a:t>
+                  <a:srgbClr val="8A8078"/>
+                </a:solidFill>
+                <a:latin typeface="Calibri" pitchFamily="34" charset="0"/>
+                <a:ea typeface="Calibri" pitchFamily="34" charset="-122"/>
+                <a:cs typeface="Calibri" pitchFamily="34" charset="-120"/>
+              </a:rPr>
+              <a:t>PART 5</a:t>
             </a:r>
             <a:endParaRPr lang="en-US" sz="850" dirty="0"/>
           </a:p>
@@ -11226,11 +11226,11 @@
             </a:avLst>
           </a:prstGeom>
           <a:solidFill>
-            <a:srgbClr val="2A0F0F"/>
+            <a:srgbClr val="F8ECEC"/>
           </a:solidFill>
           <a:ln w="15240">
             <a:solidFill>
-              <a:srgbClr val="F85149"/>
+              <a:srgbClr val="C4605B"/>
             </a:solidFill>
             <a:prstDash val="solid"/>
           </a:ln>
@@ -11263,7 +11263,7 @@
             <a:r>
               <a:rPr lang="en-US" sz="1000" b="1" dirty="0">
                 <a:solidFill>
-                  <a:srgbClr val="F85149"/>
+                  <a:srgbClr val="C4605B"/>
                 </a:solidFill>
                 <a:latin typeface="Calibri" pitchFamily="34" charset="0"/>
                 <a:ea typeface="Calibri" pitchFamily="34" charset="-122"/>
@@ -11302,13 +11302,13 @@
             <a:r>
               <a:rPr lang="en-US" sz="850" dirty="0">
                 <a:solidFill>
-                  <a:srgbClr val="8B949E"/>
-                </a:solidFill>
-                <a:latin typeface="Calibri" pitchFamily="34" charset="0"/>
-                <a:ea typeface="Calibri" pitchFamily="34" charset="-122"/>
-                <a:cs typeface="Calibri" pitchFamily="34" charset="-120"/>
-              </a:rPr>
-              <a:t>模擬真實用戶 | 分鐘級</a:t>
+                  <a:srgbClr val="8A8078"/>
+                </a:solidFill>
+                <a:latin typeface="Calibri" pitchFamily="34" charset="0"/>
+                <a:ea typeface="Calibri" pitchFamily="34" charset="-122"/>
+                <a:cs typeface="Calibri" pitchFamily="34" charset="-120"/>
+              </a:rPr>
+              <a:t>Simulate real users | Minutes</a:t>
             </a:r>
             <a:endParaRPr lang="en-US" sz="850" dirty="0"/>
           </a:p>
@@ -11331,11 +11331,11 @@
             </a:avLst>
           </a:prstGeom>
           <a:solidFill>
-            <a:srgbClr val="2A1F00"/>
+            <a:srgbClr val="F3EDE0"/>
           </a:solidFill>
           <a:ln w="15240">
             <a:solidFill>
-              <a:srgbClr val="D29922"/>
+              <a:srgbClr val="B8892C"/>
             </a:solidFill>
             <a:prstDash val="solid"/>
           </a:ln>
@@ -11368,7 +11368,7 @@
             <a:r>
               <a:rPr lang="en-US" sz="1000" b="1" dirty="0">
                 <a:solidFill>
-                  <a:srgbClr val="D29922"/>
+                  <a:srgbClr val="B8892C"/>
                 </a:solidFill>
                 <a:latin typeface="Calibri" pitchFamily="34" charset="0"/>
                 <a:ea typeface="Calibri" pitchFamily="34" charset="-122"/>
@@ -11407,13 +11407,13 @@
             <a:r>
               <a:rPr lang="en-US" sz="850" dirty="0">
                 <a:solidFill>
-                  <a:srgbClr val="8B949E"/>
-                </a:solidFill>
-                <a:latin typeface="Calibri" pitchFamily="34" charset="0"/>
-                <a:ea typeface="Calibri" pitchFamily="34" charset="-122"/>
-                <a:cs typeface="Calibri" pitchFamily="34" charset="-120"/>
-              </a:rPr>
-              <a:t>API + DB 整合 | 秒級</a:t>
+                  <a:srgbClr val="8A8078"/>
+                </a:solidFill>
+                <a:latin typeface="Calibri" pitchFamily="34" charset="0"/>
+                <a:ea typeface="Calibri" pitchFamily="34" charset="-122"/>
+                <a:cs typeface="Calibri" pitchFamily="34" charset="-120"/>
+              </a:rPr>
+              <a:t>API + DB integration | Seconds</a:t>
             </a:r>
             <a:endParaRPr lang="en-US" sz="850" dirty="0"/>
           </a:p>
@@ -11436,11 +11436,11 @@
             </a:avLst>
           </a:prstGeom>
           <a:solidFill>
-            <a:srgbClr val="0F2A1A"/>
+            <a:srgbClr val="E5F0E9"/>
           </a:solidFill>
           <a:ln w="15240">
             <a:solidFill>
-              <a:srgbClr val="3FB950"/>
+              <a:srgbClr val="4A9968"/>
             </a:solidFill>
             <a:prstDash val="solid"/>
           </a:ln>
@@ -11473,7 +11473,7 @@
             <a:r>
               <a:rPr lang="en-US" sz="1000" b="1" dirty="0">
                 <a:solidFill>
-                  <a:srgbClr val="3FB950"/>
+                  <a:srgbClr val="4A9968"/>
                 </a:solidFill>
                 <a:latin typeface="Calibri" pitchFamily="34" charset="0"/>
                 <a:ea typeface="Calibri" pitchFamily="34" charset="-122"/>
@@ -11512,13 +11512,13 @@
             <a:r>
               <a:rPr lang="en-US" sz="850" dirty="0">
                 <a:solidFill>
-                  <a:srgbClr val="8B949E"/>
-                </a:solidFill>
-                <a:latin typeface="Calibri" pitchFamily="34" charset="0"/>
-                <a:ea typeface="Calibri" pitchFamily="34" charset="-122"/>
-                <a:cs typeface="Calibri" pitchFamily="34" charset="-120"/>
-              </a:rPr>
-              <a:t>快速 | 隔離 | 毫秒級    jest, pytest, go test</a:t>
+                  <a:srgbClr val="8A8078"/>
+                </a:solidFill>
+                <a:latin typeface="Calibri" pitchFamily="34" charset="0"/>
+                <a:ea typeface="Calibri" pitchFamily="34" charset="-122"/>
+                <a:cs typeface="Calibri" pitchFamily="34" charset="-120"/>
+              </a:rPr>
+              <a:t>Fast | Isolated | Milliseconds    jest, pytest, go test</a:t>
             </a:r>
             <a:endParaRPr lang="en-US" sz="850" dirty="0"/>
           </a:p>
@@ -11541,7 +11541,7 @@
           <a:noFill/>
           <a:ln w="15240">
             <a:solidFill>
-              <a:srgbClr val="8B949E"/>
+              <a:srgbClr val="8A8078"/>
             </a:solidFill>
             <a:prstDash val="solid"/>
             <a:tailEnd type="arrow"/>
@@ -11575,13 +11575,13 @@
             <a:r>
               <a:rPr lang="en-US" sz="800" dirty="0">
                 <a:solidFill>
-                  <a:srgbClr val="8B949E"/>
-                </a:solidFill>
-                <a:latin typeface="Calibri" pitchFamily="34" charset="0"/>
-                <a:ea typeface="Calibri" pitchFamily="34" charset="-122"/>
-                <a:cs typeface="Calibri" pitchFamily="34" charset="-120"/>
-              </a:rPr>
-              <a:t>慢 🐌</a:t>
+                  <a:srgbClr val="8A8078"/>
+                </a:solidFill>
+                <a:latin typeface="Calibri" pitchFamily="34" charset="0"/>
+                <a:ea typeface="Calibri" pitchFamily="34" charset="-122"/>
+                <a:cs typeface="Calibri" pitchFamily="34" charset="-120"/>
+              </a:rPr>
+              <a:t>Slow 🐌</a:t>
             </a:r>
             <a:endParaRPr lang="en-US" sz="800" dirty="0"/>
           </a:p>
@@ -11614,13 +11614,13 @@
             <a:r>
               <a:rPr lang="en-US" sz="800" dirty="0">
                 <a:solidFill>
-                  <a:srgbClr val="8B949E"/>
-                </a:solidFill>
-                <a:latin typeface="Calibri" pitchFamily="34" charset="0"/>
-                <a:ea typeface="Calibri" pitchFamily="34" charset="-122"/>
-                <a:cs typeface="Calibri" pitchFamily="34" charset="-120"/>
-              </a:rPr>
-              <a:t>快 ⚡</a:t>
+                  <a:srgbClr val="8A8078"/>
+                </a:solidFill>
+                <a:latin typeface="Calibri" pitchFamily="34" charset="0"/>
+                <a:ea typeface="Calibri" pitchFamily="34" charset="-122"/>
+                <a:cs typeface="Calibri" pitchFamily="34" charset="-120"/>
+              </a:rPr>
+              <a:t>Fast ⚡</a:t>
             </a:r>
             <a:endParaRPr lang="en-US" sz="800" dirty="0"/>
           </a:p>
@@ -11643,18 +11643,18 @@
             </a:avLst>
           </a:prstGeom>
           <a:solidFill>
-            <a:srgbClr val="0D1117"/>
+            <a:srgbClr val="2D2926"/>
           </a:solidFill>
           <a:ln w="12700">
             <a:solidFill>
-              <a:srgbClr val="30363D"/>
+              <a:srgbClr val="D6CCBF"/>
             </a:solidFill>
             <a:prstDash val="solid"/>
           </a:ln>
           <a:effectLst>
             <a:outerShdw sx="100000" sy="100000" kx="0" ky="0" algn="bl" rotWithShape="0" blurRad="127000" dist="50800" dir="2700000">
-              <a:srgbClr val="000000">
-                <a:alpha val="50000"/>
+              <a:srgbClr val="9E9488">
+                <a:alpha val="15000"/>
               </a:srgbClr>
             </a:outerShdw>
           </a:effectLst>
@@ -11677,11 +11677,11 @@
             </a:avLst>
           </a:prstGeom>
           <a:solidFill>
-            <a:srgbClr val="1C2128"/>
+            <a:srgbClr val="ECE6DD"/>
           </a:solidFill>
           <a:ln w="6350">
             <a:solidFill>
-              <a:srgbClr val="30363D"/>
+              <a:srgbClr val="D6CCBF"/>
             </a:solidFill>
             <a:prstDash val="solid"/>
           </a:ln>
@@ -11714,7 +11714,7 @@
             <a:r>
               <a:rPr lang="en-US" sz="800" b="1" dirty="0">
                 <a:solidFill>
-                  <a:srgbClr val="8B949E"/>
+                  <a:srgbClr val="8A8078"/>
                 </a:solidFill>
                 <a:latin typeface="Consolas" pitchFamily="34" charset="0"/>
                 <a:ea typeface="Consolas" pitchFamily="34" charset="-122"/>
@@ -11756,13 +11756,13 @@
             <a:r>
               <a:rPr lang="en-US" sz="950" dirty="0">
                 <a:solidFill>
-                  <a:srgbClr val="E6EDF3"/>
+                  <a:srgbClr val="2D2926"/>
                 </a:solidFill>
                 <a:latin typeface="Consolas" pitchFamily="34" charset="0"/>
                 <a:ea typeface="Consolas" pitchFamily="34" charset="-122"/>
                 <a:cs typeface="Consolas" pitchFamily="34" charset="-120"/>
               </a:rPr>
-              <a:t># CI Pipeline 測試順序</a:t>
+              <a:t># CI Pipeline test order</a:t>
             </a:r>
             <a:endParaRPr lang="en-US" sz="950" dirty="0"/>
           </a:p>
@@ -11785,7 +11785,7 @@
             <a:r>
               <a:rPr lang="en-US" sz="950" dirty="0">
                 <a:solidFill>
-                  <a:srgbClr val="E6EDF3"/>
+                  <a:srgbClr val="2D2926"/>
                 </a:solidFill>
                 <a:latin typeface="Consolas" pitchFamily="34" charset="0"/>
                 <a:ea typeface="Consolas" pitchFamily="34" charset="-122"/>
@@ -11805,7 +11805,7 @@
             <a:r>
               <a:rPr lang="en-US" sz="950" dirty="0">
                 <a:solidFill>
-                  <a:srgbClr val="E6EDF3"/>
+                  <a:srgbClr val="2D2926"/>
                 </a:solidFill>
                 <a:latin typeface="Consolas" pitchFamily="34" charset="0"/>
                 <a:ea typeface="Consolas" pitchFamily="34" charset="-122"/>
@@ -11825,7 +11825,7 @@
             <a:r>
               <a:rPr lang="en-US" sz="950" dirty="0">
                 <a:solidFill>
-                  <a:srgbClr val="E6EDF3"/>
+                  <a:srgbClr val="2D2926"/>
                 </a:solidFill>
                 <a:latin typeface="Consolas" pitchFamily="34" charset="0"/>
                 <a:ea typeface="Consolas" pitchFamily="34" charset="-122"/>
@@ -11854,7 +11854,7 @@
             <a:r>
               <a:rPr lang="en-US" sz="950" dirty="0">
                 <a:solidFill>
-                  <a:srgbClr val="E6EDF3"/>
+                  <a:srgbClr val="2D2926"/>
                 </a:solidFill>
                 <a:latin typeface="Consolas" pitchFamily="34" charset="0"/>
                 <a:ea typeface="Consolas" pitchFamily="34" charset="-122"/>
@@ -11874,7 +11874,7 @@
             <a:r>
               <a:rPr lang="en-US" sz="950" dirty="0">
                 <a:solidFill>
-                  <a:srgbClr val="E6EDF3"/>
+                  <a:srgbClr val="2D2926"/>
                 </a:solidFill>
                 <a:latin typeface="Consolas" pitchFamily="34" charset="0"/>
                 <a:ea typeface="Consolas" pitchFamily="34" charset="-122"/>
@@ -11894,7 +11894,7 @@
             <a:r>
               <a:rPr lang="en-US" sz="950" dirty="0">
                 <a:solidFill>
-                  <a:srgbClr val="E6EDF3"/>
+                  <a:srgbClr val="2D2926"/>
                 </a:solidFill>
                 <a:latin typeface="Consolas" pitchFamily="34" charset="0"/>
                 <a:ea typeface="Consolas" pitchFamily="34" charset="-122"/>
@@ -11923,7 +11923,7 @@
             <a:r>
               <a:rPr lang="en-US" sz="950" dirty="0">
                 <a:solidFill>
-                  <a:srgbClr val="E6EDF3"/>
+                  <a:srgbClr val="2D2926"/>
                 </a:solidFill>
                 <a:latin typeface="Consolas" pitchFamily="34" charset="0"/>
                 <a:ea typeface="Consolas" pitchFamily="34" charset="-122"/>
@@ -11943,7 +11943,7 @@
             <a:r>
               <a:rPr lang="en-US" sz="950" dirty="0">
                 <a:solidFill>
-                  <a:srgbClr val="E6EDF3"/>
+                  <a:srgbClr val="2D2926"/>
                 </a:solidFill>
                 <a:latin typeface="Consolas" pitchFamily="34" charset="0"/>
                 <a:ea typeface="Consolas" pitchFamily="34" charset="-122"/>
@@ -11963,7 +11963,7 @@
             <a:r>
               <a:rPr lang="en-US" sz="950" dirty="0">
                 <a:solidFill>
-                  <a:srgbClr val="E6EDF3"/>
+                  <a:srgbClr val="2D2926"/>
                 </a:solidFill>
                 <a:latin typeface="Consolas" pitchFamily="34" charset="0"/>
                 <a:ea typeface="Consolas" pitchFamily="34" charset="-122"/>
@@ -11992,11 +11992,11 @@
             </a:avLst>
           </a:prstGeom>
           <a:solidFill>
-            <a:srgbClr val="161B22"/>
+            <a:srgbClr val="F5F1EB"/>
           </a:solidFill>
           <a:ln w="9525">
             <a:solidFill>
-              <a:srgbClr val="30363D"/>
+              <a:srgbClr val="D6CCBF"/>
             </a:solidFill>
             <a:prstDash val="solid"/>
           </a:ln>
@@ -12029,7 +12029,7 @@
             <a:r>
               <a:rPr lang="en-US" sz="1100" b="1" dirty="0">
                 <a:solidFill>
-                  <a:srgbClr val="58A6FF"/>
+                  <a:srgbClr val="4A7FB5"/>
                 </a:solidFill>
                 <a:latin typeface="Calibri" pitchFamily="34" charset="0"/>
                 <a:ea typeface="Calibri" pitchFamily="34" charset="-122"/>
@@ -12068,13 +12068,13 @@
             <a:r>
               <a:rPr lang="en-US" sz="950" dirty="0">
                 <a:solidFill>
-                  <a:srgbClr val="8B949E"/>
-                </a:solidFill>
-                <a:latin typeface="Calibri" pitchFamily="34" charset="0"/>
-                <a:ea typeface="Calibri" pitchFamily="34" charset="-122"/>
-                <a:cs typeface="Calibri" pitchFamily="34" charset="-120"/>
-              </a:rPr>
-              <a:t>Unit test 失敗立刻停止 Pipeline</a:t>
+                  <a:srgbClr val="8A8078"/>
+                </a:solidFill>
+                <a:latin typeface="Calibri" pitchFamily="34" charset="0"/>
+                <a:ea typeface="Calibri" pitchFamily="34" charset="-122"/>
+                <a:cs typeface="Calibri" pitchFamily="34" charset="-120"/>
+              </a:rPr>
+              <a:t>Stop pipeline immediately on unit test failure</a:t>
             </a:r>
             <a:endParaRPr lang="en-US" sz="950" dirty="0"/>
           </a:p>
@@ -12097,11 +12097,11 @@
             </a:avLst>
           </a:prstGeom>
           <a:solidFill>
-            <a:srgbClr val="161B22"/>
+            <a:srgbClr val="F5F1EB"/>
           </a:solidFill>
           <a:ln w="9525">
             <a:solidFill>
-              <a:srgbClr val="30363D"/>
+              <a:srgbClr val="D6CCBF"/>
             </a:solidFill>
             <a:prstDash val="solid"/>
           </a:ln>
@@ -12134,13 +12134,13 @@
             <a:r>
               <a:rPr lang="en-US" sz="1100" b="1" dirty="0">
                 <a:solidFill>
-                  <a:srgbClr val="58A6FF"/>
-                </a:solidFill>
-                <a:latin typeface="Calibri" pitchFamily="34" charset="0"/>
-                <a:ea typeface="Calibri" pitchFamily="34" charset="-122"/>
-                <a:cs typeface="Calibri" pitchFamily="34" charset="-120"/>
-              </a:rPr>
-              <a:t>🔁 測試隔離</a:t>
+                  <a:srgbClr val="4A7FB5"/>
+                </a:solidFill>
+                <a:latin typeface="Calibri" pitchFamily="34" charset="0"/>
+                <a:ea typeface="Calibri" pitchFamily="34" charset="-122"/>
+                <a:cs typeface="Calibri" pitchFamily="34" charset="-120"/>
+              </a:rPr>
+              <a:t>🔁 Test Isolation</a:t>
             </a:r>
             <a:endParaRPr lang="en-US" sz="1100" dirty="0"/>
           </a:p>
@@ -12173,13 +12173,13 @@
             <a:r>
               <a:rPr lang="en-US" sz="950" dirty="0">
                 <a:solidFill>
-                  <a:srgbClr val="8B949E"/>
-                </a:solidFill>
-                <a:latin typeface="Calibri" pitchFamily="34" charset="0"/>
-                <a:ea typeface="Calibri" pitchFamily="34" charset="-122"/>
-                <a:cs typeface="Calibri" pitchFamily="34" charset="-120"/>
-              </a:rPr>
-              <a:t>每個 Test 獨立，不依賴順序</a:t>
+                  <a:srgbClr val="8A8078"/>
+                </a:solidFill>
+                <a:latin typeface="Calibri" pitchFamily="34" charset="0"/>
+                <a:ea typeface="Calibri" pitchFamily="34" charset="-122"/>
+                <a:cs typeface="Calibri" pitchFamily="34" charset="-120"/>
+              </a:rPr>
+              <a:t>Each test is independent, no order dependency</a:t>
             </a:r>
             <a:endParaRPr lang="en-US" sz="950" dirty="0"/>
           </a:p>
@@ -12202,11 +12202,11 @@
             </a:avLst>
           </a:prstGeom>
           <a:solidFill>
-            <a:srgbClr val="161B22"/>
+            <a:srgbClr val="F5F1EB"/>
           </a:solidFill>
           <a:ln w="9525">
             <a:solidFill>
-              <a:srgbClr val="30363D"/>
+              <a:srgbClr val="D6CCBF"/>
             </a:solidFill>
             <a:prstDash val="solid"/>
           </a:ln>
@@ -12239,7 +12239,7 @@
             <a:r>
               <a:rPr lang="en-US" sz="1100" b="1" dirty="0">
                 <a:solidFill>
-                  <a:srgbClr val="58A6FF"/>
+                  <a:srgbClr val="4A7FB5"/>
                 </a:solidFill>
                 <a:latin typeface="Calibri" pitchFamily="34" charset="0"/>
                 <a:ea typeface="Calibri" pitchFamily="34" charset="-122"/>
@@ -12278,13 +12278,13 @@
             <a:r>
               <a:rPr lang="en-US" sz="950" dirty="0">
                 <a:solidFill>
-                  <a:srgbClr val="8B949E"/>
-                </a:solidFill>
-                <a:latin typeface="Calibri" pitchFamily="34" charset="0"/>
-                <a:ea typeface="Calibri" pitchFamily="34" charset="-122"/>
-                <a:cs typeface="Calibri" pitchFamily="34" charset="-120"/>
-              </a:rPr>
-              <a:t>目標 80%+，關鍵路徑 100%</a:t>
+                  <a:srgbClr val="8A8078"/>
+                </a:solidFill>
+                <a:latin typeface="Calibri" pitchFamily="34" charset="0"/>
+                <a:ea typeface="Calibri" pitchFamily="34" charset="-122"/>
+                <a:cs typeface="Calibri" pitchFamily="34" charset="-120"/>
+              </a:rPr>
+              <a:t>Target 80%+, critical paths 100%</a:t>
             </a:r>
             <a:endParaRPr lang="en-US" sz="950" dirty="0"/>
           </a:p>
@@ -12304,7 +12304,7 @@
     <p:bg>
       <p:bgPr>
         <a:solidFill>
-          <a:srgbClr val="0D1117"/>
+          <a:srgbClr val="FFFDF8"/>
         </a:solidFill>
       </p:bgPr>
     </p:bg>
@@ -12337,11 +12337,11 @@
             <a:avLst/>
           </a:prstGeom>
           <a:solidFill>
-            <a:srgbClr val="161B22"/>
+            <a:srgbClr val="F5F1EB"/>
           </a:solidFill>
           <a:ln w="6350">
             <a:solidFill>
-              <a:srgbClr val="30363D"/>
+              <a:srgbClr val="D6CCBF"/>
             </a:solidFill>
             <a:prstDash val="solid"/>
           </a:ln>
@@ -12362,11 +12362,11 @@
             <a:avLst/>
           </a:prstGeom>
           <a:solidFill>
-            <a:srgbClr val="3FB950"/>
+            <a:srgbClr val="4A9968"/>
           </a:solidFill>
           <a:ln w="12700">
             <a:solidFill>
-              <a:srgbClr val="3FB950"/>
+              <a:srgbClr val="4A9968"/>
             </a:solidFill>
             <a:prstDash val="solid"/>
           </a:ln>
@@ -12399,13 +12399,13 @@
             <a:r>
               <a:rPr lang="en-US" sz="1600" b="1" dirty="0">
                 <a:solidFill>
-                  <a:srgbClr val="E6EDF3"/>
-                </a:solidFill>
-                <a:latin typeface="Calibri" pitchFamily="34" charset="0"/>
-                <a:ea typeface="Calibri" pitchFamily="34" charset="-122"/>
-                <a:cs typeface="Calibri" pitchFamily="34" charset="-120"/>
-              </a:rPr>
-              <a:t>Part 5 小結：DevOps 讓軟體交付飛起來</a:t>
+                  <a:srgbClr val="2D2926"/>
+                </a:solidFill>
+                <a:latin typeface="Calibri" pitchFamily="34" charset="0"/>
+                <a:ea typeface="Calibri" pitchFamily="34" charset="-122"/>
+                <a:cs typeface="Calibri" pitchFamily="34" charset="-120"/>
+              </a:rPr>
+              <a:t>Part 5 Summary: DevOps Makes Software Delivery Fly</a:t>
             </a:r>
             <a:endParaRPr lang="en-US" sz="1600" dirty="0"/>
           </a:p>
@@ -12438,13 +12438,13 @@
             <a:r>
               <a:rPr lang="en-US" sz="850" dirty="0">
                 <a:solidFill>
-                  <a:srgbClr val="8B949E"/>
-                </a:solidFill>
-                <a:latin typeface="Calibri" pitchFamily="34" charset="0"/>
-                <a:ea typeface="Calibri" pitchFamily="34" charset="-122"/>
-                <a:cs typeface="Calibri" pitchFamily="34" charset="-120"/>
-              </a:rPr>
-              <a:t>PART 5  ·  42 / 50</a:t>
+                  <a:srgbClr val="8A8078"/>
+                </a:solidFill>
+                <a:latin typeface="Calibri" pitchFamily="34" charset="0"/>
+                <a:ea typeface="Calibri" pitchFamily="34" charset="-122"/>
+                <a:cs typeface="Calibri" pitchFamily="34" charset="-120"/>
+              </a:rPr>
+              <a:t>PART 5</a:t>
             </a:r>
             <a:endParaRPr lang="en-US" sz="850" dirty="0"/>
           </a:p>
@@ -12467,18 +12467,18 @@
             </a:avLst>
           </a:prstGeom>
           <a:solidFill>
-            <a:srgbClr val="161B22"/>
+            <a:srgbClr val="F5F1EB"/>
           </a:solidFill>
           <a:ln w="15240">
             <a:solidFill>
-              <a:srgbClr val="58A6FF"/>
+              <a:srgbClr val="4A7FB5"/>
             </a:solidFill>
             <a:prstDash val="solid"/>
           </a:ln>
           <a:effectLst>
             <a:outerShdw sx="100000" sy="100000" kx="0" ky="0" algn="bl" rotWithShape="0" blurRad="76200" dist="25400" dir="2700000">
-              <a:srgbClr val="000000">
-                <a:alpha val="30000"/>
+              <a:srgbClr val="9E9488">
+                <a:alpha val="15000"/>
               </a:srgbClr>
             </a:outerShdw>
           </a:effectLst>
@@ -12547,13 +12547,13 @@
             <a:r>
               <a:rPr lang="en-US" sz="1100" b="1" dirty="0">
                 <a:solidFill>
-                  <a:srgbClr val="58A6FF"/>
-                </a:solidFill>
-                <a:latin typeface="Calibri" pitchFamily="34" charset="0"/>
-                <a:ea typeface="Calibri" pitchFamily="34" charset="-122"/>
-                <a:cs typeface="Calibri" pitchFamily="34" charset="-120"/>
-              </a:rPr>
-              <a:t>DevOps 是文化，CI/CD 是工具</a:t>
+                  <a:srgbClr val="4A7FB5"/>
+                </a:solidFill>
+                <a:latin typeface="Calibri" pitchFamily="34" charset="0"/>
+                <a:ea typeface="Calibri" pitchFamily="34" charset="-122"/>
+                <a:cs typeface="Calibri" pitchFamily="34" charset="-120"/>
+              </a:rPr>
+              <a:t>DevOps Is Culture, CI/CD Is the Toolchain</a:t>
             </a:r>
             <a:endParaRPr lang="en-US" sz="1100" dirty="0"/>
           </a:p>
@@ -12586,13 +12586,13 @@
             <a:r>
               <a:rPr lang="en-US" sz="900" dirty="0">
                 <a:solidFill>
-                  <a:srgbClr val="8B949E"/>
-                </a:solidFill>
-                <a:latin typeface="Calibri" pitchFamily="34" charset="0"/>
-                <a:ea typeface="Calibri" pitchFamily="34" charset="-122"/>
-                <a:cs typeface="Calibri" pitchFamily="34" charset="-120"/>
-              </a:rPr>
-              <a:t>• 打破 Dev/Ops 高牆，共同對交付品質負責</a:t>
+                  <a:srgbClr val="8A8078"/>
+                </a:solidFill>
+                <a:latin typeface="Calibri" pitchFamily="34" charset="0"/>
+                <a:ea typeface="Calibri" pitchFamily="34" charset="-122"/>
+                <a:cs typeface="Calibri" pitchFamily="34" charset="-120"/>
+              </a:rPr>
+              <a:t>• Break down the Dev/Ops wall — shared responsibility for delivery quality</a:t>
             </a:r>
             <a:endParaRPr lang="en-US" sz="900" dirty="0"/>
           </a:p>
@@ -12625,13 +12625,13 @@
             <a:r>
               <a:rPr lang="en-US" sz="900" dirty="0">
                 <a:solidFill>
-                  <a:srgbClr val="8B949E"/>
-                </a:solidFill>
-                <a:latin typeface="Calibri" pitchFamily="34" charset="0"/>
-                <a:ea typeface="Calibri" pitchFamily="34" charset="-122"/>
-                <a:cs typeface="Calibri" pitchFamily="34" charset="-120"/>
-              </a:rPr>
-              <a:t>• CI/CD Pipeline 讓每次 Commit 都能安全部署</a:t>
+                  <a:srgbClr val="8A8078"/>
+                </a:solidFill>
+                <a:latin typeface="Calibri" pitchFamily="34" charset="0"/>
+                <a:ea typeface="Calibri" pitchFamily="34" charset="-122"/>
+                <a:cs typeface="Calibri" pitchFamily="34" charset="-120"/>
+              </a:rPr>
+              <a:t>• CI/CD Pipeline ensures every commit can be safely deployed</a:t>
             </a:r>
             <a:endParaRPr lang="en-US" sz="900" dirty="0"/>
           </a:p>
@@ -12664,13 +12664,13 @@
             <a:r>
               <a:rPr lang="en-US" sz="1200" dirty="0">
                 <a:solidFill>
-                  <a:srgbClr val="F85149"/>
-                </a:solidFill>
-                <a:latin typeface="Calibri" pitchFamily="34" charset="0"/>
-                <a:ea typeface="Calibri" pitchFamily="34" charset="-122"/>
-                <a:cs typeface="Calibri" pitchFamily="34" charset="-120"/>
-              </a:rPr>
-              <a:t>核心理念</a:t>
+                  <a:srgbClr val="C4605B"/>
+                </a:solidFill>
+                <a:latin typeface="Calibri" pitchFamily="34" charset="0"/>
+                <a:ea typeface="Calibri" pitchFamily="34" charset="-122"/>
+                <a:cs typeface="Calibri" pitchFamily="34" charset="-120"/>
+              </a:rPr>
+              <a:t>Core Principle</a:t>
             </a:r>
             <a:endParaRPr lang="en-US" sz="1200" dirty="0"/>
           </a:p>
@@ -12693,18 +12693,18 @@
             </a:avLst>
           </a:prstGeom>
           <a:solidFill>
-            <a:srgbClr val="161B22"/>
+            <a:srgbClr val="F5F1EB"/>
           </a:solidFill>
           <a:ln w="15240">
             <a:solidFill>
-              <a:srgbClr val="3FB950"/>
+              <a:srgbClr val="4A9968"/>
             </a:solidFill>
             <a:prstDash val="solid"/>
           </a:ln>
           <a:effectLst>
             <a:outerShdw sx="100000" sy="100000" kx="0" ky="0" algn="bl" rotWithShape="0" blurRad="76200" dist="25400" dir="2700000">
-              <a:srgbClr val="000000">
-                <a:alpha val="30000"/>
+              <a:srgbClr val="9E9488">
+                <a:alpha val="15000"/>
               </a:srgbClr>
             </a:outerShdw>
           </a:effectLst>
@@ -12773,13 +12773,13 @@
             <a:r>
               <a:rPr lang="en-US" sz="1100" b="1" dirty="0">
                 <a:solidFill>
-                  <a:srgbClr val="3FB950"/>
-                </a:solidFill>
-                <a:latin typeface="Calibri" pitchFamily="34" charset="0"/>
-                <a:ea typeface="Calibri" pitchFamily="34" charset="-122"/>
-                <a:cs typeface="Calibri" pitchFamily="34" charset="-120"/>
-              </a:rPr>
-              <a:t>用 DORA Metrics 衡量進步</a:t>
+                  <a:srgbClr val="4A9968"/>
+                </a:solidFill>
+                <a:latin typeface="Calibri" pitchFamily="34" charset="0"/>
+                <a:ea typeface="Calibri" pitchFamily="34" charset="-122"/>
+                <a:cs typeface="Calibri" pitchFamily="34" charset="-120"/>
+              </a:rPr>
+              <a:t>Measure Progress with DORA Metrics</a:t>
             </a:r>
             <a:endParaRPr lang="en-US" sz="1100" dirty="0"/>
           </a:p>
@@ -12812,13 +12812,13 @@
             <a:r>
               <a:rPr lang="en-US" sz="900" dirty="0">
                 <a:solidFill>
-                  <a:srgbClr val="8B949E"/>
-                </a:solidFill>
-                <a:latin typeface="Calibri" pitchFamily="34" charset="0"/>
-                <a:ea typeface="Calibri" pitchFamily="34" charset="-122"/>
-                <a:cs typeface="Calibri" pitchFamily="34" charset="-120"/>
-              </a:rPr>
-              <a:t>• 4 個指標 — 部署頻率、Lead Time、失敗率、MTTR</a:t>
+                  <a:srgbClr val="8A8078"/>
+                </a:solidFill>
+                <a:latin typeface="Calibri" pitchFamily="34" charset="0"/>
+                <a:ea typeface="Calibri" pitchFamily="34" charset="-122"/>
+                <a:cs typeface="Calibri" pitchFamily="34" charset="-120"/>
+              </a:rPr>
+              <a:t>• 4 metrics — Deploy Frequency, Lead Time, Failure Rate, MTTR</a:t>
             </a:r>
             <a:endParaRPr lang="en-US" sz="900" dirty="0"/>
           </a:p>
@@ -12851,13 +12851,13 @@
             <a:r>
               <a:rPr lang="en-US" sz="900" dirty="0">
                 <a:solidFill>
-                  <a:srgbClr val="8B949E"/>
-                </a:solidFill>
-                <a:latin typeface="Calibri" pitchFamily="34" charset="0"/>
-                <a:ea typeface="Calibri" pitchFamily="34" charset="-122"/>
-                <a:cs typeface="Calibri" pitchFamily="34" charset="-120"/>
-              </a:rPr>
-              <a:t>• Elite 表現者不是天生的 — 是 DevOps 文化建立的</a:t>
+                  <a:srgbClr val="8A8078"/>
+                </a:solidFill>
+                <a:latin typeface="Calibri" pitchFamily="34" charset="0"/>
+                <a:ea typeface="Calibri" pitchFamily="34" charset="-122"/>
+                <a:cs typeface="Calibri" pitchFamily="34" charset="-120"/>
+              </a:rPr>
+              <a:t>• Elite performers are not born — they are built by DevOps culture</a:t>
             </a:r>
             <a:endParaRPr lang="en-US" sz="900" dirty="0"/>
           </a:p>
@@ -12890,13 +12890,13 @@
             <a:r>
               <a:rPr lang="en-US" sz="1200" dirty="0">
                 <a:solidFill>
-                  <a:srgbClr val="F85149"/>
-                </a:solidFill>
-                <a:latin typeface="Calibri" pitchFamily="34" charset="0"/>
-                <a:ea typeface="Calibri" pitchFamily="34" charset="-122"/>
-                <a:cs typeface="Calibri" pitchFamily="34" charset="-120"/>
-              </a:rPr>
-              <a:t>量化成果</a:t>
+                  <a:srgbClr val="C4605B"/>
+                </a:solidFill>
+                <a:latin typeface="Calibri" pitchFamily="34" charset="0"/>
+                <a:ea typeface="Calibri" pitchFamily="34" charset="-122"/>
+                <a:cs typeface="Calibri" pitchFamily="34" charset="-120"/>
+              </a:rPr>
+              <a:t>Measurable Outcomes</a:t>
             </a:r>
             <a:endParaRPr lang="en-US" sz="1200" dirty="0"/>
           </a:p>
@@ -12919,18 +12919,18 @@
             </a:avLst>
           </a:prstGeom>
           <a:solidFill>
-            <a:srgbClr val="161B22"/>
+            <a:srgbClr val="F5F1EB"/>
           </a:solidFill>
           <a:ln w="15240">
             <a:solidFill>
-              <a:srgbClr val="0D8A6C"/>
+              <a:srgbClr val="4A9B8E"/>
             </a:solidFill>
             <a:prstDash val="solid"/>
           </a:ln>
           <a:effectLst>
             <a:outerShdw sx="100000" sy="100000" kx="0" ky="0" algn="bl" rotWithShape="0" blurRad="76200" dist="25400" dir="2700000">
-              <a:srgbClr val="000000">
-                <a:alpha val="30000"/>
+              <a:srgbClr val="9E9488">
+                <a:alpha val="15000"/>
               </a:srgbClr>
             </a:outerShdw>
           </a:effectLst>
@@ -12999,13 +12999,13 @@
             <a:r>
               <a:rPr lang="en-US" sz="1100" b="1" dirty="0">
                 <a:solidFill>
-                  <a:srgbClr val="0D8A6C"/>
-                </a:solidFill>
-                <a:latin typeface="Calibri" pitchFamily="34" charset="0"/>
-                <a:ea typeface="Calibri" pitchFamily="34" charset="-122"/>
-                <a:cs typeface="Calibri" pitchFamily="34" charset="-120"/>
-              </a:rPr>
-              <a:t>Container + GitOps + CI/CD = 現代部署三劍客</a:t>
+                  <a:srgbClr val="4A9B8E"/>
+                </a:solidFill>
+                <a:latin typeface="Calibri" pitchFamily="34" charset="0"/>
+                <a:ea typeface="Calibri" pitchFamily="34" charset="-122"/>
+                <a:cs typeface="Calibri" pitchFamily="34" charset="-120"/>
+              </a:rPr>
+              <a:t>Container + GitOps + CI/CD = The Modern Deployment Trio</a:t>
             </a:r>
             <a:endParaRPr lang="en-US" sz="1100" dirty="0"/>
           </a:p>
@@ -13038,13 +13038,13 @@
             <a:r>
               <a:rPr lang="en-US" sz="900" dirty="0">
                 <a:solidFill>
-                  <a:srgbClr val="8B949E"/>
-                </a:solidFill>
-                <a:latin typeface="Calibri" pitchFamily="34" charset="0"/>
-                <a:ea typeface="Calibri" pitchFamily="34" charset="-122"/>
-                <a:cs typeface="Calibri" pitchFamily="34" charset="-120"/>
-              </a:rPr>
-              <a:t>• Container：環境一致</a:t>
+                  <a:srgbClr val="8A8078"/>
+                </a:solidFill>
+                <a:latin typeface="Calibri" pitchFamily="34" charset="0"/>
+                <a:ea typeface="Calibri" pitchFamily="34" charset="-122"/>
+                <a:cs typeface="Calibri" pitchFamily="34" charset="-120"/>
+              </a:rPr>
+              <a:t>• Container: Consistent environments</a:t>
             </a:r>
             <a:endParaRPr lang="en-US" sz="900" dirty="0"/>
           </a:p>
@@ -13077,13 +13077,13 @@
             <a:r>
               <a:rPr lang="en-US" sz="900" dirty="0">
                 <a:solidFill>
-                  <a:srgbClr val="8B949E"/>
-                </a:solidFill>
-                <a:latin typeface="Calibri" pitchFamily="34" charset="0"/>
-                <a:ea typeface="Calibri" pitchFamily="34" charset="-122"/>
-                <a:cs typeface="Calibri" pitchFamily="34" charset="-120"/>
-              </a:rPr>
-              <a:t>• GitOps：基礎設施即代碼</a:t>
+                  <a:srgbClr val="8A8078"/>
+                </a:solidFill>
+                <a:latin typeface="Calibri" pitchFamily="34" charset="0"/>
+                <a:ea typeface="Calibri" pitchFamily="34" charset="-122"/>
+                <a:cs typeface="Calibri" pitchFamily="34" charset="-120"/>
+              </a:rPr>
+              <a:t>• GitOps: Infrastructure as Code</a:t>
             </a:r>
             <a:endParaRPr lang="en-US" sz="900" dirty="0"/>
           </a:p>
@@ -13116,13 +13116,13 @@
             <a:r>
               <a:rPr lang="en-US" sz="900" dirty="0">
                 <a:solidFill>
-                  <a:srgbClr val="8B949E"/>
-                </a:solidFill>
-                <a:latin typeface="Calibri" pitchFamily="34" charset="0"/>
-                <a:ea typeface="Calibri" pitchFamily="34" charset="-122"/>
-                <a:cs typeface="Calibri" pitchFamily="34" charset="-120"/>
-              </a:rPr>
-              <a:t>• CI/CD：自動化交付 → Part 6: 可觀測性與 SRE</a:t>
+                  <a:srgbClr val="8A8078"/>
+                </a:solidFill>
+                <a:latin typeface="Calibri" pitchFamily="34" charset="0"/>
+                <a:ea typeface="Calibri" pitchFamily="34" charset="-122"/>
+                <a:cs typeface="Calibri" pitchFamily="34" charset="-120"/>
+              </a:rPr>
+              <a:t>• CI/CD: Automated delivery → Part 6: Observability &amp; SRE</a:t>
             </a:r>
             <a:endParaRPr lang="en-US" sz="900" dirty="0"/>
           </a:p>
@@ -13155,13 +13155,13 @@
             <a:r>
               <a:rPr lang="en-US" sz="1200" dirty="0">
                 <a:solidFill>
-                  <a:srgbClr val="F85149"/>
-                </a:solidFill>
-                <a:latin typeface="Calibri" pitchFamily="34" charset="0"/>
-                <a:ea typeface="Calibri" pitchFamily="34" charset="-122"/>
-                <a:cs typeface="Calibri" pitchFamily="34" charset="-120"/>
-              </a:rPr>
-              <a:t>整合視角</a:t>
+                  <a:srgbClr val="C4605B"/>
+                </a:solidFill>
+                <a:latin typeface="Calibri" pitchFamily="34" charset="0"/>
+                <a:ea typeface="Calibri" pitchFamily="34" charset="-122"/>
+                <a:cs typeface="Calibri" pitchFamily="34" charset="-120"/>
+              </a:rPr>
+              <a:t>Integrated View</a:t>
             </a:r>
             <a:endParaRPr lang="en-US" sz="1200" dirty="0"/>
           </a:p>

</xml_diff>